<commit_message>
docs: refine single-objective experiment comparisons
</commit_message>
<xml_diff>
--- a/Meeting/20261001_self_play/20261001_verified.pptx
+++ b/Meeting/20261001_self_play/20261001_verified.pptx
@@ -493,7 +493,7 @@
           </a:p>
           <a:p xmlns:a="http://schemas.openxmlformats.org/drawingml/2006/main">
             <a:r>
-              <a:t>Notion 0925 / 0927 pages；configs/experiments/0929/README.md.</a:t>
+              <a:t>Notion 0927 page；configs/experiments/0929/README.md.</a:t>
             </a:r>
           </a:p>
         </p:txBody>
@@ -568,7 +568,7 @@
           </a:p>
           <a:p xmlns:a="http://schemas.openxmlformats.org/drawingml/2006/main">
             <a:r>
-              <a:t>Meeting/20261001/analysis_md/20260923_self_play_20x10.md；Notion 0927 Self-play 10×20 page.</a:t>
+              <a:t>Meeting/20261001/analysis_md/20260926_self_play_comparison.md；Notion 0927 10×20 page；configs/experiments/0929/fixed_opponent_10x20_control.yaml.</a:t>
             </a:r>
           </a:p>
         </p:txBody>
@@ -718,7 +718,7 @@
           </a:p>
           <a:p xmlns:a="http://schemas.openxmlformats.org/drawingml/2006/main">
             <a:r>
-              <a:t>Notion 0925–0927 pages；Meeting/20261001/analysis_md/20260928_self_play_10x10_vs_5x20.md.</a:t>
+              <a:t>Notion 0926–0927 pages；Meeting/20261001/analysis_md/20260928_self_play_10x10_vs_5x20.md.</a:t>
             </a:r>
           </a:p>
         </p:txBody>
@@ -793,7 +793,7 @@
           </a:p>
           <a:p xmlns:a="http://schemas.openxmlformats.org/drawingml/2006/main">
             <a:r>
-              <a:t>Notion MicroRTS EAGLE runs dated 2026-09-25 to 2026-09-28.</a:t>
+              <a:t>Notion 0926–0927 Self-play runs.</a:t>
             </a:r>
           </a:p>
         </p:txBody>
@@ -1543,7 +1543,7 @@
           </a:p>
           <a:p xmlns:a="http://schemas.openxmlformats.org/drawingml/2006/main">
             <a:r>
-              <a:t>本地 Meeting/20261001/README.md；Notion：0925 5×40、0926 10×10、0926 5×20、0927 10×20 pages.</a:t>
+              <a:t>本地 Meeting/20261001/README.md；Notion 0926 10×10、0926 5×20、0927 10×20 pages.</a:t>
             </a:r>
           </a:p>
         </p:txBody>
@@ -5180,40 +5180,34 @@
           </ns0:spPr>
           <ns0:cat>
             <ns0:strRef>
-              <ns0:f>'Chart Data'!$A$2:$A$5</ns0:f>
+              <ns0:f>'Chart Data'!$A$2:$A$4</ns0:f>
               <ns0:strCache>
-                <ns0:ptCount val="4"/>
+                <ns0:ptCount val="3"/>
                 <ns0:pt idx="0">
-                  <ns0:v>0925 5×40 legacy</ns0:v>
+                  <ns0:v>0926 10×10</ns0:v>
                 </ns0:pt>
                 <ns0:pt idx="1">
-                  <ns0:v>0926 10×10 sem.</ns0:v>
+                  <ns0:v>0926 5×20</ns0:v>
                 </ns0:pt>
                 <ns0:pt idx="2">
-                  <ns0:v>0926 5×20 sem.</ns0:v>
-                </ns0:pt>
-                <ns0:pt idx="3">
-                  <ns0:v>0927 10×20 sem.</ns0:v>
+                  <ns0:v>0927 10×20</ns0:v>
                 </ns0:pt>
               </ns0:strCache>
             </ns0:strRef>
           </ns0:cat>
           <ns0:val>
             <ns0:numRef>
-              <ns0:f>'Chart Data'!$B$2:$B$5</ns0:f>
+              <ns0:f>'Chart Data'!$B$2:$B$4</ns0:f>
               <ns0:numCache>
                 <ns0:formatCode>General</ns0:formatCode>
-                <ns0:ptCount val="4"/>
+                <ns0:ptCount val="3"/>
                 <ns0:pt idx="0">
-                  <ns0:v>197</ns0:v>
+                  <ns0:v>257</ns0:v>
                 </ns0:pt>
                 <ns0:pt idx="1">
-                  <ns0:v>257</ns0:v>
+                  <ns0:v>0</ns0:v>
                 </ns0:pt>
                 <ns0:pt idx="2">
-                  <ns0:v>0</ns0:v>
-                </ns0:pt>
-                <ns0:pt idx="3">
                   <ns0:v>0</ns0:v>
                 </ns0:pt>
               </ns0:numCache>
@@ -5233,40 +5227,34 @@
           </ns0:spPr>
           <ns0:cat>
             <ns0:strRef>
-              <ns0:f>'Chart Data'!$C$2:$C$5</ns0:f>
+              <ns0:f>'Chart Data'!$C$2:$C$4</ns0:f>
               <ns0:strCache>
-                <ns0:ptCount val="4"/>
+                <ns0:ptCount val="3"/>
                 <ns0:pt idx="0">
-                  <ns0:v>0925 5×40 legacy</ns0:v>
+                  <ns0:v>0926 10×10</ns0:v>
                 </ns0:pt>
                 <ns0:pt idx="1">
-                  <ns0:v>0926 10×10 sem.</ns0:v>
+                  <ns0:v>0926 5×20</ns0:v>
                 </ns0:pt>
                 <ns0:pt idx="2">
-                  <ns0:v>0926 5×20 sem.</ns0:v>
-                </ns0:pt>
-                <ns0:pt idx="3">
-                  <ns0:v>0927 10×20 sem.</ns0:v>
+                  <ns0:v>0927 10×20</ns0:v>
                 </ns0:pt>
               </ns0:strCache>
             </ns0:strRef>
           </ns0:cat>
           <ns0:val>
             <ns0:numRef>
-              <ns0:f>'Chart Data'!$D$2:$D$5</ns0:f>
+              <ns0:f>'Chart Data'!$D$2:$D$4</ns0:f>
               <ns0:numCache>
                 <ns0:formatCode>General</ns0:formatCode>
-                <ns0:ptCount val="4"/>
+                <ns0:ptCount val="3"/>
                 <ns0:pt idx="0">
-                  <ns0:v>11</ns0:v>
+                  <ns0:v>22</ns0:v>
                 </ns0:pt>
                 <ns0:pt idx="1">
-                  <ns0:v>22</ns0:v>
+                  <ns0:v>212</ns0:v>
                 </ns0:pt>
                 <ns0:pt idx="2">
-                  <ns0:v>212</ns0:v>
-                </ns0:pt>
-                <ns0:pt idx="3">
                   <ns0:v>156</ns0:v>
                 </ns0:pt>
               </ns0:numCache>
@@ -5286,40 +5274,34 @@
           </ns0:spPr>
           <ns0:cat>
             <ns0:strRef>
-              <ns0:f>'Chart Data'!$E$2:$E$5</ns0:f>
+              <ns0:f>'Chart Data'!$E$2:$E$4</ns0:f>
               <ns0:strCache>
-                <ns0:ptCount val="4"/>
+                <ns0:ptCount val="3"/>
                 <ns0:pt idx="0">
-                  <ns0:v>0925 5×40 legacy</ns0:v>
+                  <ns0:v>0926 10×10</ns0:v>
                 </ns0:pt>
                 <ns0:pt idx="1">
-                  <ns0:v>0926 10×10 sem.</ns0:v>
+                  <ns0:v>0926 5×20</ns0:v>
                 </ns0:pt>
                 <ns0:pt idx="2">
-                  <ns0:v>0926 5×20 sem.</ns0:v>
-                </ns0:pt>
-                <ns0:pt idx="3">
-                  <ns0:v>0927 10×20 sem.</ns0:v>
+                  <ns0:v>0927 10×20</ns0:v>
                 </ns0:pt>
               </ns0:strCache>
             </ns0:strRef>
           </ns0:cat>
           <ns0:val>
             <ns0:numRef>
-              <ns0:f>'Chart Data'!$F$2:$F$5</ns0:f>
+              <ns0:f>'Chart Data'!$F$2:$F$4</ns0:f>
               <ns0:numCache>
                 <ns0:formatCode>General</ns0:formatCode>
-                <ns0:ptCount val="4"/>
+                <ns0:ptCount val="3"/>
                 <ns0:pt idx="0">
-                  <ns0:v>392</ns0:v>
+                  <ns0:v>321</ns0:v>
                 </ns0:pt>
                 <ns0:pt idx="1">
-                  <ns0:v>321</ns0:v>
+                  <ns0:v>388</ns0:v>
                 </ns0:pt>
                 <ns0:pt idx="2">
-                  <ns0:v>388</ns0:v>
-                </ns0:pt>
-                <ns0:pt idx="3">
                   <ns0:v>444</ns0:v>
                 </ns0:pt>
               </ns0:numCache>
@@ -5483,7 +5465,7 @@
           <p:cNvPr id="8" name="EAGLE_0">
             <a:extLst>
               <a:ext uri="{FF2B5EF4-FFF2-40B4-BE49-F238E27FC236}">
-                <ns2:creationId id="{5C91CF13-7C0B-4AB0-BFF4-799E08044C0E}"/>
+                <ns2:creationId id="{34D8F21E-7DEE-4CC4-A1C9-9C36DE450BCC}"/>
               </a:ext>
             </a:extLst>
           </p:cNvPr>
@@ -5536,7 +5518,7 @@
           <p:cNvPr id="9" name="EAGLE_1">
             <a:extLst>
               <a:ext uri="{FF2B5EF4-FFF2-40B4-BE49-F238E27FC236}">
-                <ns2:creationId id="{C540BB75-679C-4982-9801-6E1574222DF7}"/>
+                <ns2:creationId id="{18ADD2BF-42E8-48E0-8A2B-6E3E641F8017}"/>
               </a:ext>
             </a:extLst>
           </p:cNvPr>
@@ -5589,7 +5571,7 @@
           <p:cNvPr id="5" name="">
             <a:extLst>
               <a:ext uri="{FF2B5EF4-FFF2-40B4-BE49-F238E27FC236}">
-                <ns2:creationId id="{B4048967-3050-40FC-B9B2-E5BBF3261542}"/>
+                <ns2:creationId id="{2EA86DFC-4192-482A-A4DF-AC35F70A39E6}"/>
               </a:ext>
             </a:extLst>
           </p:cNvPr>
@@ -5646,7 +5628,7 @@
           <p:cNvPr id="6" name="">
             <a:extLst>
               <a:ext uri="{FF2B5EF4-FFF2-40B4-BE49-F238E27FC236}">
-                <ns2:creationId id="{82BA1826-7BFC-4F29-A9CA-0EC639D77277}"/>
+                <ns2:creationId id="{3622F85A-A04F-45E8-9FE3-705EE34132F5}"/>
               </a:ext>
             </a:extLst>
           </p:cNvPr>
@@ -5703,7 +5685,7 @@
           <p:cNvPr id="7" name="">
             <a:extLst>
               <a:ext uri="{FF2B5EF4-FFF2-40B4-BE49-F238E27FC236}">
-                <ns2:creationId id="{46C1983C-1F23-468A-A52C-34BF254FAB56}"/>
+                <ns2:creationId id="{2FD87997-025A-4177-914A-8D6772CA69FD}"/>
               </a:ext>
             </a:extLst>
           </p:cNvPr>
@@ -5750,7 +5732,7 @@
                 <a:ea typeface="Source Han Serif TW"/>
                 <a:cs typeface="Source Han Serif TW"/>
               </a:rPr>
-              <a:t>涵蓋 09/07–09/29 分析文件與 Notion 0924 後 4 次 self-play runs</a:t>
+              <a:t>涵蓋 09/07–09/29 分析文件與 Notion 0924 後 3 次單一 game_performance 目標 self-play runs</a:t>
             </a:r>
           </a:p>
         </p:txBody>
@@ -5795,7 +5777,7 @@
                 <a:cs typeface="Source Han Serif TW"/>
               </a:defRPr>
             </a:pPr>
-            <a:fld id="{6B25A5C0-B0E7-4557-A034-8F8EB00C6373}" type="slidenum">
+            <a:fld id="{1C0A1BA7-4D10-45CE-9C06-6F7FCE73D45F}" type="slidenum">
               <a:rPr sz="1650" b="0">
                 <a:solidFill>
                   <a:srgbClr val="CF8792"/>
@@ -5812,7 +5794,7 @@
     </p:spTree>
     <p:extLst>
       <p:ext uri="{BB962C8B-B14F-4D97-AF65-F5344CB8AC3E}">
-        <ns3:creationId val="447218493"/>
+        <ns3:creationId val="674567947"/>
       </p:ext>
     </p:extLst>
   </p:cSld>
@@ -5836,7 +5818,7 @@
           <p:cNvPr id="12" name="EAGLE_0">
             <a:extLst>
               <a:ext uri="{FF2B5EF4-FFF2-40B4-BE49-F238E27FC236}">
-                <ns2:creationId id="{07827917-F322-4A57-A1D5-A6276B3FB2DA}"/>
+                <ns2:creationId id="{519073ED-8774-455E-9BBF-550B221127A3}"/>
               </a:ext>
             </a:extLst>
           </p:cNvPr>
@@ -5889,7 +5871,7 @@
           <p:cNvPr id="13" name="EAGLE_1">
             <a:extLst>
               <a:ext uri="{FF2B5EF4-FFF2-40B4-BE49-F238E27FC236}">
-                <ns2:creationId id="{9D6671F7-79D7-4315-B432-C737BD9E8CB9}"/>
+                <ns2:creationId id="{9A1D5260-5118-4D9B-98A3-39319C1EB0BC}"/>
               </a:ext>
             </a:extLst>
           </p:cNvPr>
@@ -6607,7 +6589,7 @@
           <p:cNvPr id="6" name="">
             <a:extLst>
               <a:ext uri="{FF2B5EF4-FFF2-40B4-BE49-F238E27FC236}">
-                <ns2:creationId id="{76932022-CD52-474D-AB0A-7E61F1FC100D}"/>
+                <ns2:creationId id="{5C52E5DB-A11C-4A1E-B8E9-F9080FB66C7F}"/>
               </a:ext>
             </a:extLst>
           </p:cNvPr>
@@ -6699,7 +6681,7 @@
                 <a:cs typeface="Source Han Serif TW"/>
               </a:defRPr>
             </a:pPr>
-            <a:fld id="{CC9D21B6-CAA3-4ED5-8EBB-EECD28F54F36}" type="slidenum">
+            <a:fld id="{1A5CA672-F834-4E25-86A4-55DCF532C4E8}" type="slidenum">
               <a:rPr sz="1650" b="0">
                 <a:solidFill>
                   <a:srgbClr val="CF8792"/>
@@ -6716,7 +6698,7 @@
     </p:spTree>
     <p:extLst>
       <p:ext uri="{BB962C8B-B14F-4D97-AF65-F5344CB8AC3E}">
-        <ns3:creationId val="1824250790"/>
+        <ns3:creationId val="578927247"/>
       </p:ext>
     </p:extLst>
   </p:cSld>
@@ -6740,7 +6722,7 @@
           <p:cNvPr id="13" name="EAGLE_0">
             <a:extLst>
               <a:ext uri="{FF2B5EF4-FFF2-40B4-BE49-F238E27FC236}">
-                <ns2:creationId id="{F2A0D5AB-7549-4CD7-9E26-5EAFE049AA98}"/>
+                <ns2:creationId id="{A85D74C7-82D0-4E0F-A596-1442A3CFDEC6}"/>
               </a:ext>
             </a:extLst>
           </p:cNvPr>
@@ -6764,7 +6746,7 @@
           <a:lstStyle/>
           <a:p>
             <a:pPr algn="ctr">
-              <a:defRPr sz="3775" b="1">
+              <a:defRPr sz="4480" b="1">
                 <a:solidFill>
                   <a:srgbClr val="47171C"/>
                 </a:solidFill>
@@ -6775,7 +6757,7 @@
               <a:buNone/>
             </a:pPr>
             <a:r>
-              <a:rPr sz="3775" b="1">
+              <a:rPr sz="4480" b="1">
                 <a:solidFill>
                   <a:srgbClr val="47171C"/>
                 </a:solidFill>
@@ -6783,7 +6765,7 @@
                 <a:ea typeface="Source Han Serif TW"/>
                 <a:cs typeface="Source Han Serif TW"/>
               </a:rPr>
-              <a:t>200 FFE：缺少 5×40 semantic-tie-break run</a:t>
+              <a:t>200 FFE：5×40 semantic run 尚未執行</a:t>
             </a:r>
           </a:p>
         </p:txBody>
@@ -6793,7 +6775,7 @@
           <p:cNvPr id="14" name="EAGLE_1">
             <a:extLst>
               <a:ext uri="{FF2B5EF4-FFF2-40B4-BE49-F238E27FC236}">
-                <ns2:creationId id="{16C0B5BA-0094-4E0A-BA70-95196224B102}"/>
+                <ns2:creationId id="{32A7D7E7-9EDD-47FC-AEDD-F70BB5FDF81F}"/>
               </a:ext>
             </a:extLst>
           </p:cNvPr>
@@ -6836,7 +6818,7 @@
                 <a:ea typeface="Source Han Serif TW"/>
                 <a:cs typeface="Source Han Serif TW"/>
               </a:rPr>
-              <a:t>這組缺漏讓 10×20 vs 5×40 的配置比較暫時不成立</a:t>
+              <a:t>0929 config 補齊單一目標 self-play allocation arm；semantic tie-break 僅為近似同分判定</a:t>
             </a:r>
           </a:p>
         </p:txBody>
@@ -6849,7 +6831,7 @@
         </p:nvGraphicFramePr>
         <p:xfrm>
           <a:off x="1428750" y="2491383"/>
-          <a:ext cx="13068300" cy="3193852"/>
+          <a:ext cx="13068300" cy="3138785"/>
         </p:xfrm>
         <a:graphic>
           <a:graphicData uri="http://schemas.openxmlformats.org/drawingml/2006/table">
@@ -6858,12 +6840,12 @@
                 <a:tableStyleId>{8497E131-5584-4FF0-9A17-202609170001}</a:tableStyleId>
               </a:tblPr>
               <a:tblGrid>
-                <a:gridCol w="3548719"/>
-                <a:gridCol w="2309484"/>
+                <a:gridCol w="3379733"/>
                 <a:gridCol w="3717706"/>
-                <a:gridCol w="3492391"/>
+                <a:gridCol w="3717706"/>
+                <a:gridCol w="2253155"/>
               </a:tblGrid>
-              <a:tr h="798463">
+              <a:tr h="1046262">
                 <a:tc>
                   <a:txBody>
                     <a:bodyPr>
@@ -6880,6 +6862,32 @@
                           <a:ea typeface="Source Han Serif TW"/>
                           <a:cs typeface="Source Han Serif TW"/>
                         </a:rPr>
+                        <a:t>比較問題</a:t>
+                      </a:r>
+                    </a:p>
+                  </a:txBody>
+                  <a:tcPr marL="76200" marR="76200" marT="28575" marB="28575">
+                    <a:solidFill>
+                      <a:srgbClr val="DEB4BA"/>
+                    </a:solidFill>
+                  </a:tcPr>
+                </a:tc>
+                <a:tc>
+                  <a:txBody>
+                    <a:bodyPr>
+                      <a:noAutofit/>
+                    </a:bodyPr>
+                    <a:lstStyle/>
+                    <a:p>
+                      <a:r>
+                        <a:rPr sz="1725" b="1">
+                          <a:solidFill>
+                            <a:srgbClr val="423C3B"/>
+                          </a:solidFill>
+                          <a:latin typeface="Source Han Serif TW"/>
+                          <a:ea typeface="Source Han Serif TW"/>
+                          <a:cs typeface="Source Han Serif TW"/>
+                        </a:rPr>
                         <a:t>已有實驗</a:t>
                       </a:r>
                     </a:p>
@@ -6906,7 +6914,7 @@
                           <a:ea typeface="Source Han Serif TW"/>
                           <a:cs typeface="Source Han Serif TW"/>
                         </a:rPr>
-                        <a:t>配置</a:t>
+                        <a:t>0929 補缺</a:t>
                       </a:r>
                     </a:p>
                   </a:txBody>
@@ -6932,7 +6940,7 @@
                           <a:ea typeface="Source Han Serif TW"/>
                           <a:cs typeface="Source Han Serif TW"/>
                         </a:rPr>
-                        <a:t>協定</a:t>
+                        <a:t>目前狀態</a:t>
                       </a:r>
                     </a:p>
                   </a:txBody>
@@ -6942,34 +6950,8 @@
                     </a:solidFill>
                   </a:tcPr>
                 </a:tc>
-                <a:tc>
-                  <a:txBody>
-                    <a:bodyPr>
-                      <a:noAutofit/>
-                    </a:bodyPr>
-                    <a:lstStyle/>
-                    <a:p>
-                      <a:r>
-                        <a:rPr sz="1725" b="1">
-                          <a:solidFill>
-                            <a:srgbClr val="423C3B"/>
-                          </a:solidFill>
-                          <a:latin typeface="Source Han Serif TW"/>
-                          <a:ea typeface="Source Han Serif TW"/>
-                          <a:cs typeface="Source Han Serif TW"/>
-                        </a:rPr>
-                        <a:t>W/L/D/E</a:t>
-                      </a:r>
-                    </a:p>
-                  </a:txBody>
-                  <a:tcPr marL="76200" marR="76200" marT="28575" marB="28575">
-                    <a:solidFill>
-                      <a:srgbClr val="DEB4BA"/>
-                    </a:solidFill>
-                  </a:tcPr>
-                </a:tc>
               </a:tr>
-              <a:tr h="798463">
+              <a:tr h="1046262">
                 <a:tc>
                   <a:txBody>
                     <a:bodyPr>
@@ -6986,7 +6968,7 @@
                           <a:ea typeface="Source Han Serif TW"/>
                           <a:cs typeface="Source Han Serif TW"/>
                         </a:rPr>
-                        <a:t>0927 run 20260928_115653_334420</a:t>
+                        <a:t>allocation：10×20 vs 5×40</a:t>
                       </a:r>
                     </a:p>
                   </a:txBody>
@@ -7012,7 +6994,7 @@
                           <a:ea typeface="Source Han Serif TW"/>
                           <a:cs typeface="Source Han Serif TW"/>
                         </a:rPr>
-                        <a:t>10×20, 200 FFE</a:t>
+                        <a:t>0927 semantic 10×20</a:t>
                       </a:r>
                     </a:p>
                   </a:txBody>
@@ -7038,7 +7020,7 @@
                           <a:ea typeface="Source Han Serif TW"/>
                           <a:cs typeface="Source Han Serif TW"/>
                         </a:rPr>
-                        <a:t>semantic tie-break</a:t>
+                        <a:t>single-GP semantic 5×40</a:t>
                       </a:r>
                     </a:p>
                   </a:txBody>
@@ -7064,7 +7046,7 @@
                           <a:ea typeface="Source Han Serif TW"/>
                           <a:cs typeface="Source Han Serif TW"/>
                         </a:rPr>
-                        <a:t>0 / 444 / 156 / 0</a:t>
+                        <a:t>5×40 尚無結果</a:t>
                       </a:r>
                     </a:p>
                   </a:txBody>
@@ -7075,7 +7057,7 @@
                   </a:tcPr>
                 </a:tc>
               </a:tr>
-              <a:tr h="798463">
+              <a:tr h="1046262">
                 <a:tc>
                   <a:txBody>
                     <a:bodyPr>
@@ -7092,7 +7074,7 @@
                           <a:ea typeface="Source Han Serif TW"/>
                           <a:cs typeface="Source Han Serif TW"/>
                         </a:rPr>
-                        <a:t>0925 run 20260925_134245_911171</a:t>
+                        <a:t>evaluation context：10×20</a:t>
                       </a:r>
                     </a:p>
                   </a:txBody>
@@ -7118,7 +7100,7 @@
                           <a:ea typeface="Source Han Serif TW"/>
                           <a:cs typeface="Source Han Serif TW"/>
                         </a:rPr>
-                        <a:t>5×40, 200 FFE</a:t>
+                        <a:t>0927 single-GP self-play</a:t>
                       </a:r>
                     </a:p>
                   </a:txBody>
@@ -7144,7 +7126,7 @@
                           <a:ea typeface="Source Han Serif TW"/>
                           <a:cs typeface="Source Han Serif TW"/>
                         </a:rPr>
-                        <a:t>legacy lexicase</a:t>
+                        <a:t>fixed-opponent control</a:t>
                       </a:r>
                     </a:p>
                   </a:txBody>
@@ -7170,113 +7152,7 @@
                           <a:ea typeface="Source Han Serif TW"/>
                           <a:cs typeface="Source Han Serif TW"/>
                         </a:rPr>
-                        <a:t>197 / 392 / 11 / 0</a:t>
-                      </a:r>
-                    </a:p>
-                  </a:txBody>
-                  <a:tcPr marL="76200" marR="76200" marT="28575" marB="28575">
-                    <a:solidFill>
-                      <a:srgbClr val="FCF8F5"/>
-                    </a:solidFill>
-                  </a:tcPr>
-                </a:tc>
-              </a:tr>
-              <a:tr h="798463">
-                <a:tc>
-                  <a:txBody>
-                    <a:bodyPr>
-                      <a:noAutofit/>
-                    </a:bodyPr>
-                    <a:lstStyle/>
-                    <a:p>
-                      <a:r>
-                        <a:rPr sz="1725" b="0">
-                          <a:solidFill>
-                            <a:srgbClr val="423C3B"/>
-                          </a:solidFill>
-                          <a:latin typeface="Source Han Serif TW"/>
-                          <a:ea typeface="Source Han Serif TW"/>
-                          <a:cs typeface="Source Han Serif TW"/>
-                        </a:rPr>
-                        <a:t>0929 待跑 config</a:t>
-                      </a:r>
-                    </a:p>
-                  </a:txBody>
-                  <a:tcPr marL="76200" marR="76200" marT="28575" marB="28575">
-                    <a:solidFill>
-                      <a:srgbClr val="FCF8F5"/>
-                    </a:solidFill>
-                  </a:tcPr>
-                </a:tc>
-                <a:tc>
-                  <a:txBody>
-                    <a:bodyPr>
-                      <a:noAutofit/>
-                    </a:bodyPr>
-                    <a:lstStyle/>
-                    <a:p>
-                      <a:r>
-                        <a:rPr sz="1725" b="0">
-                          <a:solidFill>
-                            <a:srgbClr val="423C3B"/>
-                          </a:solidFill>
-                          <a:latin typeface="Source Han Serif TW"/>
-                          <a:ea typeface="Source Han Serif TW"/>
-                          <a:cs typeface="Source Han Serif TW"/>
-                        </a:rPr>
-                        <a:t>5×40, 200 FFE</a:t>
-                      </a:r>
-                    </a:p>
-                  </a:txBody>
-                  <a:tcPr marL="76200" marR="76200" marT="28575" marB="28575">
-                    <a:solidFill>
-                      <a:srgbClr val="FCF8F5"/>
-                    </a:solidFill>
-                  </a:tcPr>
-                </a:tc>
-                <a:tc>
-                  <a:txBody>
-                    <a:bodyPr>
-                      <a:noAutofit/>
-                    </a:bodyPr>
-                    <a:lstStyle/>
-                    <a:p>
-                      <a:r>
-                        <a:rPr sz="1725" b="0">
-                          <a:solidFill>
-                            <a:srgbClr val="423C3B"/>
-                          </a:solidFill>
-                          <a:latin typeface="Source Han Serif TW"/>
-                          <a:ea typeface="Source Han Serif TW"/>
-                          <a:cs typeface="Source Han Serif TW"/>
-                        </a:rPr>
-                        <a:t>semantic tie-break</a:t>
-                      </a:r>
-                    </a:p>
-                  </a:txBody>
-                  <a:tcPr marL="76200" marR="76200" marT="28575" marB="28575">
-                    <a:solidFill>
-                      <a:srgbClr val="FCF8F5"/>
-                    </a:solidFill>
-                  </a:tcPr>
-                </a:tc>
-                <a:tc>
-                  <a:txBody>
-                    <a:bodyPr>
-                      <a:noAutofit/>
-                    </a:bodyPr>
-                    <a:lstStyle/>
-                    <a:p>
-                      <a:r>
-                        <a:rPr sz="1725" b="0">
-                          <a:solidFill>
-                            <a:srgbClr val="423C3B"/>
-                          </a:solidFill>
-                          <a:latin typeface="Source Han Serif TW"/>
-                          <a:ea typeface="Source Han Serif TW"/>
-                          <a:cs typeface="Source Han Serif TW"/>
-                        </a:rPr>
-                        <a:t>待測</a:t>
+                        <a:t>control config 待跑</a:t>
                       </a:r>
                     </a:p>
                   </a:txBody>
@@ -7296,7 +7172,7 @@
           <p:cNvPr id="6" name="">
             <a:extLst>
               <a:ext uri="{FF2B5EF4-FFF2-40B4-BE49-F238E27FC236}">
-                <ns2:creationId id="{7BB82624-08E6-4C74-B781-E14A7E03F7B9}"/>
+                <ns2:creationId id="{FDC1293C-8E31-40BB-A6FD-A381C5280B49}"/>
               </a:ext>
             </a:extLst>
           </p:cNvPr>
@@ -7307,8 +7183,8 @@
         </p:nvSpPr>
         <p:spPr>
           <a:xfrm>
-            <a:off x="1451282" y="6059686"/>
-            <a:ext cx="12786656" cy="605730"/>
+            <a:off x="1451282" y="6015633"/>
+            <a:ext cx="12786656" cy="638770"/>
           </a:xfrm>
           <a:prstGeom prst="rect">
             <a:avLst/>
@@ -7325,7 +7201,7 @@
           <a:lstStyle/>
           <a:p>
             <a:pPr>
-              <a:defRPr sz="1811" b="0">
+              <a:defRPr sz="1725" b="0">
                 <a:solidFill>
                   <a:srgbClr val="423C3B"/>
                 </a:solidFill>
@@ -7335,7 +7211,7 @@
               </a:defRPr>
             </a:pPr>
             <a:r>
-              <a:rPr sz="1811" b="0">
+              <a:rPr sz="1725" b="0">
                 <a:solidFill>
                   <a:srgbClr val="423C3B"/>
                 </a:solidFill>
@@ -7343,7 +7219,7 @@
                 <a:ea typeface="Source Han Serif TW"/>
                 <a:cs typeface="Source Han Serif TW"/>
               </a:rPr>
-              <a:t>0925 legacy 5×40 和 0927 semantic 10×20 不能當作只改人口／世代的對照，selection protocol 不同。</a:t>
+              <a:t>0925 legacy lexicase 也是 self-play（10 個 snapshot opponents），排除於單一目標主表。兩個 0929 config 分別補 5×40 單一目標 allocation 與 10×20 固定對手 evaluation control。</a:t>
             </a:r>
           </a:p>
         </p:txBody>
@@ -7353,7 +7229,7 @@
           <p:cNvPr id="7" name="">
             <a:extLst>
               <a:ext uri="{FF2B5EF4-FFF2-40B4-BE49-F238E27FC236}">
-                <ns2:creationId id="{AB82FC17-731A-4BBD-943F-A9C33E38074C}"/>
+                <ns2:creationId id="{288421A1-EC04-48F5-879A-045E8078AA89}"/>
               </a:ext>
             </a:extLst>
           </p:cNvPr>
@@ -7400,7 +7276,7 @@
                 <a:ea typeface="Source Han Serif TW"/>
                 <a:cs typeface="Source Han Serif TW"/>
               </a:rPr>
-              <a:t>新增的 5×40 semantic config 同時補齊 FFE allocation 與 selection-method 配對</a:t>
+              <a:t>兩個缺漏 arm 都已放入 0929 config 資料夾</a:t>
             </a:r>
           </a:p>
         </p:txBody>
@@ -7445,7 +7321,7 @@
                 <a:cs typeface="Source Han Serif TW"/>
               </a:defRPr>
             </a:pPr>
-            <a:fld id="{ED98928C-8459-4CC5-9476-58D193B250FE}" type="slidenum">
+            <a:fld id="{01314670-E42B-4FA3-9E24-6E03AE3FEB97}" type="slidenum">
               <a:rPr sz="1650" b="0">
                 <a:solidFill>
                   <a:srgbClr val="CF8792"/>
@@ -7462,7 +7338,7 @@
     </p:spTree>
     <p:extLst>
       <p:ext uri="{BB962C8B-B14F-4D97-AF65-F5344CB8AC3E}">
-        <ns3:creationId val="1823303198"/>
+        <ns3:creationId val="1734519308"/>
       </p:ext>
     </p:extLst>
   </p:cSld>
@@ -7486,7 +7362,7 @@
           <p:cNvPr id="13" name="EAGLE_0">
             <a:extLst>
               <a:ext uri="{FF2B5EF4-FFF2-40B4-BE49-F238E27FC236}">
-                <ns2:creationId id="{6803AE60-D810-422F-84D0-215C1B3FB491}"/>
+                <ns2:creationId id="{BBC8805B-AA55-4DE2-83AF-DACB4CE332D0}"/>
               </a:ext>
             </a:extLst>
           </p:cNvPr>
@@ -7510,7 +7386,7 @@
           <a:lstStyle/>
           <a:p>
             <a:pPr algn="ctr">
-              <a:defRPr sz="4019" b="1">
+              <a:defRPr sz="3301" b="1">
                 <a:solidFill>
                   <a:srgbClr val="47171C"/>
                 </a:solidFill>
@@ -7521,7 +7397,7 @@
               <a:buNone/>
             </a:pPr>
             <a:r>
-              <a:rPr sz="4019" b="1">
+              <a:rPr sz="3301" b="1">
                 <a:solidFill>
                   <a:srgbClr val="47171C"/>
                 </a:solidFill>
@@ -7529,7 +7405,7 @@
                 <a:ea typeface="Source Han Serif TW"/>
                 <a:cs typeface="Source Han Serif TW"/>
               </a:rPr>
-              <a:t>同為 10×20 的兩次 self-play 結果不能合併</a:t>
+              <a:t>固定對手組 vs self-play：10×20 歷史對照與待補控制</a:t>
             </a:r>
           </a:p>
         </p:txBody>
@@ -7539,7 +7415,7 @@
           <p:cNvPr id="14" name="EAGLE_1">
             <a:extLst>
               <a:ext uri="{FF2B5EF4-FFF2-40B4-BE49-F238E27FC236}">
-                <ns2:creationId id="{E3526FC8-4BD1-4684-911C-866CB995AA26}"/>
+                <ns2:creationId id="{AF172545-103A-4CFD-9397-5720C19511A5}"/>
               </a:ext>
             </a:extLst>
           </p:cNvPr>
@@ -7582,7 +7458,7 @@
                 <a:ea typeface="Source Han Serif TW"/>
                 <a:cs typeface="Source Han Serif TW"/>
               </a:rPr>
-              <a:t>舊草稿 0/151/449 是 0923 run，不是 0927 semantic-tie-break run</a:t>
+              <a:t>兩個已完成 run 同為 10×20 / 200 FFE；舊 fixed-roster run 來自較早版本</a:t>
             </a:r>
           </a:p>
         </p:txBody>
@@ -7595,7 +7471,7 @@
         </p:nvGraphicFramePr>
         <p:xfrm>
           <a:off x="1428750" y="2491383"/>
-          <a:ext cx="13068300" cy="2643188"/>
+          <a:ext cx="13068300" cy="2863453"/>
         </p:xfrm>
         <a:graphic>
           <a:graphicData uri="http://schemas.openxmlformats.org/drawingml/2006/table">
@@ -7604,29 +7480,30 @@
                 <a:tableStyleId>{8497E131-5584-4FF0-9A17-202609170001}</a:tableStyleId>
               </a:tblPr>
               <a:tblGrid>
-                <a:gridCol w="3830364"/>
-                <a:gridCol w="3717706"/>
-                <a:gridCol w="3379733"/>
-                <a:gridCol w="2140497"/>
+                <a:gridCol w="2816444"/>
+                <a:gridCol w="2591128"/>
+                <a:gridCol w="4055679"/>
+                <a:gridCol w="901262"/>
+                <a:gridCol w="2703786"/>
               </a:tblGrid>
-              <a:tr h="881062">
-                <a:tc>
-                  <a:txBody>
-                    <a:bodyPr>
-                      <a:noAutofit/>
-                    </a:bodyPr>
-                    <a:lstStyle/>
-                    <a:p>
-                      <a:r>
-                        <a:rPr sz="1725" b="1">
-                          <a:solidFill>
-                            <a:srgbClr val="423C3B"/>
-                          </a:solidFill>
-                          <a:latin typeface="Source Han Serif TW"/>
-                          <a:ea typeface="Source Han Serif TW"/>
-                          <a:cs typeface="Source Han Serif TW"/>
-                        </a:rPr>
-                        <a:t>Run</a:t>
+              <a:tr h="715863">
+                <a:tc>
+                  <a:txBody>
+                    <a:bodyPr>
+                      <a:noAutofit/>
+                    </a:bodyPr>
+                    <a:lstStyle/>
+                    <a:p>
+                      <a:r>
+                        <a:rPr sz="1466" b="1">
+                          <a:solidFill>
+                            <a:srgbClr val="423C3B"/>
+                          </a:solidFill>
+                          <a:latin typeface="Source Han Serif TW"/>
+                          <a:ea typeface="Source Han Serif TW"/>
+                          <a:cs typeface="Source Han Serif TW"/>
+                        </a:rPr>
+                        <a:t>Arm</a:t>
                       </a:r>
                     </a:p>
                   </a:txBody>
@@ -7644,15 +7521,15 @@
                     <a:lstStyle/>
                     <a:p>
                       <a:r>
-                        <a:rPr sz="1725" b="1">
-                          <a:solidFill>
-                            <a:srgbClr val="423C3B"/>
-                          </a:solidFill>
-                          <a:latin typeface="Source Han Serif TW"/>
-                          <a:ea typeface="Source Han Serif TW"/>
-                          <a:cs typeface="Source Han Serif TW"/>
-                        </a:rPr>
-                        <a:t>Search protocol</a:t>
+                        <a:rPr sz="1466" b="1">
+                          <a:solidFill>
+                            <a:srgbClr val="423C3B"/>
+                          </a:solidFill>
+                          <a:latin typeface="Source Han Serif TW"/>
+                          <a:ea typeface="Source Han Serif TW"/>
+                          <a:cs typeface="Source Han Serif TW"/>
+                        </a:rPr>
+                        <a:t>搜尋期 evaluation</a:t>
                       </a:r>
                     </a:p>
                   </a:txBody>
@@ -7670,15 +7547,15 @@
                     <a:lstStyle/>
                     <a:p>
                       <a:r>
-                        <a:rPr sz="1725" b="1">
-                          <a:solidFill>
-                            <a:srgbClr val="423C3B"/>
-                          </a:solidFill>
-                          <a:latin typeface="Source Han Serif TW"/>
-                          <a:ea typeface="Source Han Serif TW"/>
-                          <a:cs typeface="Source Han Serif TW"/>
-                        </a:rPr>
-                        <a:t>Final test W/L/D/E</a:t>
+                        <a:rPr sz="1466" b="1">
+                          <a:solidFill>
+                            <a:srgbClr val="423C3B"/>
+                          </a:solidFill>
+                          <a:latin typeface="Source Han Serif TW"/>
+                          <a:ea typeface="Source Han Serif TW"/>
+                          <a:cs typeface="Source Han Serif TW"/>
+                        </a:rPr>
+                        <a:t>目標口徑</a:t>
                       </a:r>
                     </a:p>
                   </a:txBody>
@@ -7696,15 +7573,15 @@
                     <a:lstStyle/>
                     <a:p>
                       <a:r>
-                        <a:rPr sz="1725" b="1">
-                          <a:solidFill>
-                            <a:srgbClr val="423C3B"/>
-                          </a:solidFill>
-                          <a:latin typeface="Source Han Serif TW"/>
-                          <a:ea typeface="Source Han Serif TW"/>
-                          <a:cs typeface="Source Han Serif TW"/>
-                        </a:rPr>
-                        <a:t>Refresh audit</a:t>
+                        <a:rPr sz="1466" b="1">
+                          <a:solidFill>
+                            <a:srgbClr val="423C3B"/>
+                          </a:solidFill>
+                          <a:latin typeface="Source Han Serif TW"/>
+                          <a:ea typeface="Source Han Serif TW"/>
+                          <a:cs typeface="Source Han Serif TW"/>
+                        </a:rPr>
+                        <a:t>FFE</a:t>
                       </a:r>
                     </a:p>
                   </a:txBody>
@@ -7714,103 +7591,155 @@
                     </a:solidFill>
                   </a:tcPr>
                 </a:tc>
+                <a:tc>
+                  <a:txBody>
+                    <a:bodyPr>
+                      <a:noAutofit/>
+                    </a:bodyPr>
+                    <a:lstStyle/>
+                    <a:p>
+                      <a:r>
+                        <a:rPr sz="1466" b="1">
+                          <a:solidFill>
+                            <a:srgbClr val="423C3B"/>
+                          </a:solidFill>
+                          <a:latin typeface="Source Han Serif TW"/>
+                          <a:ea typeface="Source Han Serif TW"/>
+                          <a:cs typeface="Source Han Serif TW"/>
+                        </a:rPr>
+                        <a:t>固定對手 final test W/L/D/E</a:t>
+                      </a:r>
+                    </a:p>
+                  </a:txBody>
+                  <a:tcPr marL="76200" marR="76200" marT="28575" marB="28575">
+                    <a:solidFill>
+                      <a:srgbClr val="DEB4BA"/>
+                    </a:solidFill>
+                  </a:tcPr>
+                </a:tc>
               </a:tr>
-              <a:tr h="881062">
-                <a:tc>
-                  <a:txBody>
-                    <a:bodyPr>
-                      <a:noAutofit/>
-                    </a:bodyPr>
-                    <a:lstStyle/>
-                    <a:p>
-                      <a:r>
-                        <a:rPr sz="1725" b="0">
-                          <a:solidFill>
-                            <a:srgbClr val="423C3B"/>
-                          </a:solidFill>
-                          <a:latin typeface="Source Han Serif TW"/>
-                          <a:ea typeface="Source Han Serif TW"/>
-                          <a:cs typeface="Source Han Serif TW"/>
-                        </a:rPr>
-                        <a:t>0923 20260923_134743_200030</a:t>
-                      </a:r>
-                    </a:p>
-                  </a:txBody>
-                  <a:tcPr marL="76200" marR="76200" marT="28575" marB="28575">
-                    <a:solidFill>
-                      <a:srgbClr val="FCF8F5"/>
-                    </a:solidFill>
-                  </a:tcPr>
-                </a:tc>
-                <a:tc>
-                  <a:txBody>
-                    <a:bodyPr>
-                      <a:noAutofit/>
-                    </a:bodyPr>
-                    <a:lstStyle/>
-                    <a:p>
-                      <a:r>
-                        <a:rPr sz="1725" b="0">
-                          <a:solidFill>
-                            <a:srgbClr val="423C3B"/>
-                          </a:solidFill>
-                          <a:latin typeface="Source Han Serif TW"/>
-                          <a:ea typeface="Source Han Serif TW"/>
-                          <a:cs typeface="Source Han Serif TW"/>
-                        </a:rPr>
-                        <a:t>較早 self-play protocol</a:t>
-                      </a:r>
-                    </a:p>
-                  </a:txBody>
-                  <a:tcPr marL="76200" marR="76200" marT="28575" marB="28575">
-                    <a:solidFill>
-                      <a:srgbClr val="FCF8F5"/>
-                    </a:solidFill>
-                  </a:tcPr>
-                </a:tc>
-                <a:tc>
-                  <a:txBody>
-                    <a:bodyPr>
-                      <a:noAutofit/>
-                    </a:bodyPr>
-                    <a:lstStyle/>
-                    <a:p>
-                      <a:r>
-                        <a:rPr sz="1725" b="0">
-                          <a:solidFill>
-                            <a:srgbClr val="423C3B"/>
-                          </a:solidFill>
-                          <a:latin typeface="Source Han Serif TW"/>
-                          <a:ea typeface="Source Han Serif TW"/>
-                          <a:cs typeface="Source Han Serif TW"/>
-                        </a:rPr>
-                        <a:t>0 / 449 / 151 / 0</a:t>
-                      </a:r>
-                    </a:p>
-                  </a:txBody>
-                  <a:tcPr marL="76200" marR="76200" marT="28575" marB="28575">
-                    <a:solidFill>
-                      <a:srgbClr val="FCF8F5"/>
-                    </a:solidFill>
-                  </a:tcPr>
-                </a:tc>
-                <a:tc>
-                  <a:txBody>
-                    <a:bodyPr>
-                      <a:noAutofit/>
-                    </a:bodyPr>
-                    <a:lstStyle/>
-                    <a:p>
-                      <a:r>
-                        <a:rPr sz="1725" b="0">
-                          <a:solidFill>
-                            <a:srgbClr val="423C3B"/>
-                          </a:solidFill>
-                          <a:latin typeface="Source Han Serif TW"/>
-                          <a:ea typeface="Source Han Serif TW"/>
-                          <a:cs typeface="Source Han Serif TW"/>
-                        </a:rPr>
-                        <a:t>舊版分析資料</a:t>
+              <a:tr h="715863">
+                <a:tc>
+                  <a:txBody>
+                    <a:bodyPr>
+                      <a:noAutofit/>
+                    </a:bodyPr>
+                    <a:lstStyle/>
+                    <a:p>
+                      <a:r>
+                        <a:rPr sz="1466" b="0">
+                          <a:solidFill>
+                            <a:srgbClr val="423C3B"/>
+                          </a:solidFill>
+                          <a:latin typeface="Source Han Serif TW"/>
+                          <a:ea typeface="Source Han Serif TW"/>
+                          <a:cs typeface="Source Han Serif TW"/>
+                        </a:rPr>
+                        <a:t>09/11 固定對手 baseline</a:t>
+                      </a:r>
+                    </a:p>
+                  </a:txBody>
+                  <a:tcPr marL="76200" marR="76200" marT="28575" marB="28575">
+                    <a:solidFill>
+                      <a:srgbClr val="FCF8F5"/>
+                    </a:solidFill>
+                  </a:tcPr>
+                </a:tc>
+                <a:tc>
+                  <a:txBody>
+                    <a:bodyPr>
+                      <a:noAutofit/>
+                    </a:bodyPr>
+                    <a:lstStyle/>
+                    <a:p>
+                      <a:r>
+                        <a:rPr sz="1466" b="0">
+                          <a:solidFill>
+                            <a:srgbClr val="423C3B"/>
+                          </a:solidFill>
+                          <a:latin typeface="Source Han Serif TW"/>
+                          <a:ea typeface="Source Han Serif TW"/>
+                          <a:cs typeface="Source Han Serif TW"/>
+                        </a:rPr>
+                        <a:t>10 個固定 opponents</a:t>
+                      </a:r>
+                    </a:p>
+                  </a:txBody>
+                  <a:tcPr marL="76200" marR="76200" marT="28575" marB="28575">
+                    <a:solidFill>
+                      <a:srgbClr val="FCF8F5"/>
+                    </a:solidFill>
+                  </a:tcPr>
+                </a:tc>
+                <a:tc>
+                  <a:txBody>
+                    <a:bodyPr>
+                      <a:noAutofit/>
+                    </a:bodyPr>
+                    <a:lstStyle/>
+                    <a:p>
+                      <a:r>
+                        <a:rPr sz="1466" b="0">
+                          <a:solidFill>
+                            <a:srgbClr val="423C3B"/>
+                          </a:solidFill>
+                          <a:latin typeface="Source Han Serif TW"/>
+                          <a:ea typeface="Source Han Serif TW"/>
+                          <a:cs typeface="Source Han Serif TW"/>
+                        </a:rPr>
+                        <a:t>opponent_cases；較早 repository state</a:t>
+                      </a:r>
+                    </a:p>
+                  </a:txBody>
+                  <a:tcPr marL="76200" marR="76200" marT="28575" marB="28575">
+                    <a:solidFill>
+                      <a:srgbClr val="FCF8F5"/>
+                    </a:solidFill>
+                  </a:tcPr>
+                </a:tc>
+                <a:tc>
+                  <a:txBody>
+                    <a:bodyPr>
+                      <a:noAutofit/>
+                    </a:bodyPr>
+                    <a:lstStyle/>
+                    <a:p>
+                      <a:r>
+                        <a:rPr sz="1466" b="0">
+                          <a:solidFill>
+                            <a:srgbClr val="423C3B"/>
+                          </a:solidFill>
+                          <a:latin typeface="Source Han Serif TW"/>
+                          <a:ea typeface="Source Han Serif TW"/>
+                          <a:cs typeface="Source Han Serif TW"/>
+                        </a:rPr>
+                        <a:t>200</a:t>
+                      </a:r>
+                    </a:p>
+                  </a:txBody>
+                  <a:tcPr marL="76200" marR="76200" marT="28575" marB="28575">
+                    <a:solidFill>
+                      <a:srgbClr val="FCF8F5"/>
+                    </a:solidFill>
+                  </a:tcPr>
+                </a:tc>
+                <a:tc>
+                  <a:txBody>
+                    <a:bodyPr>
+                      <a:noAutofit/>
+                    </a:bodyPr>
+                    <a:lstStyle/>
+                    <a:p>
+                      <a:r>
+                        <a:rPr sz="1466" b="0">
+                          <a:solidFill>
+                            <a:srgbClr val="423C3B"/>
+                          </a:solidFill>
+                          <a:latin typeface="Source Han Serif TW"/>
+                          <a:ea typeface="Source Han Serif TW"/>
+                          <a:cs typeface="Source Han Serif TW"/>
+                        </a:rPr>
+                        <a:t>256 / 332 / 12 / 0</a:t>
                       </a:r>
                     </a:p>
                   </a:txBody>
@@ -7821,68 +7750,120 @@
                   </a:tcPr>
                 </a:tc>
               </a:tr>
-              <a:tr h="881062">
-                <a:tc>
-                  <a:txBody>
-                    <a:bodyPr>
-                      <a:noAutofit/>
-                    </a:bodyPr>
-                    <a:lstStyle/>
-                    <a:p>
-                      <a:r>
-                        <a:rPr sz="1725" b="0">
-                          <a:solidFill>
-                            <a:srgbClr val="423C3B"/>
-                          </a:solidFill>
-                          <a:latin typeface="Source Han Serif TW"/>
-                          <a:ea typeface="Source Han Serif TW"/>
-                          <a:cs typeface="Source Han Serif TW"/>
-                        </a:rPr>
-                        <a:t>0927 20260928_115653_334420</a:t>
-                      </a:r>
-                    </a:p>
-                  </a:txBody>
-                  <a:tcPr marL="76200" marR="76200" marT="28575" marB="28575">
-                    <a:solidFill>
-                      <a:srgbClr val="FCF8F5"/>
-                    </a:solidFill>
-                  </a:tcPr>
-                </a:tc>
-                <a:tc>
-                  <a:txBody>
-                    <a:bodyPr>
-                      <a:noAutofit/>
-                    </a:bodyPr>
-                    <a:lstStyle/>
-                    <a:p>
-                      <a:r>
-                        <a:rPr sz="1725" b="0">
-                          <a:solidFill>
-                            <a:srgbClr val="423C3B"/>
-                          </a:solidFill>
-                          <a:latin typeface="Source Han Serif TW"/>
-                          <a:ea typeface="Source Han Serif TW"/>
-                          <a:cs typeface="Source Han Serif TW"/>
-                        </a:rPr>
-                        <a:t>semantic tie-break</a:t>
-                      </a:r>
-                    </a:p>
-                  </a:txBody>
-                  <a:tcPr marL="76200" marR="76200" marT="28575" marB="28575">
-                    <a:solidFill>
-                      <a:srgbClr val="FCF8F5"/>
-                    </a:solidFill>
-                  </a:tcPr>
-                </a:tc>
-                <a:tc>
-                  <a:txBody>
-                    <a:bodyPr>
-                      <a:noAutofit/>
-                    </a:bodyPr>
-                    <a:lstStyle/>
-                    <a:p>
-                      <a:r>
-                        <a:rPr sz="1725" b="0">
+              <a:tr h="715863">
+                <a:tc>
+                  <a:txBody>
+                    <a:bodyPr>
+                      <a:noAutofit/>
+                    </a:bodyPr>
+                    <a:lstStyle/>
+                    <a:p>
+                      <a:r>
+                        <a:rPr sz="1466" b="0">
+                          <a:solidFill>
+                            <a:srgbClr val="423C3B"/>
+                          </a:solidFill>
+                          <a:latin typeface="Source Han Serif TW"/>
+                          <a:ea typeface="Source Han Serif TW"/>
+                          <a:cs typeface="Source Han Serif TW"/>
+                        </a:rPr>
+                        <a:t>09/27 self-play run</a:t>
+                      </a:r>
+                    </a:p>
+                  </a:txBody>
+                  <a:tcPr marL="76200" marR="76200" marT="28575" marB="28575">
+                    <a:solidFill>
+                      <a:srgbClr val="FCF8F5"/>
+                    </a:solidFill>
+                  </a:tcPr>
+                </a:tc>
+                <a:tc>
+                  <a:txBody>
+                    <a:bodyPr>
+                      <a:noAutofit/>
+                    </a:bodyPr>
+                    <a:lstStyle/>
+                    <a:p>
+                      <a:r>
+                        <a:rPr sz="1466" b="0">
+                          <a:solidFill>
+                            <a:srgbClr val="423C3B"/>
+                          </a:solidFill>
+                          <a:latin typeface="Source Han Serif TW"/>
+                          <a:ea typeface="Source Han Serif TW"/>
+                          <a:cs typeface="Source Han Serif TW"/>
+                        </a:rPr>
+                        <a:t>10 個 snapshot slots</a:t>
+                      </a:r>
+                    </a:p>
+                  </a:txBody>
+                  <a:tcPr marL="76200" marR="76200" marT="28575" marB="28575">
+                    <a:solidFill>
+                      <a:srgbClr val="FCF8F5"/>
+                    </a:solidFill>
+                  </a:tcPr>
+                </a:tc>
+                <a:tc>
+                  <a:txBody>
+                    <a:bodyPr>
+                      <a:noAutofit/>
+                    </a:bodyPr>
+                    <a:lstStyle/>
+                    <a:p>
+                      <a:r>
+                        <a:rPr sz="1466" b="0">
+                          <a:solidFill>
+                            <a:srgbClr val="423C3B"/>
+                          </a:solidFill>
+                          <a:latin typeface="Source Han Serif TW"/>
+                          <a:ea typeface="Source Han Serif TW"/>
+                          <a:cs typeface="Source Han Serif TW"/>
+                        </a:rPr>
+                        <a:t>單一 game_performance；semantic tie-break ≤1.0</a:t>
+                      </a:r>
+                    </a:p>
+                  </a:txBody>
+                  <a:tcPr marL="76200" marR="76200" marT="28575" marB="28575">
+                    <a:solidFill>
+                      <a:srgbClr val="FCF8F5"/>
+                    </a:solidFill>
+                  </a:tcPr>
+                </a:tc>
+                <a:tc>
+                  <a:txBody>
+                    <a:bodyPr>
+                      <a:noAutofit/>
+                    </a:bodyPr>
+                    <a:lstStyle/>
+                    <a:p>
+                      <a:r>
+                        <a:rPr sz="1466" b="0">
+                          <a:solidFill>
+                            <a:srgbClr val="423C3B"/>
+                          </a:solidFill>
+                          <a:latin typeface="Source Han Serif TW"/>
+                          <a:ea typeface="Source Han Serif TW"/>
+                          <a:cs typeface="Source Han Serif TW"/>
+                        </a:rPr>
+                        <a:t>200</a:t>
+                      </a:r>
+                    </a:p>
+                  </a:txBody>
+                  <a:tcPr marL="76200" marR="76200" marT="28575" marB="28575">
+                    <a:solidFill>
+                      <a:srgbClr val="FCF8F5"/>
+                    </a:solidFill>
+                  </a:tcPr>
+                </a:tc>
+                <a:tc>
+                  <a:txBody>
+                    <a:bodyPr>
+                      <a:noAutofit/>
+                    </a:bodyPr>
+                    <a:lstStyle/>
+                    <a:p>
+                      <a:r>
+                        <a:rPr sz="1466" b="0">
                           <a:solidFill>
                             <a:srgbClr val="423C3B"/>
                           </a:solidFill>
@@ -7900,23 +7881,129 @@
                     </a:solidFill>
                   </a:tcPr>
                 </a:tc>
-                <a:tc>
-                  <a:txBody>
-                    <a:bodyPr>
-                      <a:noAutofit/>
-                    </a:bodyPr>
-                    <a:lstStyle/>
-                    <a:p>
-                      <a:r>
-                        <a:rPr sz="1725" b="0">
-                          <a:solidFill>
-                            <a:srgbClr val="423C3B"/>
-                          </a:solidFill>
-                          <a:latin typeface="Source Han Serif TW"/>
-                          <a:ea typeface="Source Han Serif TW"/>
-                          <a:cs typeface="Source Han Serif TW"/>
-                        </a:rPr>
-                        <a:t>14/50 Java hashes preserved</a:t>
+              </a:tr>
+              <a:tr h="715863">
+                <a:tc>
+                  <a:txBody>
+                    <a:bodyPr>
+                      <a:noAutofit/>
+                    </a:bodyPr>
+                    <a:lstStyle/>
+                    <a:p>
+                      <a:r>
+                        <a:rPr sz="1466" b="0">
+                          <a:solidFill>
+                            <a:srgbClr val="423C3B"/>
+                          </a:solidFill>
+                          <a:latin typeface="Source Han Serif TW"/>
+                          <a:ea typeface="Source Han Serif TW"/>
+                          <a:cs typeface="Source Han Serif TW"/>
+                        </a:rPr>
+                        <a:t>0929 matched rerun</a:t>
+                      </a:r>
+                    </a:p>
+                  </a:txBody>
+                  <a:tcPr marL="76200" marR="76200" marT="28575" marB="28575">
+                    <a:solidFill>
+                      <a:srgbClr val="FCF8F5"/>
+                    </a:solidFill>
+                  </a:tcPr>
+                </a:tc>
+                <a:tc>
+                  <a:txBody>
+                    <a:bodyPr>
+                      <a:noAutofit/>
+                    </a:bodyPr>
+                    <a:lstStyle/>
+                    <a:p>
+                      <a:r>
+                        <a:rPr sz="1466" b="0">
+                          <a:solidFill>
+                            <a:srgbClr val="423C3B"/>
+                          </a:solidFill>
+                          <a:latin typeface="Source Han Serif TW"/>
+                          <a:ea typeface="Source Han Serif TW"/>
+                          <a:cs typeface="Source Han Serif TW"/>
+                        </a:rPr>
+                        <a:t>固定 opponent cases</a:t>
+                      </a:r>
+                    </a:p>
+                  </a:txBody>
+                  <a:tcPr marL="76200" marR="76200" marT="28575" marB="28575">
+                    <a:solidFill>
+                      <a:srgbClr val="FCF8F5"/>
+                    </a:solidFill>
+                  </a:tcPr>
+                </a:tc>
+                <a:tc>
+                  <a:txBody>
+                    <a:bodyPr>
+                      <a:noAutofit/>
+                    </a:bodyPr>
+                    <a:lstStyle/>
+                    <a:p>
+                      <a:r>
+                        <a:rPr sz="1466" b="0">
+                          <a:solidFill>
+                            <a:srgbClr val="423C3B"/>
+                          </a:solidFill>
+                          <a:latin typeface="Source Han Serif TW"/>
+                          <a:ea typeface="Source Han Serif TW"/>
+                          <a:cs typeface="Source Han Serif TW"/>
+                        </a:rPr>
+                        <a:t>opponent_cases；沿用 baseline 參數</a:t>
+                      </a:r>
+                    </a:p>
+                  </a:txBody>
+                  <a:tcPr marL="76200" marR="76200" marT="28575" marB="28575">
+                    <a:solidFill>
+                      <a:srgbClr val="FCF8F5"/>
+                    </a:solidFill>
+                  </a:tcPr>
+                </a:tc>
+                <a:tc>
+                  <a:txBody>
+                    <a:bodyPr>
+                      <a:noAutofit/>
+                    </a:bodyPr>
+                    <a:lstStyle/>
+                    <a:p>
+                      <a:r>
+                        <a:rPr sz="1466" b="0">
+                          <a:solidFill>
+                            <a:srgbClr val="423C3B"/>
+                          </a:solidFill>
+                          <a:latin typeface="Source Han Serif TW"/>
+                          <a:ea typeface="Source Han Serif TW"/>
+                          <a:cs typeface="Source Han Serif TW"/>
+                        </a:rPr>
+                        <a:t>200</a:t>
+                      </a:r>
+                    </a:p>
+                  </a:txBody>
+                  <a:tcPr marL="76200" marR="76200" marT="28575" marB="28575">
+                    <a:solidFill>
+                      <a:srgbClr val="FCF8F5"/>
+                    </a:solidFill>
+                  </a:tcPr>
+                </a:tc>
+                <a:tc>
+                  <a:txBody>
+                    <a:bodyPr>
+                      <a:noAutofit/>
+                    </a:bodyPr>
+                    <a:lstStyle/>
+                    <a:p>
+                      <a:r>
+                        <a:rPr sz="1466" b="0">
+                          <a:solidFill>
+                            <a:srgbClr val="423C3B"/>
+                          </a:solidFill>
+                          <a:latin typeface="Source Han Serif TW"/>
+                          <a:ea typeface="Source Han Serif TW"/>
+                          <a:cs typeface="Source Han Serif TW"/>
+                        </a:rPr>
+                        <a:t>待跑</a:t>
                       </a:r>
                     </a:p>
                   </a:txBody>
@@ -7936,7 +8023,7 @@
           <p:cNvPr id="6" name="">
             <a:extLst>
               <a:ext uri="{FF2B5EF4-FFF2-40B4-BE49-F238E27FC236}">
-                <ns2:creationId id="{C9656939-0805-47E9-AAE3-DAA108601499}"/>
+                <ns2:creationId id="{362D3F17-8E62-4C1A-9824-1B44232D773D}"/>
               </a:ext>
             </a:extLst>
           </p:cNvPr>
@@ -7947,8 +8034,8 @@
         </p:nvSpPr>
         <p:spPr>
           <a:xfrm>
-            <a:off x="1451282" y="5707261"/>
-            <a:ext cx="12786656" cy="660797"/>
+            <a:off x="1451282" y="5685234"/>
+            <a:ext cx="12786656" cy="726877"/>
           </a:xfrm>
           <a:prstGeom prst="rect">
             <a:avLst/>
@@ -7965,7 +8052,7 @@
           <a:lstStyle/>
           <a:p>
             <a:pPr>
-              <a:defRPr sz="1811" b="0">
+              <a:defRPr sz="1639" b="0">
                 <a:solidFill>
                   <a:srgbClr val="423C3B"/>
                 </a:solidFill>
@@ -7975,7 +8062,7 @@
               </a:defRPr>
             </a:pPr>
             <a:r>
-              <a:rPr sz="1811" b="0">
+              <a:rPr sz="1639" b="0">
                 <a:solidFill>
                   <a:srgbClr val="423C3B"/>
                 </a:solidFill>
@@ -7983,7 +8070,7 @@
                 <a:ea typeface="Source Han Serif TW"/>
                 <a:cs typeface="Source Han Serif TW"/>
               </a:rPr>
-              <a:t>表現差異可描述，不能只歸因於 semantic tie-break：source revision、refresh Java 漂移、候選 failures 和 initial population 都不同。</a:t>
+              <a:t>歷史數字可並列，但不是乾淨因果估計。0929 control 固定 10×20、模型、prompt、地圖與 offspring 預算；要做同版本單因子對照，需在同一 source revision 重跑兩種 evaluation。</a:t>
             </a:r>
           </a:p>
         </p:txBody>
@@ -7993,7 +8080,7 @@
           <p:cNvPr id="7" name="">
             <a:extLst>
               <a:ext uri="{FF2B5EF4-FFF2-40B4-BE49-F238E27FC236}">
-                <ns2:creationId id="{BA483F48-C6EC-434F-B913-5573333AE7E4}"/>
+                <ns2:creationId id="{37280ACB-5161-4EFA-AAE4-B83B0B0DB9CF}"/>
               </a:ext>
             </a:extLst>
           </p:cNvPr>
@@ -8040,7 +8127,7 @@
                 <a:ea typeface="Source Han Serif TW"/>
                 <a:cs typeface="Source Han Serif TW"/>
               </a:rPr>
-              <a:t>保留 run ID，避免以相同 10×20 標籤覆蓋不同協定</a:t>
+              <a:t>舊版固定對手組勝 256 場；0927 self-play 在共同 final test 勝 0 場</a:t>
             </a:r>
           </a:p>
         </p:txBody>
@@ -8085,7 +8172,7 @@
                 <a:cs typeface="Source Han Serif TW"/>
               </a:defRPr>
             </a:pPr>
-            <a:fld id="{16687BC8-1034-4928-BCD0-12685D7BB20B}" type="slidenum">
+            <a:fld id="{3307F304-2424-4D5F-825C-F08C7A9688AD}" type="slidenum">
               <a:rPr sz="1650" b="0">
                 <a:solidFill>
                   <a:srgbClr val="CF8792"/>
@@ -8102,7 +8189,7 @@
     </p:spTree>
     <p:extLst>
       <p:ext uri="{BB962C8B-B14F-4D97-AF65-F5344CB8AC3E}">
-        <ns3:creationId val="1860348125"/>
+        <ns3:creationId val="754492113"/>
       </p:ext>
     </p:extLst>
   </p:cSld>
@@ -8126,7 +8213,7 @@
           <p:cNvPr id="12" name="EAGLE_0">
             <a:extLst>
               <a:ext uri="{FF2B5EF4-FFF2-40B4-BE49-F238E27FC236}">
-                <ns2:creationId id="{D9890FCD-0CE9-41E6-BC84-1D9C339B1557}"/>
+                <ns2:creationId id="{FFB1068D-DCD3-40C7-9DEA-832C0A50D18E}"/>
               </a:ext>
             </a:extLst>
           </p:cNvPr>
@@ -8179,7 +8266,7 @@
           <p:cNvPr id="13" name="EAGLE_1">
             <a:extLst>
               <a:ext uri="{FF2B5EF4-FFF2-40B4-BE49-F238E27FC236}">
-                <ns2:creationId id="{B9CBE650-2465-4190-930B-1A66CE60F354}"/>
+                <ns2:creationId id="{A4E00CCD-8B8B-4ADA-A30D-C1D65E4BFDB9}"/>
               </a:ext>
             </a:extLst>
           </p:cNvPr>
@@ -8657,7 +8744,7 @@
           <p:cNvPr id="6" name="">
             <a:extLst>
               <a:ext uri="{FF2B5EF4-FFF2-40B4-BE49-F238E27FC236}">
-                <ns2:creationId id="{A789A50B-8DB1-4ECD-ACD1-E288C1EAB205}"/>
+                <ns2:creationId id="{517AF826-14AB-4202-97E7-97FE5603DBC7}"/>
               </a:ext>
             </a:extLst>
           </p:cNvPr>
@@ -8749,7 +8836,7 @@
                 <a:cs typeface="Source Han Serif TW"/>
               </a:defRPr>
             </a:pPr>
-            <a:fld id="{92404C3F-BF5A-4468-A9D1-B86336D84C6F}" type="slidenum">
+            <a:fld id="{A8C06245-F643-43BC-9237-6CE6C5E6A851}" type="slidenum">
               <a:rPr sz="1650" b="0">
                 <a:solidFill>
                   <a:srgbClr val="CF8792"/>
@@ -8766,7 +8853,7 @@
     </p:spTree>
     <p:extLst>
       <p:ext uri="{BB962C8B-B14F-4D97-AF65-F5344CB8AC3E}">
-        <ns3:creationId val="473658940"/>
+        <ns3:creationId val="1646366034"/>
       </p:ext>
     </p:extLst>
   </p:cSld>
@@ -8790,7 +8877,7 @@
           <p:cNvPr id="13" name="EAGLE_0">
             <a:extLst>
               <a:ext uri="{FF2B5EF4-FFF2-40B4-BE49-F238E27FC236}">
-                <ns2:creationId id="{D32A0468-E0DD-4B5C-8068-744CE7E1A53B}"/>
+                <ns2:creationId id="{D7500925-9B13-4B1F-A801-D550430FC8E1}"/>
               </a:ext>
             </a:extLst>
           </p:cNvPr>
@@ -8814,7 +8901,7 @@
           <a:lstStyle/>
           <a:p>
             <a:pPr algn="ctr">
-              <a:defRPr sz="3000" b="1">
+              <a:defRPr sz="3043" b="1">
                 <a:solidFill>
                   <a:srgbClr val="47171C"/>
                 </a:solidFill>
@@ -8825,7 +8912,7 @@
               <a:buNone/>
             </a:pPr>
             <a:r>
-              <a:rPr sz="3000" b="1">
+              <a:rPr sz="3043" b="1">
                 <a:solidFill>
                   <a:srgbClr val="47171C"/>
                 </a:solidFill>
@@ -8833,7 +8920,7 @@
                 <a:ea typeface="Source Han Serif TW"/>
                 <a:cs typeface="Source Han Serif TW"/>
               </a:rPr>
-              <a:t>Refresh Java 漂移與 candidate failures 是主要有效性風險</a:t>
+              <a:t>三組單一目標 runs：refresh 漂移與 candidate failures</a:t>
             </a:r>
           </a:p>
         </p:txBody>
@@ -8843,7 +8930,7 @@
           <p:cNvPr id="14" name="EAGLE_1">
             <a:extLst>
               <a:ext uri="{FF2B5EF4-FFF2-40B4-BE49-F238E27FC236}">
-                <ns2:creationId id="{20E4498C-03D4-4F89-B01F-A75B8C7EAA6B}"/>
+                <ns2:creationId id="{53374EC3-87D1-4FEC-BC47-BE6B34126004}"/>
               </a:ext>
             </a:extLst>
           </p:cNvPr>
@@ -8886,7 +8973,7 @@
                 <a:ea typeface="Source Han Serif TW"/>
                 <a:cs typeface="Source Han Serif TW"/>
               </a:rPr>
-              <a:t>所有 4 個 Notion runs 的 final tests 無 match errors；演化路徑仍有紀錄完整性 caveat</a:t>
+              <a:t>final test 無 match errors；演化路徑仍有紀錄完整性 caveat</a:t>
             </a:r>
           </a:p>
         </p:txBody>
@@ -8913,7 +9000,7 @@
                 <a:gridCol w="3041759"/>
                 <a:gridCol w="3605048"/>
               </a:tblGrid>
-              <a:tr h="660797">
+              <a:tr h="825996">
                 <a:tc>
                   <a:txBody>
                     <a:bodyPr>
@@ -9019,7 +9106,7 @@
                   </a:tcPr>
                 </a:tc>
               </a:tr>
-              <a:tr h="660797">
+              <a:tr h="825996">
                 <a:tc>
                   <a:txBody>
                     <a:bodyPr>
@@ -9036,7 +9123,7 @@
                           <a:ea typeface="Source Han Serif TW"/>
                           <a:cs typeface="Source Han Serif TW"/>
                         </a:rPr>
-                        <a:t>0925 5×40 legacy</a:t>
+                        <a:t>0926 10×10 semantic</a:t>
                       </a:r>
                     </a:p>
                   </a:txBody>
@@ -9062,7 +9149,7 @@
                           <a:ea typeface="Source Han Serif TW"/>
                           <a:cs typeface="Source Han Serif TW"/>
                         </a:rPr>
-                        <a:t>40</a:t>
+                        <a:t>20</a:t>
                       </a:r>
                     </a:p>
                   </a:txBody>
@@ -9088,7 +9175,7 @@
                           <a:ea typeface="Source Han Serif TW"/>
                           <a:cs typeface="Source Han Serif TW"/>
                         </a:rPr>
-                        <a:t>14/40</a:t>
+                        <a:t>5/20</a:t>
                       </a:r>
                     </a:p>
                   </a:txBody>
@@ -9114,7 +9201,7 @@
                           <a:ea typeface="Source Han Serif TW"/>
                           <a:cs typeface="Source Han Serif TW"/>
                         </a:rPr>
-                        <a:t>2 / 245</a:t>
+                        <a:t>5 / 130</a:t>
                       </a:r>
                     </a:p>
                   </a:txBody>
@@ -9125,7 +9212,7 @@
                   </a:tcPr>
                 </a:tc>
               </a:tr>
-              <a:tr h="660797">
+              <a:tr h="825996">
                 <a:tc>
                   <a:txBody>
                     <a:bodyPr>
@@ -9142,7 +9229,7 @@
                           <a:ea typeface="Source Han Serif TW"/>
                           <a:cs typeface="Source Han Serif TW"/>
                         </a:rPr>
-                        <a:t>0926 10×10 semantic</a:t>
+                        <a:t>0926 5×20 semantic</a:t>
                       </a:r>
                     </a:p>
                   </a:txBody>
@@ -9168,7 +9255,7 @@
                           <a:ea typeface="Source Han Serif TW"/>
                           <a:cs typeface="Source Han Serif TW"/>
                         </a:rPr>
-                        <a:t>20</a:t>
+                        <a:t>25</a:t>
                       </a:r>
                     </a:p>
                   </a:txBody>
@@ -9194,7 +9281,7 @@
                           <a:ea typeface="Source Han Serif TW"/>
                           <a:cs typeface="Source Han Serif TW"/>
                         </a:rPr>
-                        <a:t>5/20</a:t>
+                        <a:t>8/25</a:t>
                       </a:r>
                     </a:p>
                   </a:txBody>
@@ -9220,7 +9307,7 @@
                           <a:ea typeface="Source Han Serif TW"/>
                           <a:cs typeface="Source Han Serif TW"/>
                         </a:rPr>
-                        <a:t>5 / 130</a:t>
+                        <a:t>3 / 130</a:t>
                       </a:r>
                     </a:p>
                   </a:txBody>
@@ -9231,113 +9318,7 @@
                   </a:tcPr>
                 </a:tc>
               </a:tr>
-              <a:tr h="660797">
-                <a:tc>
-                  <a:txBody>
-                    <a:bodyPr>
-                      <a:noAutofit/>
-                    </a:bodyPr>
-                    <a:lstStyle/>
-                    <a:p>
-                      <a:r>
-                        <a:rPr sz="1811" b="0">
-                          <a:solidFill>
-                            <a:srgbClr val="423C3B"/>
-                          </a:solidFill>
-                          <a:latin typeface="Source Han Serif TW"/>
-                          <a:ea typeface="Source Han Serif TW"/>
-                          <a:cs typeface="Source Han Serif TW"/>
-                        </a:rPr>
-                        <a:t>0926 5×20 semantic</a:t>
-                      </a:r>
-                    </a:p>
-                  </a:txBody>
-                  <a:tcPr marL="76200" marR="76200" marT="28575" marB="28575">
-                    <a:solidFill>
-                      <a:srgbClr val="FCF8F5"/>
-                    </a:solidFill>
-                  </a:tcPr>
-                </a:tc>
-                <a:tc>
-                  <a:txBody>
-                    <a:bodyPr>
-                      <a:noAutofit/>
-                    </a:bodyPr>
-                    <a:lstStyle/>
-                    <a:p>
-                      <a:r>
-                        <a:rPr sz="1811" b="0">
-                          <a:solidFill>
-                            <a:srgbClr val="423C3B"/>
-                          </a:solidFill>
-                          <a:latin typeface="Source Han Serif TW"/>
-                          <a:ea typeface="Source Han Serif TW"/>
-                          <a:cs typeface="Source Han Serif TW"/>
-                        </a:rPr>
-                        <a:t>25</a:t>
-                      </a:r>
-                    </a:p>
-                  </a:txBody>
-                  <a:tcPr marL="76200" marR="76200" marT="28575" marB="28575">
-                    <a:solidFill>
-                      <a:srgbClr val="FCF8F5"/>
-                    </a:solidFill>
-                  </a:tcPr>
-                </a:tc>
-                <a:tc>
-                  <a:txBody>
-                    <a:bodyPr>
-                      <a:noAutofit/>
-                    </a:bodyPr>
-                    <a:lstStyle/>
-                    <a:p>
-                      <a:r>
-                        <a:rPr sz="1811" b="0">
-                          <a:solidFill>
-                            <a:srgbClr val="423C3B"/>
-                          </a:solidFill>
-                          <a:latin typeface="Source Han Serif TW"/>
-                          <a:ea typeface="Source Han Serif TW"/>
-                          <a:cs typeface="Source Han Serif TW"/>
-                        </a:rPr>
-                        <a:t>8/25</a:t>
-                      </a:r>
-                    </a:p>
-                  </a:txBody>
-                  <a:tcPr marL="76200" marR="76200" marT="28575" marB="28575">
-                    <a:solidFill>
-                      <a:srgbClr val="FCF8F5"/>
-                    </a:solidFill>
-                  </a:tcPr>
-                </a:tc>
-                <a:tc>
-                  <a:txBody>
-                    <a:bodyPr>
-                      <a:noAutofit/>
-                    </a:bodyPr>
-                    <a:lstStyle/>
-                    <a:p>
-                      <a:r>
-                        <a:rPr sz="1811" b="0">
-                          <a:solidFill>
-                            <a:srgbClr val="423C3B"/>
-                          </a:solidFill>
-                          <a:latin typeface="Source Han Serif TW"/>
-                          <a:ea typeface="Source Han Serif TW"/>
-                          <a:cs typeface="Source Han Serif TW"/>
-                        </a:rPr>
-                        <a:t>3 / 130</a:t>
-                      </a:r>
-                    </a:p>
-                  </a:txBody>
-                  <a:tcPr marL="76200" marR="76200" marT="28575" marB="28575">
-                    <a:solidFill>
-                      <a:srgbClr val="FCF8F5"/>
-                    </a:solidFill>
-                  </a:tcPr>
-                </a:tc>
-              </a:tr>
-              <a:tr h="660797">
+              <a:tr h="825996">
                 <a:tc>
                   <a:txBody>
                     <a:bodyPr>
@@ -9452,7 +9433,7 @@
           <p:cNvPr id="6" name="">
             <a:extLst>
               <a:ext uri="{FF2B5EF4-FFF2-40B4-BE49-F238E27FC236}">
-                <ns2:creationId id="{D460FB62-C0B6-43A8-8C04-23AB1647EA30}"/>
+                <ns2:creationId id="{FABCDE9B-BD36-49A6-87EF-0E345CBB167A}"/>
               </a:ext>
             </a:extLst>
           </p:cNvPr>
@@ -9481,7 +9462,7 @@
           <a:lstStyle/>
           <a:p>
             <a:pPr>
-              <a:defRPr sz="1725" b="0">
+              <a:defRPr sz="1639" b="0">
                 <a:solidFill>
                   <a:srgbClr val="423C3B"/>
                 </a:solidFill>
@@ -9491,7 +9472,7 @@
               </a:defRPr>
             </a:pPr>
             <a:r>
-              <a:rPr sz="1725" b="0">
+              <a:rPr sz="1639" b="0">
                 <a:solidFill>
                   <a:srgbClr val="423C3B"/>
                 </a:solidFill>
@@ -9499,7 +9480,7 @@
                 <a:ea typeface="Source Han Serif TW"/>
                 <a:cs typeface="Source Han Serif TW"/>
               </a:rPr>
-              <a:t>0927 的 28 failures：validation 19、generation 7、compilation 2。0926 5×20 多出 generation 4 migration refresh。</a:t>
+              <a:t>0927 的 28 failures：validation 19、generation 7、compilation 2。0926 5×20 多出 generation 4 migration refresh。semantic 只做 tie resolution，非第二 objective。</a:t>
             </a:r>
           </a:p>
         </p:txBody>
@@ -9509,7 +9490,7 @@
           <p:cNvPr id="7" name="">
             <a:extLst>
               <a:ext uri="{FF2B5EF4-FFF2-40B4-BE49-F238E27FC236}">
-                <ns2:creationId id="{2FE47664-74AC-4340-B7CE-B5E8F2B41FD1}"/>
+                <ns2:creationId id="{BA86B1F3-88D6-49AF-A254-5916A8BC50AD}"/>
               </a:ext>
             </a:extLst>
           </p:cNvPr>
@@ -9601,7 +9582,7 @@
                 <a:cs typeface="Source Han Serif TW"/>
               </a:defRPr>
             </a:pPr>
-            <a:fld id="{B3504977-488F-4812-8386-F00E479780BF}" type="slidenum">
+            <a:fld id="{1C7CD676-1ACD-412B-81E6-AACD5890D926}" type="slidenum">
               <a:rPr sz="1650" b="0">
                 <a:solidFill>
                   <a:srgbClr val="CF8792"/>
@@ -9618,7 +9599,7 @@
     </p:spTree>
     <p:extLst>
       <p:ext uri="{BB962C8B-B14F-4D97-AF65-F5344CB8AC3E}">
-        <ns3:creationId val="1346438980"/>
+        <ns3:creationId val="837850365"/>
       </p:ext>
     </p:extLst>
   </p:cSld>
@@ -9642,7 +9623,7 @@
           <p:cNvPr id="13" name="EAGLE_0">
             <a:extLst>
               <a:ext uri="{FF2B5EF4-FFF2-40B4-BE49-F238E27FC236}">
-                <ns2:creationId id="{09ED2FDD-441F-4091-8FF1-6DBA04961A31}"/>
+                <ns2:creationId id="{4E67E068-9C27-4D16-B7A9-2F39F6DF81B7}"/>
               </a:ext>
             </a:extLst>
           </p:cNvPr>
@@ -9666,7 +9647,7 @@
           <a:lstStyle/>
           <a:p>
             <a:pPr algn="ctr">
-              <a:defRPr sz="4253" b="1">
+              <a:defRPr sz="4480" b="1">
                 <a:solidFill>
                   <a:srgbClr val="47171C"/>
                 </a:solidFill>
@@ -9677,7 +9658,7 @@
               <a:buNone/>
             </a:pPr>
             <a:r>
-              <a:rPr sz="4253" b="1">
+              <a:rPr sz="4480" b="1">
                 <a:solidFill>
                   <a:srgbClr val="47171C"/>
                 </a:solidFill>
@@ -9685,7 +9666,7 @@
                 <a:ea typeface="Source Han Serif TW"/>
                 <a:cs typeface="Source Han Serif TW"/>
               </a:rPr>
-              <a:t>整體結果：高 FFE 或較多世代沒有保證更強</a:t>
+              <a:t>三組單一目標結果：同 FFE 內差距仍很大</a:t>
             </a:r>
           </a:p>
         </p:txBody>
@@ -9695,7 +9676,7 @@
           <p:cNvPr id="14" name="EAGLE_1">
             <a:extLst>
               <a:ext uri="{FF2B5EF4-FFF2-40B4-BE49-F238E27FC236}">
-                <ns2:creationId id="{5781F8A9-63B3-41F0-9ED3-AD5AF4DC58DC}"/>
+                <ns2:creationId id="{F64C6E44-4714-4301-8467-B7BC1AA58803}"/>
               </a:ext>
             </a:extLst>
           </p:cNvPr>
@@ -9738,7 +9719,7 @@
                 <a:ea typeface="Source Han Serif TW"/>
                 <a:cs typeface="Source Han Serif TW"/>
               </a:rPr>
-              <a:t>本批四組單次 runs 中，10×10 的共同外部測試勝場最多</a:t>
+              <a:t>只有 10×10 與 5×20 同為 100 FFE；200 FFE 的 5×40 arm 尚待跑</a:t>
             </a:r>
           </a:p>
         </p:txBody>
@@ -9755,7 +9736,7 @@
         </p:xfrm>
         <a:graphic>
           <a:graphicData uri="http://schemas.openxmlformats.org/drawingml/2006/chart">
-            <ns3:chart r:id="R0d1f434d7c9446a2"/>
+            <ns3:chart r:id="R531f9fb61b474019"/>
           </a:graphicData>
         </a:graphic>
       </p:graphicFrame>
@@ -9764,7 +9745,7 @@
           <p:cNvPr id="6" name="">
             <a:extLst>
               <a:ext uri="{FF2B5EF4-FFF2-40B4-BE49-F238E27FC236}">
-                <ns2:creationId id="{D4C641B2-BB8B-4990-9AE6-A85B0FA6EA25}"/>
+                <ns2:creationId id="{DC197EAB-9788-4621-9CA7-1E5D47B17011}"/>
               </a:ext>
             </a:extLst>
           </p:cNvPr>
@@ -9811,7 +9792,7 @@
                 <a:ea typeface="Source Han Serif TW"/>
                 <a:cs typeface="Source Han Serif TW"/>
               </a:rPr>
-              <a:t>Observed ordering: 10×10 &gt; legacy 5×40 &gt; semantic 5×20 ≈ semantic 10×20 by wins. Protocol and refresh differences prevent ranking config effects.</a:t>
+              <a:t>Fixed-roster results are outcomes against the common opponent group; they do not equal the self-play Game Performance objective. Cross-FFE results are descriptive only.</a:t>
             </a:r>
           </a:p>
         </p:txBody>
@@ -9821,7 +9802,7 @@
           <p:cNvPr id="7" name="">
             <a:extLst>
               <a:ext uri="{FF2B5EF4-FFF2-40B4-BE49-F238E27FC236}">
-                <ns2:creationId id="{983445A2-227A-4828-9331-73FD04E5C331}"/>
+                <ns2:creationId id="{10F82B43-B22F-4A58-A723-6928B245003D}"/>
               </a:ext>
             </a:extLst>
           </p:cNvPr>
@@ -9868,7 +9849,7 @@
                 <a:ea typeface="Source Han Serif TW"/>
                 <a:cs typeface="Source Han Serif TW"/>
               </a:rPr>
-              <a:t>優先以 10×10 作可重現的近期戰力基準，先釐清 phenotype-preserving refresh</a:t>
+              <a:t>10×10 是目前固定對手測試勝場最高的 single-objective run</a:t>
             </a:r>
           </a:p>
         </p:txBody>
@@ -9913,7 +9894,7 @@
                 <a:cs typeface="Source Han Serif TW"/>
               </a:defRPr>
             </a:pPr>
-            <a:fld id="{D75C0996-FBBB-45CC-BA03-31C48F4A5F9A}" type="slidenum">
+            <a:fld id="{AB4B49AD-FA47-4D42-B7D4-F653245E2704}" type="slidenum">
               <a:rPr sz="1650" b="0">
                 <a:solidFill>
                   <a:srgbClr val="CF8792"/>
@@ -9930,7 +9911,7 @@
     </p:spTree>
     <p:extLst>
       <p:ext uri="{BB962C8B-B14F-4D97-AF65-F5344CB8AC3E}">
-        <ns5:creationId val="181525133"/>
+        <ns5:creationId val="540224743"/>
       </p:ext>
     </p:extLst>
   </p:cSld>
@@ -9954,7 +9935,7 @@
           <p:cNvPr id="13" name="EAGLE_0">
             <a:extLst>
               <a:ext uri="{FF2B5EF4-FFF2-40B4-BE49-F238E27FC236}">
-                <ns2:creationId id="{105D2B58-0C9A-485E-864C-37B41B031625}"/>
+                <ns2:creationId id="{73F526BB-6B94-4642-983F-C298671A4720}"/>
               </a:ext>
             </a:extLst>
           </p:cNvPr>
@@ -10007,7 +9988,7 @@
           <p:cNvPr id="14" name="EAGLE_1">
             <a:extLst>
               <a:ext uri="{FF2B5EF4-FFF2-40B4-BE49-F238E27FC236}">
-                <ns2:creationId id="{C528F301-49D1-46B3-947A-70ABABD4101A}"/>
+                <ns2:creationId id="{02CCF35C-6A2E-4343-8AA2-398A44D49F68}"/>
               </a:ext>
             </a:extLst>
           </p:cNvPr>
@@ -10412,7 +10393,7 @@
                           <a:ea typeface="Source Han Serif TW"/>
                           <a:cs typeface="Source Han Serif TW"/>
                         </a:rPr>
-                        <a:t>5×40 selection</a:t>
+                        <a:t>evaluation context at 10×20</a:t>
                       </a:r>
                     </a:p>
                   </a:txBody>
@@ -10438,7 +10419,7 @@
                           <a:ea typeface="Source Han Serif TW"/>
                           <a:cs typeface="Source Han Serif TW"/>
                         </a:rPr>
-                        <a:t>legacy lexicase</a:t>
+                        <a:t>0927 self-play GP</a:t>
                       </a:r>
                     </a:p>
                   </a:txBody>
@@ -10464,7 +10445,7 @@
                           <a:ea typeface="Source Han Serif TW"/>
                           <a:cs typeface="Source Han Serif TW"/>
                         </a:rPr>
-                        <a:t>semantic tie-break</a:t>
+                        <a:t>0929 fixed opponent cases</a:t>
                       </a:r>
                     </a:p>
                   </a:txBody>
@@ -10490,7 +10471,7 @@
                           <a:ea typeface="Source Han Serif TW"/>
                           <a:cs typeface="Source Han Serif TW"/>
                         </a:rPr>
-                        <a:t>selection protocol</a:t>
+                        <a:t>搜尋期評估方式</a:t>
                       </a:r>
                     </a:p>
                   </a:txBody>
@@ -10510,7 +10491,7 @@
           <p:cNvPr id="6" name="">
             <a:extLst>
               <a:ext uri="{FF2B5EF4-FFF2-40B4-BE49-F238E27FC236}">
-                <ns2:creationId id="{B9D52BA7-F1FD-45D8-A5B5-749EF801E5C6}"/>
+                <ns2:creationId id="{A738CB3B-B9F6-4077-9B4D-C8A44C64C410}"/>
               </a:ext>
             </a:extLst>
           </p:cNvPr>
@@ -10567,7 +10548,7 @@
           <p:cNvPr id="7" name="">
             <a:extLst>
               <a:ext uri="{FF2B5EF4-FFF2-40B4-BE49-F238E27FC236}">
-                <ns2:creationId id="{9CDBD7B6-1625-44E3-9448-5FB22E7589FF}"/>
+                <ns2:creationId id="{CDCE966E-0ED9-42DE-85EE-BF6B84B88C23}"/>
               </a:ext>
             </a:extLst>
           </p:cNvPr>
@@ -10614,7 +10595,7 @@
                 <a:ea typeface="Source Han Serif TW"/>
                 <a:cs typeface="Source Han Serif TW"/>
               </a:rPr>
-              <a:t>0929 新增 config 可同時作為兩個 200 FFE 配對的共用對照組</a:t>
+              <a:t>0929 新增 config 分別補齊 200 FFE allocation 與 fixed-opponent evaluation control</a:t>
             </a:r>
           </a:p>
         </p:txBody>
@@ -10659,7 +10640,7 @@
                 <a:cs typeface="Source Han Serif TW"/>
               </a:defRPr>
             </a:pPr>
-            <a:fld id="{624D6412-EC39-42D9-9646-166080DC3BFB}" type="slidenum">
+            <a:fld id="{4D676A2F-1938-4902-9269-5C23FA62D616}" type="slidenum">
               <a:rPr sz="1650" b="0">
                 <a:solidFill>
                   <a:srgbClr val="CF8792"/>
@@ -10676,7 +10657,7 @@
     </p:spTree>
     <p:extLst>
       <p:ext uri="{BB962C8B-B14F-4D97-AF65-F5344CB8AC3E}">
-        <ns3:creationId val="177108152"/>
+        <ns3:creationId val="777971432"/>
       </p:ext>
     </p:extLst>
   </p:cSld>
@@ -10700,7 +10681,7 @@
           <p:cNvPr id="12" name="EAGLE_0">
             <a:extLst>
               <a:ext uri="{FF2B5EF4-FFF2-40B4-BE49-F238E27FC236}">
-                <ns2:creationId id="{509C2F82-07AA-4E17-90DD-A49EBE912FE8}"/>
+                <ns2:creationId id="{0ACBA75D-86AF-442A-AC5C-ECE7259AAF49}"/>
               </a:ext>
             </a:extLst>
           </p:cNvPr>
@@ -10753,7 +10734,7 @@
           <p:cNvPr id="13" name="EAGLE_1">
             <a:extLst>
               <a:ext uri="{FF2B5EF4-FFF2-40B4-BE49-F238E27FC236}">
-                <ns2:creationId id="{3D2B4BBB-2F56-464A-B65C-B5B9BDF392A4}"/>
+                <ns2:creationId id="{A1FF8948-21B8-4946-8227-24436CA4BE9D}"/>
               </a:ext>
             </a:extLst>
           </p:cNvPr>
@@ -10892,7 +10873,7 @@
                           <a:ea typeface="Source Han Serif TW"/>
                           <a:cs typeface="Source Han Serif TW"/>
                         </a:rPr>
-                        <a:t>Algorithm / tie-break</a:t>
+                        <a:t>Objective / semantic tie-break</a:t>
                       </a:r>
                     </a:p>
                   </a:txBody>
@@ -10918,7 +10899,7 @@
                           <a:ea typeface="Source Han Serif TW"/>
                           <a:cs typeface="Source Han Serif TW"/>
                         </a:rPr>
-                        <a:t>game_performance_semantic_tiebreak；fitness tie tolerance 1.0</a:t>
+                        <a:t>game_performance 單一目標；tie ≤1.0 使用 semantic probes 決勝</a:t>
                       </a:r>
                     </a:p>
                   </a:txBody>
@@ -11262,7 +11243,7 @@
           <p:cNvPr id="6" name="">
             <a:extLst>
               <a:ext uri="{FF2B5EF4-FFF2-40B4-BE49-F238E27FC236}">
-                <ns2:creationId id="{91E28E69-1D8A-48C3-9662-ACC169D43C9C}"/>
+                <ns2:creationId id="{0EAE1F2D-714D-4E83-84F0-E844C6BF9056}"/>
               </a:ext>
             </a:extLst>
           </p:cNvPr>
@@ -11354,7 +11335,7 @@
                 <a:cs typeface="Source Han Serif TW"/>
               </a:defRPr>
             </a:pPr>
-            <a:fld id="{CFD4CD73-D1BA-4B6A-8D66-323C24E9843B}" type="slidenum">
+            <a:fld id="{484DC8B8-7677-4048-922C-1C5BFD843A1E}" type="slidenum">
               <a:rPr sz="1650" b="0">
                 <a:solidFill>
                   <a:srgbClr val="CF8792"/>
@@ -11371,7 +11352,7 @@
     </p:spTree>
     <p:extLst>
       <p:ext uri="{BB962C8B-B14F-4D97-AF65-F5344CB8AC3E}">
-        <ns3:creationId val="494037841"/>
+        <ns3:creationId val="22371854"/>
       </p:ext>
     </p:extLst>
   </p:cSld>
@@ -11395,7 +11376,7 @@
           <p:cNvPr id="12" name="EAGLE_0">
             <a:extLst>
               <a:ext uri="{FF2B5EF4-FFF2-40B4-BE49-F238E27FC236}">
-                <ns2:creationId id="{936B5EAF-C717-4A93-8BC7-7B9659E51416}"/>
+                <ns2:creationId id="{EB0AF600-431A-4665-B6E2-B21450623C9A}"/>
               </a:ext>
             </a:extLst>
           </p:cNvPr>
@@ -11448,7 +11429,7 @@
           <p:cNvPr id="13" name="EAGLE_1">
             <a:extLst>
               <a:ext uri="{FF2B5EF4-FFF2-40B4-BE49-F238E27FC236}">
-                <ns2:creationId id="{86FE358F-F6E8-450B-97D7-9DFC22203DF2}"/>
+                <ns2:creationId id="{A4EB73EA-09B7-422C-98DA-DA07CD107EF1}"/>
               </a:ext>
             </a:extLst>
           </p:cNvPr>
@@ -11587,7 +11568,7 @@
                           <a:ea typeface="Source Han Serif TW"/>
                           <a:cs typeface="Source Han Serif TW"/>
                         </a:rPr>
-                        <a:t>Self-play</a:t>
+                        <a:t>Single-objective 主分析</a:t>
                       </a:r>
                     </a:p>
                   </a:txBody>
@@ -11613,7 +11594,7 @@
                           <a:ea typeface="Source Han Serif TW"/>
                           <a:cs typeface="Source Han Serif TW"/>
                         </a:rPr>
-                        <a:t>Notion 0925、0926 10×10、0926 5×20、0927 10×20；README.md 與 3 份 self-play analysis</a:t>
+                        <a:t>Notion 0926 10×10、0926 5×20、0927 10×20；README.md 與 self-play analysis</a:t>
                       </a:r>
                     </a:p>
                   </a:txBody>
@@ -11641,7 +11622,7 @@
                           <a:ea typeface="Source Han Serif TW"/>
                           <a:cs typeface="Source Han Serif TW"/>
                         </a:rPr>
-                        <a:t>Earlier controlled studies</a:t>
+                        <a:t>evaluation-mode control</a:t>
                       </a:r>
                     </a:p>
                   </a:txBody>
@@ -11667,7 +11648,7 @@
                           <a:ea typeface="Source Han Serif TW"/>
                           <a:cs typeface="Source Han Serif TW"/>
                         </a:rPr>
-                        <a:t>09/07 reflection、09/10 model、09/12 initialization、09/14 parent regeneration</a:t>
+                        <a:t>09/11 fixed-roster 10×20 歷史 run；0929 同設定重跑 config 待執行</a:t>
                       </a:r>
                     </a:p>
                   </a:txBody>
@@ -11695,7 +11676,7 @@
                           <a:ea typeface="Source Han Serif TW"/>
                           <a:cs typeface="Source Han Serif TW"/>
                         </a:rPr>
-                        <a:t>Cross-cutting</a:t>
+                        <a:t>Earlier controlled studies</a:t>
                       </a:r>
                     </a:p>
                   </a:txBody>
@@ -11721,7 +11702,7 @@
                           <a:ea typeface="Source Han Serif TW"/>
                           <a:cs typeface="Source Han Serif TW"/>
                         </a:rPr>
-                        <a:t>experiment_results_after_0907.md；version_summary_after_0907.md；model_parameter_audit.md</a:t>
+                        <a:t>09/07 reflection、09/10 model、09/12 initialization、09/14 parent regeneration</a:t>
                       </a:r>
                     </a:p>
                   </a:txBody>
@@ -11775,7 +11756,7 @@
                           <a:ea typeface="Source Han Serif TW"/>
                           <a:cs typeface="Source Han Serif TW"/>
                         </a:rPr>
-                        <a:t>本地 runs 資料夾未提供 0925–0927 原始 run artifacts；近期細節以 Notion page 和同步的 analysis_md 為證據。</a:t>
+                        <a:t>0929 5×40 與 fixed-opponent control configs 尚未執行；無新結果。近期細節以 Notion page 和 analysis_md 為證據。</a:t>
                       </a:r>
                     </a:p>
                   </a:txBody>
@@ -11795,7 +11776,7 @@
           <p:cNvPr id="6" name="">
             <a:extLst>
               <a:ext uri="{FF2B5EF4-FFF2-40B4-BE49-F238E27FC236}">
-                <ns2:creationId id="{B32C412A-1B1B-413A-A0FC-5340C1B49087}"/>
+                <ns2:creationId id="{51ABC6E5-8166-41C9-9659-A5F75305E50A}"/>
               </a:ext>
             </a:extLst>
           </p:cNvPr>
@@ -11887,7 +11868,7 @@
                 <a:cs typeface="Source Han Serif TW"/>
               </a:defRPr>
             </a:pPr>
-            <a:fld id="{9CBFB90C-8F1F-4727-8359-BA1B0640361B}" type="slidenum">
+            <a:fld id="{76BB165B-A82F-4847-B8F3-06D00334483E}" type="slidenum">
               <a:rPr sz="1650" b="0">
                 <a:solidFill>
                   <a:srgbClr val="CF8792"/>
@@ -11904,7 +11885,7 @@
     </p:spTree>
     <p:extLst>
       <p:ext uri="{BB962C8B-B14F-4D97-AF65-F5344CB8AC3E}">
-        <ns3:creationId val="1011307094"/>
+        <ns3:creationId val="943265581"/>
       </p:ext>
     </p:extLst>
   </p:cSld>
@@ -11928,7 +11909,7 @@
           <p:cNvPr id="12" name="EAGLE_0">
             <a:extLst>
               <a:ext uri="{FF2B5EF4-FFF2-40B4-BE49-F238E27FC236}">
-                <ns2:creationId id="{CE428A28-FB4A-4E5A-A01A-1200F632FCD1}"/>
+                <ns2:creationId id="{82FF10C9-C1D1-40E6-BC3E-D38372AF23B4}"/>
               </a:ext>
             </a:extLst>
           </p:cNvPr>
@@ -11981,7 +11962,7 @@
           <p:cNvPr id="13" name="EAGLE_1">
             <a:extLst>
               <a:ext uri="{FF2B5EF4-FFF2-40B4-BE49-F238E27FC236}">
-                <ns2:creationId id="{51787E14-71F1-4FFF-B49F-000D82E71170}"/>
+                <ns2:creationId id="{00BAB8A9-065B-426D-A63D-E01FF8059F09}"/>
               </a:ext>
             </a:extLst>
           </p:cNvPr>
@@ -12174,7 +12155,7 @@
                           <a:ea typeface="Source Han Serif TW"/>
                           <a:cs typeface="Source Han Serif TW"/>
                         </a:rPr>
-                        <a:t>0925 5×40 identity</a:t>
+                        <a:t>0925 5×40 evaluation</a:t>
                       </a:r>
                     </a:p>
                   </a:txBody>
@@ -12200,7 +12181,7 @@
                           <a:ea typeface="Source Han Serif TW"/>
                           <a:cs typeface="Source Han Serif TW"/>
                         </a:rPr>
-                        <a:t>以 config 與 run ID 判斷；manifest experiment_name 誤寫為 self_play_10x20。</a:t>
+                        <a:t>舊 lexicase 對 10 個 self-play snapshot opponents；不是單一 game_performance 目標，排除主表。</a:t>
                       </a:r>
                     </a:p>
                   </a:txBody>
@@ -12228,7 +12209,7 @@
                           <a:ea typeface="Source Han Serif TW"/>
                           <a:cs typeface="Source Han Serif TW"/>
                         </a:rPr>
-                        <a:t>比分順序</a:t>
+                        <a:t>單一目標範圍</a:t>
                       </a:r>
                     </a:p>
                   </a:txBody>
@@ -12254,7 +12235,7 @@
                           <a:ea typeface="Source Han Serif TW"/>
                           <a:cs typeface="Source Han Serif TW"/>
                         </a:rPr>
-                        <a:t>全簡報統一使用 W/L/D/E；不得混用 W/D/L。</a:t>
+                        <a:t>0926–0927 三組只有 game_performance 數值目標；semantic tie-break 有使用、但只在 fitness 差距 ≤1.0 時決勝。</a:t>
                       </a:r>
                     </a:p>
                   </a:txBody>
@@ -12282,7 +12263,7 @@
                           <a:ea typeface="Source Han Serif TW"/>
                           <a:cs typeface="Source Han Serif TW"/>
                         </a:rPr>
-                        <a:t>fitness 比較</a:t>
+                        <a:t>比分順序</a:t>
                       </a:r>
                     </a:p>
                   </a:txBody>
@@ -12308,7 +12289,7 @@
                           <a:ea typeface="Source Han Serif TW"/>
                           <a:cs typeface="Source Han Serif TW"/>
                         </a:rPr>
-                        <a:t>Self-play snapshot 每 5 代換對手 context；跨 snapshot/run 不直接比較 GP。</a:t>
+                        <a:t>全簡報統一使用 W/L/D/E；不得混用 W/D/L。</a:t>
                       </a:r>
                     </a:p>
                   </a:txBody>
@@ -12336,7 +12317,7 @@
                           <a:ea typeface="Source Han Serif TW"/>
                           <a:cs typeface="Source Han Serif TW"/>
                         </a:rPr>
-                        <a:t>因果結論</a:t>
+                        <a:t>fitness 比較</a:t>
                       </a:r>
                     </a:p>
                   </a:txBody>
@@ -12362,7 +12343,7 @@
                           <a:ea typeface="Source Han Serif TW"/>
                           <a:cs typeface="Source Han Serif TW"/>
                         </a:rPr>
-                        <a:t>舊草稿的 5×40 優勢是觀察結果；selection 版本、refresh hash 漂移與 repository revision 仍是混淆因子。</a:t>
+                        <a:t>Self-play snapshot 每 5 代換對手 context；跨 snapshot/run 不直接比較 GP。</a:t>
                       </a:r>
                     </a:p>
                   </a:txBody>
@@ -12382,7 +12363,7 @@
           <p:cNvPr id="6" name="">
             <a:extLst>
               <a:ext uri="{FF2B5EF4-FFF2-40B4-BE49-F238E27FC236}">
-                <ns2:creationId id="{E4F81B94-FF37-40D2-80A5-01CF1492C878}"/>
+                <ns2:creationId id="{8BA21B76-54FF-41C1-BCE8-F9B7CEB45427}"/>
               </a:ext>
             </a:extLst>
           </p:cNvPr>
@@ -12474,7 +12455,7 @@
                 <a:cs typeface="Source Han Serif TW"/>
               </a:defRPr>
             </a:pPr>
-            <a:fld id="{BD288CBD-D7AA-4E46-9121-51CFB085BD8D}" type="slidenum">
+            <a:fld id="{3E7E6945-CF90-48AB-806F-EE7AECD183F3}" type="slidenum">
               <a:rPr sz="1650" b="0">
                 <a:solidFill>
                   <a:srgbClr val="CF8792"/>
@@ -12491,7 +12472,7 @@
     </p:spTree>
     <p:extLst>
       <p:ext uri="{BB962C8B-B14F-4D97-AF65-F5344CB8AC3E}">
-        <ns3:creationId val="1729219368"/>
+        <ns3:creationId val="1171926029"/>
       </p:ext>
     </p:extLst>
   </p:cSld>
@@ -12515,7 +12496,7 @@
           <p:cNvPr id="13" name="EAGLE_0">
             <a:extLst>
               <a:ext uri="{FF2B5EF4-FFF2-40B4-BE49-F238E27FC236}">
-                <ns2:creationId id="{2A5C8C15-E7F9-4922-A3CF-7A4C73122038}"/>
+                <ns2:creationId id="{6A0866E3-73E7-454B-8D0B-6B88B91FDD30}"/>
               </a:ext>
             </a:extLst>
           </p:cNvPr>
@@ -12568,7 +12549,7 @@
           <p:cNvPr id="14" name="EAGLE_1">
             <a:extLst>
               <a:ext uri="{FF2B5EF4-FFF2-40B4-BE49-F238E27FC236}">
-                <ns2:creationId id="{CC2F1445-4B55-4D78-80A2-58CD0C5AC405}"/>
+                <ns2:creationId id="{54224C64-CD1C-49EE-8EEC-86DC45997282}"/>
               </a:ext>
             </a:extLst>
           </p:cNvPr>
@@ -13046,7 +13027,7 @@
           <p:cNvPr id="6" name="">
             <a:extLst>
               <a:ext uri="{FF2B5EF4-FFF2-40B4-BE49-F238E27FC236}">
-                <ns2:creationId id="{6DC2FAB4-5B42-4809-9A55-09C2687B036F}"/>
+                <ns2:creationId id="{4A7035BC-9B16-4376-BB92-E073A309079C}"/>
               </a:ext>
             </a:extLst>
           </p:cNvPr>
@@ -13103,7 +13084,7 @@
           <p:cNvPr id="7" name="">
             <a:extLst>
               <a:ext uri="{FF2B5EF4-FFF2-40B4-BE49-F238E27FC236}">
-                <ns2:creationId id="{EABCFD88-9F5D-432B-92FB-14E5B12BA373}"/>
+                <ns2:creationId id="{AB31584A-8235-4BA2-BB06-A2EE80751ABB}"/>
               </a:ext>
             </a:extLst>
           </p:cNvPr>
@@ -13195,7 +13176,7 @@
                 <a:cs typeface="Source Han Serif TW"/>
               </a:defRPr>
             </a:pPr>
-            <a:fld id="{01C5C17E-96CB-44F4-A937-D6DD6796E9BD}" type="slidenum">
+            <a:fld id="{67B380AF-91E5-4E63-B856-53CE6A1F8137}" type="slidenum">
               <a:rPr sz="1650" b="0">
                 <a:solidFill>
                   <a:srgbClr val="CF8792"/>
@@ -13212,7 +13193,7 @@
     </p:spTree>
     <p:extLst>
       <p:ext uri="{BB962C8B-B14F-4D97-AF65-F5344CB8AC3E}">
-        <ns3:creationId val="856149661"/>
+        <ns3:creationId val="1385412734"/>
       </p:ext>
     </p:extLst>
   </p:cSld>
@@ -13236,7 +13217,7 @@
           <p:cNvPr id="13" name="EAGLE_0">
             <a:extLst>
               <a:ext uri="{FF2B5EF4-FFF2-40B4-BE49-F238E27FC236}">
-                <ns2:creationId id="{FB31B9DA-17FB-435F-8326-AEBB895F1070}"/>
+                <ns2:creationId id="{BEFB1342-78DB-4013-B54F-EFFC5F9DCDFF}"/>
               </a:ext>
             </a:extLst>
           </p:cNvPr>
@@ -13289,7 +13270,7 @@
           <p:cNvPr id="14" name="EAGLE_1">
             <a:extLst>
               <a:ext uri="{FF2B5EF4-FFF2-40B4-BE49-F238E27FC236}">
-                <ns2:creationId id="{315093D0-C163-43BD-96A6-8CD2862DC53A}"/>
+                <ns2:creationId id="{25D8BF36-332D-436A-856A-396A5AE82AFA}"/>
               </a:ext>
             </a:extLst>
           </p:cNvPr>
@@ -13847,7 +13828,7 @@
           <p:cNvPr id="6" name="">
             <a:extLst>
               <a:ext uri="{FF2B5EF4-FFF2-40B4-BE49-F238E27FC236}">
-                <ns2:creationId id="{425FF7F6-6D21-4ECC-A42E-9CEABCA78701}"/>
+                <ns2:creationId id="{F21A828F-1FEB-412E-8A46-62960EDDB948}"/>
               </a:ext>
             </a:extLst>
           </p:cNvPr>
@@ -13904,7 +13885,7 @@
           <p:cNvPr id="7" name="">
             <a:extLst>
               <a:ext uri="{FF2B5EF4-FFF2-40B4-BE49-F238E27FC236}">
-                <ns2:creationId id="{BE047FB6-351A-4E82-8D4D-B3BCDAE3F25B}"/>
+                <ns2:creationId id="{4842D059-A6DF-41D5-813E-B16FEED5CCC7}"/>
               </a:ext>
             </a:extLst>
           </p:cNvPr>
@@ -13996,7 +13977,7 @@
                 <a:cs typeface="Source Han Serif TW"/>
               </a:defRPr>
             </a:pPr>
-            <a:fld id="{F9494553-2D64-432A-8622-FD6342CFA8FA}" type="slidenum">
+            <a:fld id="{61A0C9F6-A030-4429-82D8-7A8C5BEE4F38}" type="slidenum">
               <a:rPr sz="1650" b="0">
                 <a:solidFill>
                   <a:srgbClr val="CF8792"/>
@@ -14013,7 +13994,7 @@
     </p:spTree>
     <p:extLst>
       <p:ext uri="{BB962C8B-B14F-4D97-AF65-F5344CB8AC3E}">
-        <ns3:creationId val="1883973959"/>
+        <ns3:creationId val="800909425"/>
       </p:ext>
     </p:extLst>
   </p:cSld>
@@ -14037,7 +14018,7 @@
           <p:cNvPr id="13" name="EAGLE_0">
             <a:extLst>
               <a:ext uri="{FF2B5EF4-FFF2-40B4-BE49-F238E27FC236}">
-                <ns2:creationId id="{88341815-6FCC-4AE2-A69D-0FBDAD88965E}"/>
+                <ns2:creationId id="{F0E02D47-8A10-4F99-8925-D8081FEF04A6}"/>
               </a:ext>
             </a:extLst>
           </p:cNvPr>
@@ -14090,7 +14071,7 @@
           <p:cNvPr id="14" name="EAGLE_1">
             <a:extLst>
               <a:ext uri="{FF2B5EF4-FFF2-40B4-BE49-F238E27FC236}">
-                <ns2:creationId id="{A7531CE9-0859-48D3-8BCC-3DFC661ACAF3}"/>
+                <ns2:creationId id="{4A8D6A0D-9287-4E2E-814C-49ED543A62E3}"/>
               </a:ext>
             </a:extLst>
           </p:cNvPr>
@@ -14568,7 +14549,7 @@
           <p:cNvPr id="6" name="">
             <a:extLst>
               <a:ext uri="{FF2B5EF4-FFF2-40B4-BE49-F238E27FC236}">
-                <ns2:creationId id="{D0A4E5BE-511B-4C18-83CD-88209AC59E49}"/>
+                <ns2:creationId id="{30C11FC0-8629-4F13-8482-D9DE56FCDA6A}"/>
               </a:ext>
             </a:extLst>
           </p:cNvPr>
@@ -14625,7 +14606,7 @@
           <p:cNvPr id="7" name="">
             <a:extLst>
               <a:ext uri="{FF2B5EF4-FFF2-40B4-BE49-F238E27FC236}">
-                <ns2:creationId id="{6B69FC0F-97C0-4C8D-A755-5E9885575561}"/>
+                <ns2:creationId id="{6F71B1E1-2608-4F15-9E9D-4FF788EF2419}"/>
               </a:ext>
             </a:extLst>
           </p:cNvPr>
@@ -14717,7 +14698,7 @@
                 <a:cs typeface="Source Han Serif TW"/>
               </a:defRPr>
             </a:pPr>
-            <a:fld id="{1022676C-50D6-47EF-B353-62E89F6B9AB0}" type="slidenum">
+            <a:fld id="{9A5A8FFC-B84A-4C5E-BE5F-4E781328FB02}" type="slidenum">
               <a:rPr sz="1650" b="0">
                 <a:solidFill>
                   <a:srgbClr val="CF8792"/>
@@ -14734,7 +14715,7 @@
     </p:spTree>
     <p:extLst>
       <p:ext uri="{BB962C8B-B14F-4D97-AF65-F5344CB8AC3E}">
-        <ns3:creationId val="1292830235"/>
+        <ns3:creationId val="1287304546"/>
       </p:ext>
     </p:extLst>
   </p:cSld>
@@ -14758,7 +14739,7 @@
           <p:cNvPr id="13" name="EAGLE_0">
             <a:extLst>
               <a:ext uri="{FF2B5EF4-FFF2-40B4-BE49-F238E27FC236}">
-                <ns2:creationId id="{77079A85-D6FD-4401-AA4C-8A69BCF0FED6}"/>
+                <ns2:creationId id="{2A5584A0-813D-4AEE-93DD-39FEEA7C9DDF}"/>
               </a:ext>
             </a:extLst>
           </p:cNvPr>
@@ -14811,7 +14792,7 @@
           <p:cNvPr id="14" name="EAGLE_1">
             <a:extLst>
               <a:ext uri="{FF2B5EF4-FFF2-40B4-BE49-F238E27FC236}">
-                <ns2:creationId id="{28B28EE8-E32C-45AA-BD3A-8EFC1F282511}"/>
+                <ns2:creationId id="{01B6F3C5-ADB8-4470-96A1-A0CA7734C274}"/>
               </a:ext>
             </a:extLst>
           </p:cNvPr>
@@ -15289,7 +15270,7 @@
           <p:cNvPr id="6" name="">
             <a:extLst>
               <a:ext uri="{FF2B5EF4-FFF2-40B4-BE49-F238E27FC236}">
-                <ns2:creationId id="{FECFFE9E-9B9F-495B-9AD4-8F0BEC4D1D80}"/>
+                <ns2:creationId id="{391EB4F8-149D-444B-90BA-E10E100284C7}"/>
               </a:ext>
             </a:extLst>
           </p:cNvPr>
@@ -15346,7 +15327,7 @@
           <p:cNvPr id="7" name="">
             <a:extLst>
               <a:ext uri="{FF2B5EF4-FFF2-40B4-BE49-F238E27FC236}">
-                <ns2:creationId id="{FAC4190F-F48F-4B99-B63F-0CEA261C1721}"/>
+                <ns2:creationId id="{A5E7E2C6-A960-4A45-A7E9-177D131DC1B6}"/>
               </a:ext>
             </a:extLst>
           </p:cNvPr>
@@ -15438,7 +15419,7 @@
                 <a:cs typeface="Source Han Serif TW"/>
               </a:defRPr>
             </a:pPr>
-            <a:fld id="{F647B584-F30D-4E47-8BB5-012394031999}" type="slidenum">
+            <a:fld id="{44EE84E2-EB35-4199-AA4A-810169245AD5}" type="slidenum">
               <a:rPr sz="1650" b="0">
                 <a:solidFill>
                   <a:srgbClr val="CF8792"/>
@@ -15455,7 +15436,7 @@
     </p:spTree>
     <p:extLst>
       <p:ext uri="{BB962C8B-B14F-4D97-AF65-F5344CB8AC3E}">
-        <ns3:creationId val="1175252726"/>
+        <ns3:creationId val="266163929"/>
       </p:ext>
     </p:extLst>
   </p:cSld>
@@ -15479,7 +15460,7 @@
           <p:cNvPr id="13" name="EAGLE_0">
             <a:extLst>
               <a:ext uri="{FF2B5EF4-FFF2-40B4-BE49-F238E27FC236}">
-                <ns2:creationId id="{8ACB9658-17B3-491E-AE00-FCF65DF4DDED}"/>
+                <ns2:creationId id="{57B356E1-1DE6-40ED-90D6-8AE53000C480}"/>
               </a:ext>
             </a:extLst>
           </p:cNvPr>
@@ -15532,7 +15513,7 @@
           <p:cNvPr id="14" name="EAGLE_1">
             <a:extLst>
               <a:ext uri="{FF2B5EF4-FFF2-40B4-BE49-F238E27FC236}">
-                <ns2:creationId id="{2F4C4C63-BEFF-4804-AEB7-B5E6CCAF7E0B}"/>
+                <ns2:creationId id="{3269C2C8-8879-4B73-9949-6A02DBC16C87}"/>
               </a:ext>
             </a:extLst>
           </p:cNvPr>
@@ -15825,7 +15806,7 @@
           <p:cNvPr id="6" name="">
             <a:extLst>
               <a:ext uri="{FF2B5EF4-FFF2-40B4-BE49-F238E27FC236}">
-                <ns2:creationId id="{3AF85D76-5688-4413-BB6D-B088D89793B4}"/>
+                <ns2:creationId id="{FE1DD4BD-5C1F-4795-98EA-AA1E55D779AD}"/>
               </a:ext>
             </a:extLst>
           </p:cNvPr>
@@ -15882,7 +15863,7 @@
           <p:cNvPr id="7" name="">
             <a:extLst>
               <a:ext uri="{FF2B5EF4-FFF2-40B4-BE49-F238E27FC236}">
-                <ns2:creationId id="{FCEEF4FE-F4B5-4E4F-AB4A-8E5C19003256}"/>
+                <ns2:creationId id="{CD8A6A59-C231-4895-9A8F-D173539D1627}"/>
               </a:ext>
             </a:extLst>
           </p:cNvPr>
@@ -15974,7 +15955,7 @@
                 <a:cs typeface="Source Han Serif TW"/>
               </a:defRPr>
             </a:pPr>
-            <a:fld id="{8F36C5EB-CB37-4376-9875-235E3E59697A}" type="slidenum">
+            <a:fld id="{E1CA52C4-97F8-4AC2-9A96-4D7030F4A1A7}" type="slidenum">
               <a:rPr sz="1650" b="0">
                 <a:solidFill>
                   <a:srgbClr val="CF8792"/>
@@ -15991,7 +15972,7 @@
     </p:spTree>
     <p:extLst>
       <p:ext uri="{BB962C8B-B14F-4D97-AF65-F5344CB8AC3E}">
-        <ns3:creationId val="625979740"/>
+        <ns3:creationId val="793562071"/>
       </p:ext>
     </p:extLst>
   </p:cSld>
@@ -16012,10 +15993,10 @@
       </p:grpSpPr>
       <p:sp>
         <p:nvSpPr>
-          <p:cNvPr id="12" name="EAGLE_0">
+          <p:cNvPr id="13" name="EAGLE_0">
             <a:extLst>
               <a:ext uri="{FF2B5EF4-FFF2-40B4-BE49-F238E27FC236}">
-                <ns2:creationId id="{9CB13A83-18EA-4FE3-B3D5-AFB58B7B5EAF}"/>
+                <ns2:creationId id="{52307C25-BE68-4A55-B4D4-26873CFB23BE}"/>
               </a:ext>
             </a:extLst>
           </p:cNvPr>
@@ -16039,7 +16020,7 @@
           <a:lstStyle/>
           <a:p>
             <a:pPr algn="ctr">
-              <a:defRPr sz="4650" b="1">
+              <a:defRPr sz="4553" b="1">
                 <a:solidFill>
                   <a:srgbClr val="47171C"/>
                 </a:solidFill>
@@ -16050,7 +16031,7 @@
               <a:buNone/>
             </a:pPr>
             <a:r>
-              <a:rPr sz="4650" b="1">
+              <a:rPr sz="4553" b="1">
                 <a:solidFill>
                   <a:srgbClr val="47171C"/>
                 </a:solidFill>
@@ -16058,17 +16039,17 @@
                 <a:ea typeface="Source Han Serif TW"/>
                 <a:cs typeface="Source Han Serif TW"/>
               </a:rPr>
-              <a:t>0924 後 self-play 四組 run</a:t>
+              <a:t>0924 後單一目標 self-play：三組 run</a:t>
             </a:r>
           </a:p>
         </p:txBody>
       </p:sp>
       <p:sp>
         <p:nvSpPr>
-          <p:cNvPr id="13" name="EAGLE_1">
+          <p:cNvPr id="14" name="EAGLE_1">
             <a:extLst>
               <a:ext uri="{FF2B5EF4-FFF2-40B4-BE49-F238E27FC236}">
-                <ns2:creationId id="{3742BB71-6A4A-47B5-93CC-5944949272E1}"/>
+                <ns2:creationId id="{7A4DBCEC-5339-47FF-A8C7-D67F9A0BE593}"/>
               </a:ext>
             </a:extLst>
           </p:cNvPr>
@@ -16111,20 +16092,20 @@
                 <a:ea typeface="Source Han Serif TW"/>
                 <a:cs typeface="Source Han Serif TW"/>
               </a:rPr>
-              <a:t>Notion 記錄與本地 README 的 run ID、配置和 final test 相符</a:t>
+              <a:t>semantic tie-break 有使用，但不是第二個目標；只列 game_performance 作 selection objective</a:t>
             </a:r>
           </a:p>
         </p:txBody>
       </p:sp>
       <p:graphicFrame>
         <p:nvGraphicFramePr>
-          <p:cNvPr id="11" name=""/>
+          <p:cNvPr id="12" name=""/>
           <p:cNvGraphicFramePr/>
           <p:nvPr/>
         </p:nvGraphicFramePr>
         <p:xfrm>
           <a:off x="1428750" y="2469356"/>
-          <a:ext cx="13068300" cy="3744516"/>
+          <a:ext cx="13068300" cy="3689449"/>
         </p:xfrm>
         <a:graphic>
           <a:graphicData uri="http://schemas.openxmlformats.org/drawingml/2006/table">
@@ -16133,29 +16114,30 @@
                 <a:tableStyleId>{8497E131-5584-4FF0-9A17-202609170001}</a:tableStyleId>
               </a:tblPr>
               <a:tblGrid>
-                <a:gridCol w="4393653"/>
-                <a:gridCol w="2478471"/>
-                <a:gridCol w="1689866"/>
-                <a:gridCol w="4506310"/>
+                <a:gridCol w="3210746"/>
+                <a:gridCol w="1633538"/>
+                <a:gridCol w="1013920"/>
+                <a:gridCol w="1971511"/>
+                <a:gridCol w="5238586"/>
               </a:tblGrid>
-              <a:tr h="748903">
-                <a:tc>
-                  <a:txBody>
-                    <a:bodyPr>
-                      <a:noAutofit/>
-                    </a:bodyPr>
-                    <a:lstStyle/>
-                    <a:p>
-                      <a:r>
-                        <a:rPr sz="1725" b="1">
-                          <a:solidFill>
-                            <a:srgbClr val="423C3B"/>
-                          </a:solidFill>
-                          <a:latin typeface="Source Han Serif TW"/>
-                          <a:ea typeface="Source Han Serif TW"/>
-                          <a:cs typeface="Source Han Serif TW"/>
-                        </a:rPr>
-                        <a:t>Run / protocol</a:t>
+              <a:tr h="922363">
+                <a:tc>
+                  <a:txBody>
+                    <a:bodyPr>
+                      <a:noAutofit/>
+                    </a:bodyPr>
+                    <a:lstStyle/>
+                    <a:p>
+                      <a:r>
+                        <a:rPr sz="1639" b="1">
+                          <a:solidFill>
+                            <a:srgbClr val="423C3B"/>
+                          </a:solidFill>
+                          <a:latin typeface="Source Han Serif TW"/>
+                          <a:ea typeface="Source Han Serif TW"/>
+                          <a:cs typeface="Source Han Serif TW"/>
+                        </a:rPr>
+                        <a:t>Run</a:t>
                       </a:r>
                     </a:p>
                   </a:txBody>
@@ -16173,7 +16155,7 @@
                     <a:lstStyle/>
                     <a:p>
                       <a:r>
-                        <a:rPr sz="1725" b="1">
+                        <a:rPr sz="1639" b="1">
                           <a:solidFill>
                             <a:srgbClr val="423C3B"/>
                           </a:solidFill>
@@ -16199,7 +16181,7 @@
                     <a:lstStyle/>
                     <a:p>
                       <a:r>
-                        <a:rPr sz="1725" b="1">
+                        <a:rPr sz="1639" b="1">
                           <a:solidFill>
                             <a:srgbClr val="423C3B"/>
                           </a:solidFill>
@@ -16225,15 +16207,15 @@
                     <a:lstStyle/>
                     <a:p>
                       <a:r>
-                        <a:rPr sz="1725" b="1">
-                          <a:solidFill>
-                            <a:srgbClr val="423C3B"/>
-                          </a:solidFill>
-                          <a:latin typeface="Source Han Serif TW"/>
-                          <a:ea typeface="Source Han Serif TW"/>
-                          <a:cs typeface="Source Han Serif TW"/>
-                        </a:rPr>
-                        <a:t>Final test W/L/D/E</a:t>
+                        <a:rPr sz="1639" b="1">
+                          <a:solidFill>
+                            <a:srgbClr val="423C3B"/>
+                          </a:solidFill>
+                          <a:latin typeface="Source Han Serif TW"/>
+                          <a:ea typeface="Source Han Serif TW"/>
+                          <a:cs typeface="Source Han Serif TW"/>
+                        </a:rPr>
+                        <a:t>Search best GP¹</a:t>
                       </a:r>
                     </a:p>
                   </a:txBody>
@@ -16243,69 +16225,359 @@
                     </a:solidFill>
                   </a:tcPr>
                 </a:tc>
+                <a:tc>
+                  <a:txBody>
+                    <a:bodyPr>
+                      <a:noAutofit/>
+                    </a:bodyPr>
+                    <a:lstStyle/>
+                    <a:p>
+                      <a:r>
+                        <a:rPr sz="1639" b="1">
+                          <a:solidFill>
+                            <a:srgbClr val="423C3B"/>
+                          </a:solidFill>
+                          <a:latin typeface="Source Han Serif TW"/>
+                          <a:ea typeface="Source Han Serif TW"/>
+                          <a:cs typeface="Source Han Serif TW"/>
+                        </a:rPr>
+                        <a:t>固定對手 final test W/L/D/E</a:t>
+                      </a:r>
+                    </a:p>
+                  </a:txBody>
+                  <a:tcPr marL="76200" marR="76200" marT="28575" marB="28575">
+                    <a:solidFill>
+                      <a:srgbClr val="DEB4BA"/>
+                    </a:solidFill>
+                  </a:tcPr>
+                </a:tc>
               </a:tr>
-              <a:tr h="748903">
-                <a:tc>
-                  <a:txBody>
-                    <a:bodyPr>
-                      <a:noAutofit/>
-                    </a:bodyPr>
-                    <a:lstStyle/>
-                    <a:p>
-                      <a:r>
-                        <a:rPr sz="1725" b="0">
-                          <a:solidFill>
-                            <a:srgbClr val="423C3B"/>
-                          </a:solidFill>
-                          <a:latin typeface="Source Han Serif TW"/>
-                          <a:ea typeface="Source Han Serif TW"/>
-                          <a:cs typeface="Source Han Serif TW"/>
-                        </a:rPr>
-                        <a:t>0925 5×40 legacy lexicase</a:t>
-                      </a:r>
-                    </a:p>
-                  </a:txBody>
-                  <a:tcPr marL="76200" marR="76200" marT="28575" marB="28575">
-                    <a:solidFill>
-                      <a:srgbClr val="FCF8F5"/>
-                    </a:solidFill>
-                  </a:tcPr>
-                </a:tc>
-                <a:tc>
-                  <a:txBody>
-                    <a:bodyPr>
-                      <a:noAutofit/>
-                    </a:bodyPr>
-                    <a:lstStyle/>
-                    <a:p>
-                      <a:r>
-                        <a:rPr sz="1725" b="0">
-                          <a:solidFill>
-                            <a:srgbClr val="423C3B"/>
-                          </a:solidFill>
-                          <a:latin typeface="Source Han Serif TW"/>
-                          <a:ea typeface="Source Han Serif TW"/>
-                          <a:cs typeface="Source Han Serif TW"/>
-                        </a:rPr>
-                        <a:t>40 × 5</a:t>
-                      </a:r>
-                    </a:p>
-                  </a:txBody>
-                  <a:tcPr marL="76200" marR="76200" marT="28575" marB="28575">
-                    <a:solidFill>
-                      <a:srgbClr val="FCF8F5"/>
-                    </a:solidFill>
-                  </a:tcPr>
-                </a:tc>
-                <a:tc>
-                  <a:txBody>
-                    <a:bodyPr>
-                      <a:noAutofit/>
-                    </a:bodyPr>
-                    <a:lstStyle/>
-                    <a:p>
-                      <a:r>
-                        <a:rPr sz="1725" b="0">
+              <a:tr h="922363">
+                <a:tc>
+                  <a:txBody>
+                    <a:bodyPr>
+                      <a:noAutofit/>
+                    </a:bodyPr>
+                    <a:lstStyle/>
+                    <a:p>
+                      <a:r>
+                        <a:rPr sz="1639" b="0">
+                          <a:solidFill>
+                            <a:srgbClr val="423C3B"/>
+                          </a:solidFill>
+                          <a:latin typeface="Source Han Serif TW"/>
+                          <a:ea typeface="Source Han Serif TW"/>
+                          <a:cs typeface="Source Han Serif TW"/>
+                        </a:rPr>
+                        <a:t>0926 10×10（semantic tie-break）</a:t>
+                      </a:r>
+                    </a:p>
+                  </a:txBody>
+                  <a:tcPr marL="76200" marR="76200" marT="28575" marB="28575">
+                    <a:solidFill>
+                      <a:srgbClr val="FCF8F5"/>
+                    </a:solidFill>
+                  </a:tcPr>
+                </a:tc>
+                <a:tc>
+                  <a:txBody>
+                    <a:bodyPr>
+                      <a:noAutofit/>
+                    </a:bodyPr>
+                    <a:lstStyle/>
+                    <a:p>
+                      <a:r>
+                        <a:rPr sz="1639" b="0">
+                          <a:solidFill>
+                            <a:srgbClr val="423C3B"/>
+                          </a:solidFill>
+                          <a:latin typeface="Source Han Serif TW"/>
+                          <a:ea typeface="Source Han Serif TW"/>
+                          <a:cs typeface="Source Han Serif TW"/>
+                        </a:rPr>
+                        <a:t>10 × 10</a:t>
+                      </a:r>
+                    </a:p>
+                  </a:txBody>
+                  <a:tcPr marL="76200" marR="76200" marT="28575" marB="28575">
+                    <a:solidFill>
+                      <a:srgbClr val="FCF8F5"/>
+                    </a:solidFill>
+                  </a:tcPr>
+                </a:tc>
+                <a:tc>
+                  <a:txBody>
+                    <a:bodyPr>
+                      <a:noAutofit/>
+                    </a:bodyPr>
+                    <a:lstStyle/>
+                    <a:p>
+                      <a:r>
+                        <a:rPr sz="1639" b="0">
+                          <a:solidFill>
+                            <a:srgbClr val="423C3B"/>
+                          </a:solidFill>
+                          <a:latin typeface="Source Han Serif TW"/>
+                          <a:ea typeface="Source Han Serif TW"/>
+                          <a:cs typeface="Source Han Serif TW"/>
+                        </a:rPr>
+                        <a:t>100</a:t>
+                      </a:r>
+                    </a:p>
+                  </a:txBody>
+                  <a:tcPr marL="76200" marR="76200" marT="28575" marB="28575">
+                    <a:solidFill>
+                      <a:srgbClr val="FCF8F5"/>
+                    </a:solidFill>
+                  </a:tcPr>
+                </a:tc>
+                <a:tc>
+                  <a:txBody>
+                    <a:bodyPr>
+                      <a:noAutofit/>
+                    </a:bodyPr>
+                    <a:lstStyle/>
+                    <a:p>
+                      <a:r>
+                        <a:rPr sz="1639" b="0">
+                          <a:solidFill>
+                            <a:srgbClr val="423C3B"/>
+                          </a:solidFill>
+                          <a:latin typeface="Source Han Serif TW"/>
+                          <a:ea typeface="Source Han Serif TW"/>
+                          <a:cs typeface="Source Han Serif TW"/>
+                        </a:rPr>
+                        <a:t>0.666667</a:t>
+                      </a:r>
+                    </a:p>
+                  </a:txBody>
+                  <a:tcPr marL="76200" marR="76200" marT="28575" marB="28575">
+                    <a:solidFill>
+                      <a:srgbClr val="FCF8F5"/>
+                    </a:solidFill>
+                  </a:tcPr>
+                </a:tc>
+                <a:tc>
+                  <a:txBody>
+                    <a:bodyPr>
+                      <a:noAutofit/>
+                    </a:bodyPr>
+                    <a:lstStyle/>
+                    <a:p>
+                      <a:r>
+                        <a:rPr sz="1639" b="0">
+                          <a:solidFill>
+                            <a:srgbClr val="423C3B"/>
+                          </a:solidFill>
+                          <a:latin typeface="Source Han Serif TW"/>
+                          <a:ea typeface="Source Han Serif TW"/>
+                          <a:cs typeface="Source Han Serif TW"/>
+                        </a:rPr>
+                        <a:t>257 / 321 / 22 / 0</a:t>
+                      </a:r>
+                    </a:p>
+                  </a:txBody>
+                  <a:tcPr marL="76200" marR="76200" marT="28575" marB="28575">
+                    <a:solidFill>
+                      <a:srgbClr val="FCF8F5"/>
+                    </a:solidFill>
+                  </a:tcPr>
+                </a:tc>
+              </a:tr>
+              <a:tr h="922363">
+                <a:tc>
+                  <a:txBody>
+                    <a:bodyPr>
+                      <a:noAutofit/>
+                    </a:bodyPr>
+                    <a:lstStyle/>
+                    <a:p>
+                      <a:r>
+                        <a:rPr sz="1639" b="0">
+                          <a:solidFill>
+                            <a:srgbClr val="423C3B"/>
+                          </a:solidFill>
+                          <a:latin typeface="Source Han Serif TW"/>
+                          <a:ea typeface="Source Han Serif TW"/>
+                          <a:cs typeface="Source Han Serif TW"/>
+                        </a:rPr>
+                        <a:t>0926 5×20（semantic tie-break）</a:t>
+                      </a:r>
+                    </a:p>
+                  </a:txBody>
+                  <a:tcPr marL="76200" marR="76200" marT="28575" marB="28575">
+                    <a:solidFill>
+                      <a:srgbClr val="FCF8F5"/>
+                    </a:solidFill>
+                  </a:tcPr>
+                </a:tc>
+                <a:tc>
+                  <a:txBody>
+                    <a:bodyPr>
+                      <a:noAutofit/>
+                    </a:bodyPr>
+                    <a:lstStyle/>
+                    <a:p>
+                      <a:r>
+                        <a:rPr sz="1639" b="0">
+                          <a:solidFill>
+                            <a:srgbClr val="423C3B"/>
+                          </a:solidFill>
+                          <a:latin typeface="Source Han Serif TW"/>
+                          <a:ea typeface="Source Han Serif TW"/>
+                          <a:cs typeface="Source Han Serif TW"/>
+                        </a:rPr>
+                        <a:t>20 × 5</a:t>
+                      </a:r>
+                    </a:p>
+                  </a:txBody>
+                  <a:tcPr marL="76200" marR="76200" marT="28575" marB="28575">
+                    <a:solidFill>
+                      <a:srgbClr val="FCF8F5"/>
+                    </a:solidFill>
+                  </a:tcPr>
+                </a:tc>
+                <a:tc>
+                  <a:txBody>
+                    <a:bodyPr>
+                      <a:noAutofit/>
+                    </a:bodyPr>
+                    <a:lstStyle/>
+                    <a:p>
+                      <a:r>
+                        <a:rPr sz="1639" b="0">
+                          <a:solidFill>
+                            <a:srgbClr val="423C3B"/>
+                          </a:solidFill>
+                          <a:latin typeface="Source Han Serif TW"/>
+                          <a:ea typeface="Source Han Serif TW"/>
+                          <a:cs typeface="Source Han Serif TW"/>
+                        </a:rPr>
+                        <a:t>100</a:t>
+                      </a:r>
+                    </a:p>
+                  </a:txBody>
+                  <a:tcPr marL="76200" marR="76200" marT="28575" marB="28575">
+                    <a:solidFill>
+                      <a:srgbClr val="FCF8F5"/>
+                    </a:solidFill>
+                  </a:tcPr>
+                </a:tc>
+                <a:tc>
+                  <a:txBody>
+                    <a:bodyPr>
+                      <a:noAutofit/>
+                    </a:bodyPr>
+                    <a:lstStyle/>
+                    <a:p>
+                      <a:r>
+                        <a:rPr sz="1639" b="0">
+                          <a:solidFill>
+                            <a:srgbClr val="423C3B"/>
+                          </a:solidFill>
+                          <a:latin typeface="Source Han Serif TW"/>
+                          <a:ea typeface="Source Han Serif TW"/>
+                          <a:cs typeface="Source Han Serif TW"/>
+                        </a:rPr>
+                        <a:t>1.326067</a:t>
+                      </a:r>
+                    </a:p>
+                  </a:txBody>
+                  <a:tcPr marL="76200" marR="76200" marT="28575" marB="28575">
+                    <a:solidFill>
+                      <a:srgbClr val="FCF8F5"/>
+                    </a:solidFill>
+                  </a:tcPr>
+                </a:tc>
+                <a:tc>
+                  <a:txBody>
+                    <a:bodyPr>
+                      <a:noAutofit/>
+                    </a:bodyPr>
+                    <a:lstStyle/>
+                    <a:p>
+                      <a:r>
+                        <a:rPr sz="1639" b="0">
+                          <a:solidFill>
+                            <a:srgbClr val="423C3B"/>
+                          </a:solidFill>
+                          <a:latin typeface="Source Han Serif TW"/>
+                          <a:ea typeface="Source Han Serif TW"/>
+                          <a:cs typeface="Source Han Serif TW"/>
+                        </a:rPr>
+                        <a:t>0 / 388 / 212 / 0</a:t>
+                      </a:r>
+                    </a:p>
+                  </a:txBody>
+                  <a:tcPr marL="76200" marR="76200" marT="28575" marB="28575">
+                    <a:solidFill>
+                      <a:srgbClr val="FCF8F5"/>
+                    </a:solidFill>
+                  </a:tcPr>
+                </a:tc>
+              </a:tr>
+              <a:tr h="922363">
+                <a:tc>
+                  <a:txBody>
+                    <a:bodyPr>
+                      <a:noAutofit/>
+                    </a:bodyPr>
+                    <a:lstStyle/>
+                    <a:p>
+                      <a:r>
+                        <a:rPr sz="1639" b="0">
+                          <a:solidFill>
+                            <a:srgbClr val="423C3B"/>
+                          </a:solidFill>
+                          <a:latin typeface="Source Han Serif TW"/>
+                          <a:ea typeface="Source Han Serif TW"/>
+                          <a:cs typeface="Source Han Serif TW"/>
+                        </a:rPr>
+                        <a:t>0927 10×20（semantic tie-break）</a:t>
+                      </a:r>
+                    </a:p>
+                  </a:txBody>
+                  <a:tcPr marL="76200" marR="76200" marT="28575" marB="28575">
+                    <a:solidFill>
+                      <a:srgbClr val="FCF8F5"/>
+                    </a:solidFill>
+                  </a:tcPr>
+                </a:tc>
+                <a:tc>
+                  <a:txBody>
+                    <a:bodyPr>
+                      <a:noAutofit/>
+                    </a:bodyPr>
+                    <a:lstStyle/>
+                    <a:p>
+                      <a:r>
+                        <a:rPr sz="1639" b="0">
+                          <a:solidFill>
+                            <a:srgbClr val="423C3B"/>
+                          </a:solidFill>
+                          <a:latin typeface="Source Han Serif TW"/>
+                          <a:ea typeface="Source Han Serif TW"/>
+                          <a:cs typeface="Source Han Serif TW"/>
+                        </a:rPr>
+                        <a:t>20 × 10</a:t>
+                      </a:r>
+                    </a:p>
+                  </a:txBody>
+                  <a:tcPr marL="76200" marR="76200" marT="28575" marB="28575">
+                    <a:solidFill>
+                      <a:srgbClr val="FCF8F5"/>
+                    </a:solidFill>
+                  </a:tcPr>
+                </a:tc>
+                <a:tc>
+                  <a:txBody>
+                    <a:bodyPr>
+                      <a:noAutofit/>
+                    </a:bodyPr>
+                    <a:lstStyle/>
+                    <a:p>
+                      <a:r>
+                        <a:rPr sz="1639" b="0">
                           <a:solidFill>
                             <a:srgbClr val="423C3B"/>
                           </a:solidFill>
@@ -16331,325 +16603,33 @@
                     <a:lstStyle/>
                     <a:p>
                       <a:r>
-                        <a:rPr sz="1725" b="0">
-                          <a:solidFill>
-                            <a:srgbClr val="423C3B"/>
-                          </a:solidFill>
-                          <a:latin typeface="Source Han Serif TW"/>
-                          <a:ea typeface="Source Han Serif TW"/>
-                          <a:cs typeface="Source Han Serif TW"/>
-                        </a:rPr>
-                        <a:t>197 / 392 / 11 / 0</a:t>
-                      </a:r>
-                    </a:p>
-                  </a:txBody>
-                  <a:tcPr marL="76200" marR="76200" marT="28575" marB="28575">
-                    <a:solidFill>
-                      <a:srgbClr val="FCF8F5"/>
-                    </a:solidFill>
-                  </a:tcPr>
-                </a:tc>
-              </a:tr>
-              <a:tr h="748903">
-                <a:tc>
-                  <a:txBody>
-                    <a:bodyPr>
-                      <a:noAutofit/>
-                    </a:bodyPr>
-                    <a:lstStyle/>
-                    <a:p>
-                      <a:r>
-                        <a:rPr sz="1725" b="0">
-                          <a:solidFill>
-                            <a:srgbClr val="423C3B"/>
-                          </a:solidFill>
-                          <a:latin typeface="Source Han Serif TW"/>
-                          <a:ea typeface="Source Han Serif TW"/>
-                          <a:cs typeface="Source Han Serif TW"/>
-                        </a:rPr>
-                        <a:t>0926 10×10 semantic tie-break</a:t>
-                      </a:r>
-                    </a:p>
-                  </a:txBody>
-                  <a:tcPr marL="76200" marR="76200" marT="28575" marB="28575">
-                    <a:solidFill>
-                      <a:srgbClr val="FCF8F5"/>
-                    </a:solidFill>
-                  </a:tcPr>
-                </a:tc>
-                <a:tc>
-                  <a:txBody>
-                    <a:bodyPr>
-                      <a:noAutofit/>
-                    </a:bodyPr>
-                    <a:lstStyle/>
-                    <a:p>
-                      <a:r>
-                        <a:rPr sz="1725" b="0">
-                          <a:solidFill>
-                            <a:srgbClr val="423C3B"/>
-                          </a:solidFill>
-                          <a:latin typeface="Source Han Serif TW"/>
-                          <a:ea typeface="Source Han Serif TW"/>
-                          <a:cs typeface="Source Han Serif TW"/>
-                        </a:rPr>
-                        <a:t>10 × 10</a:t>
-                      </a:r>
-                    </a:p>
-                  </a:txBody>
-                  <a:tcPr marL="76200" marR="76200" marT="28575" marB="28575">
-                    <a:solidFill>
-                      <a:srgbClr val="FCF8F5"/>
-                    </a:solidFill>
-                  </a:tcPr>
-                </a:tc>
-                <a:tc>
-                  <a:txBody>
-                    <a:bodyPr>
-                      <a:noAutofit/>
-                    </a:bodyPr>
-                    <a:lstStyle/>
-                    <a:p>
-                      <a:r>
-                        <a:rPr sz="1725" b="0">
-                          <a:solidFill>
-                            <a:srgbClr val="423C3B"/>
-                          </a:solidFill>
-                          <a:latin typeface="Source Han Serif TW"/>
-                          <a:ea typeface="Source Han Serif TW"/>
-                          <a:cs typeface="Source Han Serif TW"/>
-                        </a:rPr>
-                        <a:t>100</a:t>
-                      </a:r>
-                    </a:p>
-                  </a:txBody>
-                  <a:tcPr marL="76200" marR="76200" marT="28575" marB="28575">
-                    <a:solidFill>
-                      <a:srgbClr val="FCF8F5"/>
-                    </a:solidFill>
-                  </a:tcPr>
-                </a:tc>
-                <a:tc>
-                  <a:txBody>
-                    <a:bodyPr>
-                      <a:noAutofit/>
-                    </a:bodyPr>
-                    <a:lstStyle/>
-                    <a:p>
-                      <a:r>
-                        <a:rPr sz="1725" b="0">
-                          <a:solidFill>
-                            <a:srgbClr val="423C3B"/>
-                          </a:solidFill>
-                          <a:latin typeface="Source Han Serif TW"/>
-                          <a:ea typeface="Source Han Serif TW"/>
-                          <a:cs typeface="Source Han Serif TW"/>
-                        </a:rPr>
-                        <a:t>257 / 321 / 22 / 0</a:t>
-                      </a:r>
-                    </a:p>
-                  </a:txBody>
-                  <a:tcPr marL="76200" marR="76200" marT="28575" marB="28575">
-                    <a:solidFill>
-                      <a:srgbClr val="FCF8F5"/>
-                    </a:solidFill>
-                  </a:tcPr>
-                </a:tc>
-              </a:tr>
-              <a:tr h="748903">
-                <a:tc>
-                  <a:txBody>
-                    <a:bodyPr>
-                      <a:noAutofit/>
-                    </a:bodyPr>
-                    <a:lstStyle/>
-                    <a:p>
-                      <a:r>
-                        <a:rPr sz="1725" b="0">
-                          <a:solidFill>
-                            <a:srgbClr val="423C3B"/>
-                          </a:solidFill>
-                          <a:latin typeface="Source Han Serif TW"/>
-                          <a:ea typeface="Source Han Serif TW"/>
-                          <a:cs typeface="Source Han Serif TW"/>
-                        </a:rPr>
-                        <a:t>0926 5×20 semantic tie-break</a:t>
-                      </a:r>
-                    </a:p>
-                  </a:txBody>
-                  <a:tcPr marL="76200" marR="76200" marT="28575" marB="28575">
-                    <a:solidFill>
-                      <a:srgbClr val="FCF8F5"/>
-                    </a:solidFill>
-                  </a:tcPr>
-                </a:tc>
-                <a:tc>
-                  <a:txBody>
-                    <a:bodyPr>
-                      <a:noAutofit/>
-                    </a:bodyPr>
-                    <a:lstStyle/>
-                    <a:p>
-                      <a:r>
-                        <a:rPr sz="1725" b="0">
-                          <a:solidFill>
-                            <a:srgbClr val="423C3B"/>
-                          </a:solidFill>
-                          <a:latin typeface="Source Han Serif TW"/>
-                          <a:ea typeface="Source Han Serif TW"/>
-                          <a:cs typeface="Source Han Serif TW"/>
-                        </a:rPr>
-                        <a:t>20 × 5</a:t>
-                      </a:r>
-                    </a:p>
-                  </a:txBody>
-                  <a:tcPr marL="76200" marR="76200" marT="28575" marB="28575">
-                    <a:solidFill>
-                      <a:srgbClr val="FCF8F5"/>
-                    </a:solidFill>
-                  </a:tcPr>
-                </a:tc>
-                <a:tc>
-                  <a:txBody>
-                    <a:bodyPr>
-                      <a:noAutofit/>
-                    </a:bodyPr>
-                    <a:lstStyle/>
-                    <a:p>
-                      <a:r>
-                        <a:rPr sz="1725" b="0">
-                          <a:solidFill>
-                            <a:srgbClr val="423C3B"/>
-                          </a:solidFill>
-                          <a:latin typeface="Source Han Serif TW"/>
-                          <a:ea typeface="Source Han Serif TW"/>
-                          <a:cs typeface="Source Han Serif TW"/>
-                        </a:rPr>
-                        <a:t>100</a:t>
-                      </a:r>
-                    </a:p>
-                  </a:txBody>
-                  <a:tcPr marL="76200" marR="76200" marT="28575" marB="28575">
-                    <a:solidFill>
-                      <a:srgbClr val="FCF8F5"/>
-                    </a:solidFill>
-                  </a:tcPr>
-                </a:tc>
-                <a:tc>
-                  <a:txBody>
-                    <a:bodyPr>
-                      <a:noAutofit/>
-                    </a:bodyPr>
-                    <a:lstStyle/>
-                    <a:p>
-                      <a:r>
-                        <a:rPr sz="1725" b="0">
-                          <a:solidFill>
-                            <a:srgbClr val="423C3B"/>
-                          </a:solidFill>
-                          <a:latin typeface="Source Han Serif TW"/>
-                          <a:ea typeface="Source Han Serif TW"/>
-                          <a:cs typeface="Source Han Serif TW"/>
-                        </a:rPr>
-                        <a:t>0 / 388 / 212 / 0</a:t>
-                      </a:r>
-                    </a:p>
-                  </a:txBody>
-                  <a:tcPr marL="76200" marR="76200" marT="28575" marB="28575">
-                    <a:solidFill>
-                      <a:srgbClr val="FCF8F5"/>
-                    </a:solidFill>
-                  </a:tcPr>
-                </a:tc>
-              </a:tr>
-              <a:tr h="748903">
-                <a:tc>
-                  <a:txBody>
-                    <a:bodyPr>
-                      <a:noAutofit/>
-                    </a:bodyPr>
-                    <a:lstStyle/>
-                    <a:p>
-                      <a:r>
-                        <a:rPr sz="1725" b="0">
-                          <a:solidFill>
-                            <a:srgbClr val="423C3B"/>
-                          </a:solidFill>
-                          <a:latin typeface="Source Han Serif TW"/>
-                          <a:ea typeface="Source Han Serif TW"/>
-                          <a:cs typeface="Source Han Serif TW"/>
-                        </a:rPr>
-                        <a:t>0927 10×20 semantic tie-break</a:t>
-                      </a:r>
-                    </a:p>
-                  </a:txBody>
-                  <a:tcPr marL="76200" marR="76200" marT="28575" marB="28575">
-                    <a:solidFill>
-                      <a:srgbClr val="FCF8F5"/>
-                    </a:solidFill>
-                  </a:tcPr>
-                </a:tc>
-                <a:tc>
-                  <a:txBody>
-                    <a:bodyPr>
-                      <a:noAutofit/>
-                    </a:bodyPr>
-                    <a:lstStyle/>
-                    <a:p>
-                      <a:r>
-                        <a:rPr sz="1725" b="0">
-                          <a:solidFill>
-                            <a:srgbClr val="423C3B"/>
-                          </a:solidFill>
-                          <a:latin typeface="Source Han Serif TW"/>
-                          <a:ea typeface="Source Han Serif TW"/>
-                          <a:cs typeface="Source Han Serif TW"/>
-                        </a:rPr>
-                        <a:t>20 × 10</a:t>
-                      </a:r>
-                    </a:p>
-                  </a:txBody>
-                  <a:tcPr marL="76200" marR="76200" marT="28575" marB="28575">
-                    <a:solidFill>
-                      <a:srgbClr val="FCF8F5"/>
-                    </a:solidFill>
-                  </a:tcPr>
-                </a:tc>
-                <a:tc>
-                  <a:txBody>
-                    <a:bodyPr>
-                      <a:noAutofit/>
-                    </a:bodyPr>
-                    <a:lstStyle/>
-                    <a:p>
-                      <a:r>
-                        <a:rPr sz="1725" b="0">
-                          <a:solidFill>
-                            <a:srgbClr val="423C3B"/>
-                          </a:solidFill>
-                          <a:latin typeface="Source Han Serif TW"/>
-                          <a:ea typeface="Source Han Serif TW"/>
-                          <a:cs typeface="Source Han Serif TW"/>
-                        </a:rPr>
-                        <a:t>200</a:t>
-                      </a:r>
-                    </a:p>
-                  </a:txBody>
-                  <a:tcPr marL="76200" marR="76200" marT="28575" marB="28575">
-                    <a:solidFill>
-                      <a:srgbClr val="FCF8F5"/>
-                    </a:solidFill>
-                  </a:tcPr>
-                </a:tc>
-                <a:tc>
-                  <a:txBody>
-                    <a:bodyPr>
-                      <a:noAutofit/>
-                    </a:bodyPr>
-                    <a:lstStyle/>
-                    <a:p>
-                      <a:r>
-                        <a:rPr sz="1725" b="0">
+                        <a:rPr sz="1639" b="0">
+                          <a:solidFill>
+                            <a:srgbClr val="423C3B"/>
+                          </a:solidFill>
+                          <a:latin typeface="Source Han Serif TW"/>
+                          <a:ea typeface="Source Han Serif TW"/>
+                          <a:cs typeface="Source Han Serif TW"/>
+                        </a:rPr>
+                        <a:t>1.263534</a:t>
+                      </a:r>
+                    </a:p>
+                  </a:txBody>
+                  <a:tcPr marL="76200" marR="76200" marT="28575" marB="28575">
+                    <a:solidFill>
+                      <a:srgbClr val="FCF8F5"/>
+                    </a:solidFill>
+                  </a:tcPr>
+                </a:tc>
+                <a:tc>
+                  <a:txBody>
+                    <a:bodyPr>
+                      <a:noAutofit/>
+                    </a:bodyPr>
+                    <a:lstStyle/>
+                    <a:p>
+                      <a:r>
+                        <a:rPr sz="1639" b="0">
                           <a:solidFill>
                             <a:srgbClr val="423C3B"/>
                           </a:solidFill>
@@ -16677,7 +16657,7 @@
           <p:cNvPr id="6" name="">
             <a:extLst>
               <a:ext uri="{FF2B5EF4-FFF2-40B4-BE49-F238E27FC236}">
-                <ns2:creationId id="{507CD5B8-572F-4595-AEF5-E9A9BE6C70F4}"/>
+                <ns2:creationId id="{DC0E36C7-CD3F-485F-9EF6-89E0FC3D092E}"/>
               </a:ext>
             </a:extLst>
           </p:cNvPr>
@@ -16688,8 +16668,8 @@
         </p:nvSpPr>
         <p:spPr>
           <a:xfrm>
-            <a:off x="1451282" y="6478191"/>
-            <a:ext cx="12842984" cy="462558"/>
+            <a:off x="1451282" y="6346031"/>
+            <a:ext cx="12842984" cy="605730"/>
           </a:xfrm>
           <a:prstGeom prst="rect">
             <a:avLst/>
@@ -16706,7 +16686,7 @@
           <a:lstStyle/>
           <a:p>
             <a:pPr>
-              <a:defRPr sz="1725" b="0">
+              <a:defRPr sz="1639" b="0">
                 <a:solidFill>
                   <a:srgbClr val="423C3B"/>
                 </a:solidFill>
@@ -16716,7 +16696,7 @@
               </a:defRPr>
             </a:pPr>
             <a:r>
-              <a:rPr sz="1725" b="0">
+              <a:rPr sz="1639" b="0">
                 <a:solidFill>
                   <a:srgbClr val="423C3B"/>
                 </a:solidFill>
@@ -16724,14 +16704,71 @@
                 <a:ea typeface="Source Han Serif TW"/>
                 <a:cs typeface="Source Han Serif TW"/>
               </a:rPr>
-              <a:t>四組都完成 600 場 final test，Integration 7/7，match errors = 0。10×10 的 final test wins 最高：257/600（42.83%）。</a:t>
+              <a:t>三組 final test 都完成 600 場、Integration 7/7、match errors = 0。¹ Search GP 是各 run 當時 self-play snapshot 下的分數；snapshot 不同，分數不可跨 run 當作同尺度排名。</a:t>
             </a:r>
           </a:p>
         </p:txBody>
       </p:sp>
       <p:sp>
         <p:nvSpPr>
-          <p:cNvPr id="14" name="Slide Number"/>
+          <p:cNvPr id="7" name="">
+            <a:extLst>
+              <a:ext uri="{FF2B5EF4-FFF2-40B4-BE49-F238E27FC236}">
+                <ns2:creationId id="{297D0E50-CD62-4170-B643-5752B91C79FC}"/>
+              </a:ext>
+            </a:extLst>
+          </p:cNvPr>
+          <p:cNvSpPr>
+            <a:spLocks noGrp="1"/>
+          </p:cNvSpPr>
+          <p:nvPr/>
+        </p:nvSpPr>
+        <p:spPr>
+          <a:xfrm>
+            <a:off x="1428750" y="7227094"/>
+            <a:ext cx="12955642" cy="572691"/>
+          </a:xfrm>
+          <a:prstGeom prst="rect">
+            <a:avLst/>
+          </a:prstGeom>
+          <a:noFill/>
+          <a:ln w="0">
+            <a:noFill/>
+          </a:ln>
+        </p:spPr>
+        <p:txBody>
+          <a:bodyPr>
+            <a:noAutofit/>
+          </a:bodyPr>
+          <a:lstStyle/>
+          <a:p>
+            <a:pPr>
+              <a:defRPr sz="2070" b="1">
+                <a:solidFill>
+                  <a:srgbClr val="47171C"/>
+                </a:solidFill>
+                <a:latin typeface="Source Han Serif TW"/>
+                <a:ea typeface="Source Han Serif TW"/>
+                <a:cs typeface="Source Han Serif TW"/>
+              </a:defRPr>
+            </a:pPr>
+            <a:r>
+              <a:rPr sz="2070" b="1">
+                <a:solidFill>
+                  <a:srgbClr val="47171C"/>
+                </a:solidFill>
+                <a:latin typeface="Source Han Serif TW"/>
+                <a:ea typeface="Source Han Serif TW"/>
+                <a:cs typeface="Source Han Serif TW"/>
+              </a:rPr>
+              <a:t>同一張表並列 self-play selection 訊號與固定對手實戰結果</a:t>
+            </a:r>
+          </a:p>
+        </p:txBody>
+      </p:sp>
+      <p:sp>
+        <p:nvSpPr>
+          <p:cNvPr id="15" name="Slide Number"/>
           <p:cNvSpPr>
             <a:spLocks noGrp="1"/>
           </p:cNvSpPr>
@@ -16769,7 +16806,7 @@
                 <a:cs typeface="Source Han Serif TW"/>
               </a:defRPr>
             </a:pPr>
-            <a:fld id="{E74156BE-B9BF-4CFC-A6A0-49BEF07B316D}" type="slidenum">
+            <a:fld id="{BC40875A-8BCA-4F82-BBC1-89566185C323}" type="slidenum">
               <a:rPr sz="1650" b="0">
                 <a:solidFill>
                   <a:srgbClr val="CF8792"/>
@@ -16786,7 +16823,7 @@
     </p:spTree>
     <p:extLst>
       <p:ext uri="{BB962C8B-B14F-4D97-AF65-F5344CB8AC3E}">
-        <ns3:creationId val="818379686"/>
+        <ns3:creationId val="638170892"/>
       </p:ext>
     </p:extLst>
   </p:cSld>
@@ -16810,7 +16847,7 @@
           <p:cNvPr id="13" name="EAGLE_0">
             <a:extLst>
               <a:ext uri="{FF2B5EF4-FFF2-40B4-BE49-F238E27FC236}">
-                <ns2:creationId id="{8B49A6E6-DDC2-4BF3-BB75-BBA3E4E92CB7}"/>
+                <ns2:creationId id="{BBD4F1B4-1EF2-4658-88D5-C25CB2B59D9D}"/>
               </a:ext>
             </a:extLst>
           </p:cNvPr>
@@ -16863,7 +16900,7 @@
           <p:cNvPr id="14" name="EAGLE_1">
             <a:extLst>
               <a:ext uri="{FF2B5EF4-FFF2-40B4-BE49-F238E27FC236}">
-                <ns2:creationId id="{6E2FD095-3EB7-4BCE-AFCB-C15E399D1388}"/>
+                <ns2:creationId id="{45CBFB38-9EC2-4840-B4CE-D27045CE0849}"/>
               </a:ext>
             </a:extLst>
           </p:cNvPr>
@@ -16923,7 +16960,7 @@
         </p:xfrm>
         <a:graphic>
           <a:graphicData uri="http://schemas.openxmlformats.org/drawingml/2006/chart">
-            <ns3:chart r:id="Rcfba2d4628e04401"/>
+            <ns3:chart r:id="R9dabe66619de4eca"/>
           </a:graphicData>
         </a:graphic>
       </p:graphicFrame>
@@ -16932,7 +16969,7 @@
           <p:cNvPr id="6" name="">
             <a:extLst>
               <a:ext uri="{FF2B5EF4-FFF2-40B4-BE49-F238E27FC236}">
-                <ns2:creationId id="{19D96649-F137-4CE9-BEF7-750744825361}"/>
+                <ns2:creationId id="{C65F7826-47E0-43C8-9F17-D6E2E3D99452}"/>
               </a:ext>
             </a:extLst>
           </p:cNvPr>
@@ -16989,7 +17026,7 @@
           <p:cNvPr id="7" name="">
             <a:extLst>
               <a:ext uri="{FF2B5EF4-FFF2-40B4-BE49-F238E27FC236}">
-                <ns2:creationId id="{CEB71915-5D28-4120-B994-C183249B4158}"/>
+                <ns2:creationId id="{23B062EA-8FF5-4B9D-A630-6CF736E2F1D1}"/>
               </a:ext>
             </a:extLst>
           </p:cNvPr>
@@ -17081,7 +17118,7 @@
                 <a:cs typeface="Source Han Serif TW"/>
               </a:defRPr>
             </a:pPr>
-            <a:fld id="{3655BF45-5FA7-4540-8610-E78BD847B9BE}" type="slidenum">
+            <a:fld id="{9CB91AE4-501E-4F39-BAAA-8CC2214D6A53}" type="slidenum">
               <a:rPr sz="1650" b="0">
                 <a:solidFill>
                   <a:srgbClr val="CF8792"/>
@@ -17098,7 +17135,7 @@
     </p:spTree>
     <p:extLst>
       <p:ext uri="{BB962C8B-B14F-4D97-AF65-F5344CB8AC3E}">
-        <ns5:creationId val="264047156"/>
+        <ns5:creationId val="1127269012"/>
       </p:ext>
     </p:extLst>
   </p:cSld>

</xml_diff>

<commit_message>
docs: add September 29 run diagnostics to deck
</commit_message>
<xml_diff>
--- a/Meeting/20261001_self_play/20261001_verified.pptx
+++ b/Meeting/20261001_self_play/20261001_verified.pptx
@@ -26,6 +26,8 @@
     <p:sldId id="271" r:id="rIdReportSlide16"/>
     <p:sldId id="272" r:id="rIdReportSlide17"/>
     <p:sldId id="273" r:id="rIdReportSlide18"/>
+    <p:sldId id="274" r:id="rIdReportSlide19"/>
+    <p:sldId id="275" r:id="rIdReportSlide20"/>
   </p:sldIdLst>
   <p:sldSz cx="15925800" cy="8963025"/>
   <p:notesSz cx="6858000" cy="9144000"/>
@@ -418,7 +420,7 @@
           </a:p>
           <a:p xmlns:a="http://schemas.openxmlformats.org/drawingml/2006/main">
             <a:r>
-              <a:t>Notion 0926 Self-play 10×10 與 5×20 pages；Meeting/20261001/analysis_md/20260928_self_play_10x10_vs_5x20.md.</a:t>
+              <a:t>Notion EAGLE 實驗整理｜2026-09-29：https://app.notion.com/p/3eac9b9735d981d08651cdb192122d79；run 20260928_115653_334420.</a:t>
             </a:r>
           </a:p>
         </p:txBody>
@@ -493,7 +495,7 @@
           </a:p>
           <a:p xmlns:a="http://schemas.openxmlformats.org/drawingml/2006/main">
             <a:r>
-              <a:t>Notion 0927 page；configs/experiments/0929/README.md.</a:t>
+              <a:t>Meeting/20261001/analysis_md/20260928_self_play_10x10_vs_5x20.md；Notion 0926 pages.</a:t>
             </a:r>
           </a:p>
         </p:txBody>
@@ -568,7 +570,7 @@
           </a:p>
           <a:p xmlns:a="http://schemas.openxmlformats.org/drawingml/2006/main">
             <a:r>
-              <a:t>Meeting/20261001/analysis_md/20260926_self_play_comparison.md；Notion 0927 10×20 page；configs/experiments/0929/fixed_opponent_10x20_control.yaml.</a:t>
+              <a:t>Notion 0926 Self-play 10×10 與 5×20 pages；Meeting/20261001/analysis_md/20260928_self_play_10x10_vs_5x20.md.</a:t>
             </a:r>
           </a:p>
         </p:txBody>
@@ -643,7 +645,7 @@
           </a:p>
           <a:p xmlns:a="http://schemas.openxmlformats.org/drawingml/2006/main">
             <a:r>
-              <a:t>Meeting/20261001/analysis_md/20260928_self_play_10x10_vs_5x20.md；Notion 0926 pages.</a:t>
+              <a:t>Notion 0927 page；configs/experiments/0929/README.md.</a:t>
             </a:r>
           </a:p>
         </p:txBody>
@@ -718,7 +720,7 @@
           </a:p>
           <a:p xmlns:a="http://schemas.openxmlformats.org/drawingml/2006/main">
             <a:r>
-              <a:t>Notion 0926–0927 pages；Meeting/20261001/analysis_md/20260928_self_play_10x10_vs_5x20.md.</a:t>
+              <a:t>Meeting/20261001/analysis_md/20260926_self_play_comparison.md；Notion 0927 10×20 page；configs/experiments/0929/fixed_opponent_10x20_control.yaml.</a:t>
             </a:r>
           </a:p>
         </p:txBody>
@@ -793,7 +795,7 @@
           </a:p>
           <a:p xmlns:a="http://schemas.openxmlformats.org/drawingml/2006/main">
             <a:r>
-              <a:t>Notion 0926–0927 Self-play runs.</a:t>
+              <a:t>Meeting/20261001/analysis_md/20260928_self_play_10x10_vs_5x20.md；Notion 0926 pages.</a:t>
             </a:r>
           </a:p>
         </p:txBody>
@@ -868,7 +870,7 @@
           </a:p>
           <a:p xmlns:a="http://schemas.openxmlformats.org/drawingml/2006/main">
             <a:r>
-              <a:t>configs/experiments/0929/README.md; self_play_5x40_semantic_tiebreak.yaml.</a:t>
+              <a:t>Notion 0926–0927 pages；Meeting/20261001/analysis_md/20260928_self_play_10x10_vs_5x20.md.</a:t>
             </a:r>
           </a:p>
         </p:txBody>
@@ -943,7 +945,7 @@
           </a:p>
           <a:p xmlns:a="http://schemas.openxmlformats.org/drawingml/2006/main">
             <a:r>
-              <a:t>configs/experiments/0929/self_play_5x40_semantic_tiebreak.yaml；對照 configs/experiments/0926_self_play_sent/self_play_10x20.yaml.</a:t>
+              <a:t>Notion 0926–0927 Self-play runs.</a:t>
             </a:r>
           </a:p>
         </p:txBody>
@@ -1018,7 +1020,82 @@
           </a:p>
           <a:p xmlns:a="http://schemas.openxmlformats.org/drawingml/2006/main">
             <a:r>
-              <a:t>Notion database MicroRTS EAGLE; Meeting/20261001/README.md and analysis_md/*.md.</a:t>
+              <a:t>configs/experiments/0929/README.md; self_play_5x40_semantic_tiebreak.yaml.</a:t>
+            </a:r>
+          </a:p>
+        </p:txBody>
+      </p:sp>
+      <p:sp>
+        <p:nvSpPr>
+          <p:cNvPr id="4" name="Slide Number Placeholder 3"/>
+          <p:cNvSpPr>
+            <a:spLocks xmlns:a="http://schemas.openxmlformats.org/drawingml/2006/main" noGrp="1"/>
+          </p:cNvSpPr>
+          <p:nvPr>
+            <p:ph type="sldNum" idx="5"/>
+          </p:nvPr>
+        </p:nvSpPr>
+        <p:spPr/>
+        <p:txBody>
+          <a:bodyPr xmlns:a="http://schemas.openxmlformats.org/drawingml/2006/main"/>
+          <a:lstStyle xmlns:a="http://schemas.openxmlformats.org/drawingml/2006/main"/>
+          <a:p xmlns:a="http://schemas.openxmlformats.org/drawingml/2006/main"/>
+        </p:txBody>
+      </p:sp>
+    </p:spTree>
+  </p:cSld>
+  <p:clrMapOvr>
+    <a:masterClrMapping xmlns:a="http://schemas.openxmlformats.org/drawingml/2006/main"/>
+  </p:clrMapOvr>
+</p:notes>
+</file>
+
+<file path=ppt/notesSlides/notesSlide19.xml><?xml version="1.0" encoding="utf-8"?>
+<p:notes xmlns:p="http://schemas.openxmlformats.org/presentationml/2006/main">
+  <p:cSld>
+    <p:spTree>
+      <p:nvGrpSpPr>
+        <p:cNvPr id="1" name=""/>
+        <p:cNvGrpSpPr/>
+        <p:nvPr/>
+      </p:nvGrpSpPr>
+      <p:grpSpPr>
+        <a:xfrm xmlns:a="http://schemas.openxmlformats.org/drawingml/2006/main"/>
+      </p:grpSpPr>
+      <p:sp>
+        <p:nvSpPr>
+          <p:cNvPr id="2" name="Slide Image Placeholder 1"/>
+          <p:cNvSpPr>
+            <a:spLocks xmlns:a="http://schemas.openxmlformats.org/drawingml/2006/main" noGrp="1"/>
+          </p:cNvSpPr>
+          <p:nvPr>
+            <p:ph type="sldImg" idx="0"/>
+          </p:nvPr>
+        </p:nvSpPr>
+        <p:spPr/>
+      </p:sp>
+      <p:sp>
+        <p:nvSpPr>
+          <p:cNvPr id="3" name="Notes Placeholder 2"/>
+          <p:cNvSpPr>
+            <a:spLocks xmlns:a="http://schemas.openxmlformats.org/drawingml/2006/main" noGrp="1"/>
+          </p:cNvSpPr>
+          <p:nvPr>
+            <p:ph type="body" idx="1"/>
+          </p:nvPr>
+        </p:nvSpPr>
+        <p:spPr/>
+        <p:txBody>
+          <a:bodyPr xmlns:a="http://schemas.openxmlformats.org/drawingml/2006/main"/>
+          <a:lstStyle xmlns:a="http://schemas.openxmlformats.org/drawingml/2006/main"/>
+          <a:p xmlns:a="http://schemas.openxmlformats.org/drawingml/2006/main">
+            <a:r>
+              <a:t>資料截點：2026-09-29</a:t>
+            </a:r>
+          </a:p>
+          <a:p xmlns:a="http://schemas.openxmlformats.org/drawingml/2006/main">
+            <a:r>
+              <a:t>configs/experiments/0929/self_play_5x40_semantic_tiebreak.yaml；對照 configs/experiments/0926_self_play_sent/self_play_10x20.yaml.</a:t>
             </a:r>
           </a:p>
         </p:txBody>
@@ -1123,6 +1200,81 @@
 </p:notes>
 </file>
 
+<file path=ppt/notesSlides/notesSlide20.xml><?xml version="1.0" encoding="utf-8"?>
+<p:notes xmlns:p="http://schemas.openxmlformats.org/presentationml/2006/main">
+  <p:cSld>
+    <p:spTree>
+      <p:nvGrpSpPr>
+        <p:cNvPr id="1" name=""/>
+        <p:cNvGrpSpPr/>
+        <p:nvPr/>
+      </p:nvGrpSpPr>
+      <p:grpSpPr>
+        <a:xfrm xmlns:a="http://schemas.openxmlformats.org/drawingml/2006/main"/>
+      </p:grpSpPr>
+      <p:sp>
+        <p:nvSpPr>
+          <p:cNvPr id="2" name="Slide Image Placeholder 1"/>
+          <p:cNvSpPr>
+            <a:spLocks xmlns:a="http://schemas.openxmlformats.org/drawingml/2006/main" noGrp="1"/>
+          </p:cNvSpPr>
+          <p:nvPr>
+            <p:ph type="sldImg" idx="0"/>
+          </p:nvPr>
+        </p:nvSpPr>
+        <p:spPr/>
+      </p:sp>
+      <p:sp>
+        <p:nvSpPr>
+          <p:cNvPr id="3" name="Notes Placeholder 2"/>
+          <p:cNvSpPr>
+            <a:spLocks xmlns:a="http://schemas.openxmlformats.org/drawingml/2006/main" noGrp="1"/>
+          </p:cNvSpPr>
+          <p:nvPr>
+            <p:ph type="body" idx="1"/>
+          </p:nvPr>
+        </p:nvSpPr>
+        <p:spPr/>
+        <p:txBody>
+          <a:bodyPr xmlns:a="http://schemas.openxmlformats.org/drawingml/2006/main"/>
+          <a:lstStyle xmlns:a="http://schemas.openxmlformats.org/drawingml/2006/main"/>
+          <a:p xmlns:a="http://schemas.openxmlformats.org/drawingml/2006/main">
+            <a:r>
+              <a:t>資料截點：2026-09-29</a:t>
+            </a:r>
+          </a:p>
+          <a:p xmlns:a="http://schemas.openxmlformats.org/drawingml/2006/main">
+            <a:r>
+              <a:t>Notion database MicroRTS EAGLE; Meeting/20261001/README.md and analysis_md/*.md.</a:t>
+            </a:r>
+          </a:p>
+        </p:txBody>
+      </p:sp>
+      <p:sp>
+        <p:nvSpPr>
+          <p:cNvPr id="4" name="Slide Number Placeholder 3"/>
+          <p:cNvSpPr>
+            <a:spLocks xmlns:a="http://schemas.openxmlformats.org/drawingml/2006/main" noGrp="1"/>
+          </p:cNvSpPr>
+          <p:nvPr>
+            <p:ph type="sldNum" idx="5"/>
+          </p:nvPr>
+        </p:nvSpPr>
+        <p:spPr/>
+        <p:txBody>
+          <a:bodyPr xmlns:a="http://schemas.openxmlformats.org/drawingml/2006/main"/>
+          <a:lstStyle xmlns:a="http://schemas.openxmlformats.org/drawingml/2006/main"/>
+          <a:p xmlns:a="http://schemas.openxmlformats.org/drawingml/2006/main"/>
+        </p:txBody>
+      </p:sp>
+    </p:spTree>
+  </p:cSld>
+  <p:clrMapOvr>
+    <a:masterClrMapping xmlns:a="http://schemas.openxmlformats.org/drawingml/2006/main"/>
+  </p:clrMapOvr>
+</p:notes>
+</file>
+
 <file path=ppt/notesSlides/notesSlide3.xml><?xml version="1.0" encoding="utf-8"?>
 <p:notes xmlns:p="http://schemas.openxmlformats.org/presentationml/2006/main">
   <p:cSld>
@@ -1543,7 +1695,7 @@
           </a:p>
           <a:p xmlns:a="http://schemas.openxmlformats.org/drawingml/2006/main">
             <a:r>
-              <a:t>本地 Meeting/20261001/README.md；Notion 0926 10×10、0926 5×20、0927 10×20 pages.</a:t>
+              <a:t>本地 Meeting/20261001/README.md；Notion 0926 10×10、0926 5×20、0927 10×20 pages；EAGLE 實驗整理 2026-09-29：https://app.notion.com/p/3eac9b9735d981d08651cdb192122d79.</a:t>
             </a:r>
           </a:p>
         </p:txBody>
@@ -1618,7 +1770,7 @@
           </a:p>
           <a:p xmlns:a="http://schemas.openxmlformats.org/drawingml/2006/main">
             <a:r>
-              <a:t>Meeting/20261001/analysis_md/20260928_self_play_10x10_vs_5x20.md；Notion 0926 pages.</a:t>
+              <a:t>Notion EAGLE 實驗整理｜2026-09-29：https://app.notion.com/p/3eac9b9735d981d08651cdb192122d79；configs/experiments/0927/self_play_10x20.yaml.</a:t>
             </a:r>
           </a:p>
         </p:txBody>
@@ -5465,7 +5617,7 @@
           <p:cNvPr id="8" name="EAGLE_0">
             <a:extLst>
               <a:ext uri="{FF2B5EF4-FFF2-40B4-BE49-F238E27FC236}">
-                <ns2:creationId id="{34D8F21E-7DEE-4CC4-A1C9-9C36DE450BCC}"/>
+                <ns2:creationId id="{D987E8C0-4C20-4933-B84B-42119ABCDBD6}"/>
               </a:ext>
             </a:extLst>
           </p:cNvPr>
@@ -5518,7 +5670,7 @@
           <p:cNvPr id="9" name="EAGLE_1">
             <a:extLst>
               <a:ext uri="{FF2B5EF4-FFF2-40B4-BE49-F238E27FC236}">
-                <ns2:creationId id="{18ADD2BF-42E8-48E0-8A2B-6E3E641F8017}"/>
+                <ns2:creationId id="{570531A9-E435-49E5-A182-B61F60A51AE1}"/>
               </a:ext>
             </a:extLst>
           </p:cNvPr>
@@ -5571,7 +5723,7 @@
           <p:cNvPr id="5" name="">
             <a:extLst>
               <a:ext uri="{FF2B5EF4-FFF2-40B4-BE49-F238E27FC236}">
-                <ns2:creationId id="{2EA86DFC-4192-482A-A4DF-AC35F70A39E6}"/>
+                <ns2:creationId id="{8597F8BD-D4CC-4D68-A749-E8F759E69DB6}"/>
               </a:ext>
             </a:extLst>
           </p:cNvPr>
@@ -5628,7 +5780,7 @@
           <p:cNvPr id="6" name="">
             <a:extLst>
               <a:ext uri="{FF2B5EF4-FFF2-40B4-BE49-F238E27FC236}">
-                <ns2:creationId id="{3622F85A-A04F-45E8-9FE3-705EE34132F5}"/>
+                <ns2:creationId id="{02D67923-0521-4B8B-80A5-89E3FF0986DD}"/>
               </a:ext>
             </a:extLst>
           </p:cNvPr>
@@ -5685,7 +5837,7 @@
           <p:cNvPr id="7" name="">
             <a:extLst>
               <a:ext uri="{FF2B5EF4-FFF2-40B4-BE49-F238E27FC236}">
-                <ns2:creationId id="{2FD87997-025A-4177-914A-8D6772CA69FD}"/>
+                <ns2:creationId id="{025AF41E-9656-4761-9223-18A74E2B3061}"/>
               </a:ext>
             </a:extLst>
           </p:cNvPr>
@@ -5777,7 +5929,7 @@
                 <a:cs typeface="Source Han Serif TW"/>
               </a:defRPr>
             </a:pPr>
-            <a:fld id="{1C0A1BA7-4D10-45CE-9C06-6F7FCE73D45F}" type="slidenum">
+            <a:fld id="{7CDBC5AA-15D4-440B-80DD-1902C2DC9B36}" type="slidenum">
               <a:rPr sz="1650" b="0">
                 <a:solidFill>
                   <a:srgbClr val="CF8792"/>
@@ -5794,7 +5946,7 @@
     </p:spTree>
     <p:extLst>
       <p:ext uri="{BB962C8B-B14F-4D97-AF65-F5344CB8AC3E}">
-        <ns3:creationId val="674567947"/>
+        <ns3:creationId val="363733803"/>
       </p:ext>
     </p:extLst>
   </p:cSld>
@@ -5815,10 +5967,966 @@
       </p:grpSpPr>
       <p:sp>
         <p:nvSpPr>
+          <p:cNvPr id="13" name="EAGLE_0">
+            <a:extLst>
+              <a:ext uri="{FF2B5EF4-FFF2-40B4-BE49-F238E27FC236}">
+                <ns2:creationId id="{817282F0-DFBA-42E4-ADCE-0E7EA133FA95}"/>
+              </a:ext>
+            </a:extLst>
+          </p:cNvPr>
+          <p:cNvSpPr>
+            <a:spLocks noGrp="1"/>
+          </p:cNvSpPr>
+          <p:nvPr>
+            <p:ph idx="0"/>
+          </p:nvPr>
+        </p:nvSpPr>
+        <p:spPr>
+          <a:xfrm>
+            <a:off x="2286000" y="438150"/>
+            <a:ext cx="11353800" cy="1047750"/>
+          </a:xfrm>
+        </p:spPr>
+        <p:txBody>
+          <a:bodyPr anchor="ctr">
+            <a:noAutofit/>
+          </a:bodyPr>
+          <a:lstStyle/>
+          <a:p>
+            <a:pPr algn="ctr">
+              <a:defRPr sz="4128" b="1">
+                <a:solidFill>
+                  <a:srgbClr val="47171C"/>
+                </a:solidFill>
+                <a:latin typeface="Source Han Serif TW"/>
+                <a:ea typeface="Source Han Serif TW"/>
+                <a:cs typeface="Source Han Serif TW"/>
+              </a:defRPr>
+              <a:buNone/>
+            </a:pPr>
+            <a:r>
+              <a:rPr sz="4128" b="1">
+                <a:solidFill>
+                  <a:srgbClr val="47171C"/>
+                </a:solidFill>
+                <a:latin typeface="Source Han Serif TW"/>
+                <a:ea typeface="Source Han Serif TW"/>
+                <a:cs typeface="Source Han Serif TW"/>
+              </a:rPr>
+              <a:t>0927 run 診斷：失敗、refresh 與對手結果</a:t>
+            </a:r>
+          </a:p>
+        </p:txBody>
+      </p:sp>
+      <p:sp>
+        <p:nvSpPr>
+          <p:cNvPr id="14" name="EAGLE_1">
+            <a:extLst>
+              <a:ext uri="{FF2B5EF4-FFF2-40B4-BE49-F238E27FC236}">
+                <ns2:creationId id="{847F88FF-32B5-4E40-81CA-637C3B3BF91B}"/>
+              </a:ext>
+            </a:extLst>
+          </p:cNvPr>
+          <p:cNvSpPr>
+            <a:spLocks noGrp="1"/>
+          </p:cNvSpPr>
+          <p:nvPr>
+            <p:ph idx="1"/>
+          </p:nvPr>
+        </p:nvSpPr>
+        <p:spPr>
+          <a:xfrm>
+            <a:off x="2476500" y="1571625"/>
+            <a:ext cx="10972800" cy="457200"/>
+          </a:xfrm>
+        </p:spPr>
+        <p:txBody>
+          <a:bodyPr anchor="ctr">
+            <a:noAutofit/>
+          </a:bodyPr>
+          <a:lstStyle/>
+          <a:p>
+            <a:pPr algn="ctr">
+              <a:defRPr sz="1875" b="0">
+                <a:solidFill>
+                  <a:srgbClr val="423C3B"/>
+                </a:solidFill>
+                <a:latin typeface="Source Han Serif TW"/>
+                <a:ea typeface="Source Han Serif TW"/>
+                <a:cs typeface="Source Han Serif TW"/>
+              </a:defRPr>
+              <a:buNone/>
+            </a:pPr>
+            <a:r>
+              <a:rPr sz="1875" b="0">
+                <a:solidFill>
+                  <a:srgbClr val="423C3B"/>
+                </a:solidFill>
+                <a:latin typeface="Source Han Serif TW"/>
+                <a:ea typeface="Source Han Serif TW"/>
+                <a:cs typeface="Source Han Serif TW"/>
+              </a:rPr>
+              <a:t>600 場 fixed-roster final test：0 勝、444 敗、156 和；Integration 7/7，match errors = 0</a:t>
+            </a:r>
+          </a:p>
+        </p:txBody>
+      </p:sp>
+      <p:graphicFrame>
+        <p:nvGraphicFramePr>
+          <p:cNvPr id="12" name=""/>
+          <p:cNvGraphicFramePr/>
+          <p:nvPr/>
+        </p:nvGraphicFramePr>
+        <p:xfrm>
+          <a:off x="1428750" y="2436316"/>
+          <a:ext cx="13068300" cy="3854648"/>
+        </p:xfrm>
+        <a:graphic>
+          <a:graphicData uri="http://schemas.openxmlformats.org/drawingml/2006/table">
+            <a:tbl>
+              <a:tblPr firstRow="1" bandRow="0">
+                <a:tableStyleId>{8497E131-5584-4FF0-9A17-202609170001}</a:tableStyleId>
+              </a:tblPr>
+              <a:tblGrid>
+                <a:gridCol w="3717706"/>
+                <a:gridCol w="9350594"/>
+              </a:tblGrid>
+              <a:tr h="642441">
+                <a:tc>
+                  <a:txBody>
+                    <a:bodyPr>
+                      <a:noAutofit/>
+                    </a:bodyPr>
+                    <a:lstStyle/>
+                    <a:p>
+                      <a:r>
+                        <a:rPr sz="1639" b="1">
+                          <a:solidFill>
+                            <a:srgbClr val="423C3B"/>
+                          </a:solidFill>
+                          <a:latin typeface="Source Han Serif TW"/>
+                          <a:ea typeface="Source Han Serif TW"/>
+                          <a:cs typeface="Source Han Serif TW"/>
+                        </a:rPr>
+                        <a:t>診斷面向</a:t>
+                      </a:r>
+                    </a:p>
+                  </a:txBody>
+                  <a:tcPr marL="76200" marR="76200" marT="28575" marB="28575">
+                    <a:solidFill>
+                      <a:srgbClr val="DEB4BA"/>
+                    </a:solidFill>
+                  </a:tcPr>
+                </a:tc>
+                <a:tc>
+                  <a:txBody>
+                    <a:bodyPr>
+                      <a:noAutofit/>
+                    </a:bodyPr>
+                    <a:lstStyle/>
+                    <a:p>
+                      <a:r>
+                        <a:rPr sz="1639" b="1">
+                          <a:solidFill>
+                            <a:srgbClr val="423C3B"/>
+                          </a:solidFill>
+                          <a:latin typeface="Source Han Serif TW"/>
+                          <a:ea typeface="Source Han Serif TW"/>
+                          <a:cs typeface="Source Han Serif TW"/>
+                        </a:rPr>
+                        <a:t>結果</a:t>
+                      </a:r>
+                    </a:p>
+                  </a:txBody>
+                  <a:tcPr marL="76200" marR="76200" marT="28575" marB="28575">
+                    <a:solidFill>
+                      <a:srgbClr val="DEB4BA"/>
+                    </a:solidFill>
+                  </a:tcPr>
+                </a:tc>
+              </a:tr>
+              <a:tr h="642441">
+                <a:tc>
+                  <a:txBody>
+                    <a:bodyPr>
+                      <a:noAutofit/>
+                    </a:bodyPr>
+                    <a:lstStyle/>
+                    <a:p>
+                      <a:r>
+                        <a:rPr sz="1639" b="0">
+                          <a:solidFill>
+                            <a:srgbClr val="423C3B"/>
+                          </a:solidFill>
+                          <a:latin typeface="Source Han Serif TW"/>
+                          <a:ea typeface="Source Han Serif TW"/>
+                          <a:cs typeface="Source Han Serif TW"/>
+                        </a:rPr>
+                        <a:t>Candidate records</a:t>
+                      </a:r>
+                    </a:p>
+                  </a:txBody>
+                  <a:tcPr marL="76200" marR="76200" marT="28575" marB="28575">
+                    <a:solidFill>
+                      <a:srgbClr val="FCF8F5"/>
+                    </a:solidFill>
+                  </a:tcPr>
+                </a:tc>
+                <a:tc>
+                  <a:txBody>
+                    <a:bodyPr>
+                      <a:noAutofit/>
+                    </a:bodyPr>
+                    <a:lstStyle/>
+                    <a:p>
+                      <a:r>
+                        <a:rPr sz="1639" b="0">
+                          <a:solidFill>
+                            <a:srgbClr val="423C3B"/>
+                          </a:solidFill>
+                          <a:latin typeface="Source Han Serif TW"/>
+                          <a:ea typeface="Source Han Serif TW"/>
+                          <a:cs typeface="Source Han Serif TW"/>
+                        </a:rPr>
+                        <a:t>260 筆：evaluated 232、failed 28（validation 19、generation 7、compilation 2）</a:t>
+                      </a:r>
+                    </a:p>
+                  </a:txBody>
+                  <a:tcPr marL="76200" marR="76200" marT="28575" marB="28575">
+                    <a:solidFill>
+                      <a:srgbClr val="FCF8F5"/>
+                    </a:solidFill>
+                  </a:tcPr>
+                </a:tc>
+              </a:tr>
+              <a:tr h="642441">
+                <a:tc>
+                  <a:txBody>
+                    <a:bodyPr>
+                      <a:noAutofit/>
+                    </a:bodyPr>
+                    <a:lstStyle/>
+                    <a:p>
+                      <a:r>
+                        <a:rPr sz="1639" b="0">
+                          <a:solidFill>
+                            <a:srgbClr val="423C3B"/>
+                          </a:solidFill>
+                          <a:latin typeface="Source Han Serif TW"/>
+                          <a:ea typeface="Source Han Serif TW"/>
+                          <a:cs typeface="Source Han Serif TW"/>
+                        </a:rPr>
+                        <a:t>Refresh Java preservation</a:t>
+                      </a:r>
+                    </a:p>
+                  </a:txBody>
+                  <a:tcPr marL="76200" marR="76200" marT="28575" marB="28575">
+                    <a:solidFill>
+                      <a:srgbClr val="FCF8F5"/>
+                    </a:solidFill>
+                  </a:tcPr>
+                </a:tc>
+                <a:tc>
+                  <a:txBody>
+                    <a:bodyPr>
+                      <a:noAutofit/>
+                    </a:bodyPr>
+                    <a:lstStyle/>
+                    <a:p>
+                      <a:r>
+                        <a:rPr sz="1639" b="0">
+                          <a:solidFill>
+                            <a:srgbClr val="423C3B"/>
+                          </a:solidFill>
+                          <a:latin typeface="Source Han Serif TW"/>
+                          <a:ea typeface="Source Han Serif TW"/>
+                          <a:cs typeface="Source Han Serif TW"/>
+                        </a:rPr>
+                        <a:t>5 個 boundary 共 50 筆；14/50 保留相同 Java hash，36 筆 generated_java_preserved=false</a:t>
+                      </a:r>
+                    </a:p>
+                  </a:txBody>
+                  <a:tcPr marL="76200" marR="76200" marT="28575" marB="28575">
+                    <a:solidFill>
+                      <a:srgbClr val="FCF8F5"/>
+                    </a:solidFill>
+                  </a:tcPr>
+                </a:tc>
+              </a:tr>
+              <a:tr h="642441">
+                <a:tc>
+                  <a:txBody>
+                    <a:bodyPr>
+                      <a:noAutofit/>
+                    </a:bodyPr>
+                    <a:lstStyle/>
+                    <a:p>
+                      <a:r>
+                        <a:rPr sz="1639" b="0">
+                          <a:solidFill>
+                            <a:srgbClr val="423C3B"/>
+                          </a:solidFill>
+                          <a:latin typeface="Source Han Serif TW"/>
+                          <a:ea typeface="Source Han Serif TW"/>
+                          <a:cs typeface="Source Han Serif TW"/>
+                        </a:rPr>
+                        <a:t>Semantic diversity</a:t>
+                      </a:r>
+                    </a:p>
+                  </a:txBody>
+                  <a:tcPr marL="76200" marR="76200" marT="28575" marB="28575">
+                    <a:solidFill>
+                      <a:srgbClr val="FCF8F5"/>
+                    </a:solidFill>
+                  </a:tcPr>
+                </a:tc>
+                <a:tc>
+                  <a:txBody>
+                    <a:bodyPr>
+                      <a:noAutofit/>
+                    </a:bodyPr>
+                    <a:lstStyle/>
+                    <a:p>
+                      <a:r>
+                        <a:rPr sz="1639" b="0">
+                          <a:solidFill>
+                            <a:srgbClr val="423C3B"/>
+                          </a:solidFill>
+                          <a:latin typeface="Source Han Serif TW"/>
+                          <a:ea typeface="Source Han Serif TW"/>
+                          <a:cs typeface="Source Han Serif TW"/>
+                        </a:rPr>
+                        <a:t>Final 4/10 signatures；G5、G10、G15 各 1/10，G20 回升至 4/10</a:t>
+                      </a:r>
+                    </a:p>
+                  </a:txBody>
+                  <a:tcPr marL="76200" marR="76200" marT="28575" marB="28575">
+                    <a:solidFill>
+                      <a:srgbClr val="FCF8F5"/>
+                    </a:solidFill>
+                  </a:tcPr>
+                </a:tc>
+              </a:tr>
+              <a:tr h="642441">
+                <a:tc>
+                  <a:txBody>
+                    <a:bodyPr>
+                      <a:noAutofit/>
+                    </a:bodyPr>
+                    <a:lstStyle/>
+                    <a:p>
+                      <a:r>
+                        <a:rPr sz="1639" b="0">
+                          <a:solidFill>
+                            <a:srgbClr val="423C3B"/>
+                          </a:solidFill>
+                          <a:latin typeface="Source Han Serif TW"/>
+                          <a:ea typeface="Source Han Serif TW"/>
+                          <a:cs typeface="Source Han Serif TW"/>
+                        </a:rPr>
+                        <a:t>Generation timing</a:t>
+                      </a:r>
+                    </a:p>
+                  </a:txBody>
+                  <a:tcPr marL="76200" marR="76200" marT="28575" marB="28575">
+                    <a:solidFill>
+                      <a:srgbClr val="FCF8F5"/>
+                    </a:solidFill>
+                  </a:tcPr>
+                </a:tc>
+                <a:tc>
+                  <a:txBody>
+                    <a:bodyPr>
+                      <a:noAutofit/>
+                    </a:bodyPr>
+                    <a:lstStyle/>
+                    <a:p>
+                      <a:r>
+                        <a:rPr sz="1639" b="0">
+                          <a:solidFill>
+                            <a:srgbClr val="423C3B"/>
+                          </a:solidFill>
+                          <a:latin typeface="Source Han Serif TW"/>
+                          <a:ea typeface="Source Han Serif TW"/>
+                          <a:cs typeface="Source Han Serif TW"/>
+                        </a:rPr>
+                        <a:t>約 23.106 小時（generation timing records 加總）</a:t>
+                      </a:r>
+                    </a:p>
+                  </a:txBody>
+                  <a:tcPr marL="76200" marR="76200" marT="28575" marB="28575">
+                    <a:solidFill>
+                      <a:srgbClr val="FCF8F5"/>
+                    </a:solidFill>
+                  </a:tcPr>
+                </a:tc>
+              </a:tr>
+              <a:tr h="642441">
+                <a:tc>
+                  <a:txBody>
+                    <a:bodyPr>
+                      <a:noAutofit/>
+                    </a:bodyPr>
+                    <a:lstStyle/>
+                    <a:p>
+                      <a:r>
+                        <a:rPr sz="1639" b="0">
+                          <a:solidFill>
+                            <a:srgbClr val="423C3B"/>
+                          </a:solidFill>
+                          <a:latin typeface="Source Han Serif TW"/>
+                          <a:ea typeface="Source Han Serif TW"/>
+                          <a:cs typeface="Source Han Serif TW"/>
+                        </a:rPr>
+                        <a:t>Self-play 對手別 W/L/D</a:t>
+                      </a:r>
+                    </a:p>
+                  </a:txBody>
+                  <a:tcPr marL="76200" marR="76200" marT="28575" marB="28575">
+                    <a:solidFill>
+                      <a:srgbClr val="FCF8F5"/>
+                    </a:solidFill>
+                  </a:tcPr>
+                </a:tc>
+                <a:tc>
+                  <a:txBody>
+                    <a:bodyPr>
+                      <a:noAutofit/>
+                    </a:bodyPr>
+                    <a:lstStyle/>
+                    <a:p>
+                      <a:r>
+                        <a:rPr sz="1639" b="0">
+                          <a:solidFill>
+                            <a:srgbClr val="423C3B"/>
+                          </a:solidFill>
+                          <a:latin typeface="Source Han Serif TW"/>
+                          <a:ea typeface="Source Han Serif TW"/>
+                          <a:cs typeface="Source Han Serif TW"/>
+                        </a:rPr>
+                        <a:t>PassiveAI 0/0/60；RandomAI 0/2/58；RandomBiasedAI 0/22/38；其餘 7 個對手各 0/60/0</a:t>
+                      </a:r>
+                    </a:p>
+                  </a:txBody>
+                  <a:tcPr marL="76200" marR="76200" marT="28575" marB="28575">
+                    <a:solidFill>
+                      <a:srgbClr val="FCF8F5"/>
+                    </a:solidFill>
+                  </a:tcPr>
+                </a:tc>
+              </a:tr>
+            </a:tbl>
+          </a:graphicData>
+        </a:graphic>
+      </p:graphicFrame>
+      <p:sp>
+        <p:nvSpPr>
+          <p:cNvPr id="6" name="">
+            <a:extLst>
+              <a:ext uri="{FF2B5EF4-FFF2-40B4-BE49-F238E27FC236}">
+                <ns2:creationId id="{E6BD98A8-7324-4162-AC28-9F179111FE6B}"/>
+              </a:ext>
+            </a:extLst>
+          </p:cNvPr>
+          <p:cNvSpPr>
+            <a:spLocks noGrp="1"/>
+          </p:cNvSpPr>
+          <p:nvPr/>
+        </p:nvSpPr>
+        <p:spPr>
+          <a:xfrm>
+            <a:off x="1451282" y="6544270"/>
+            <a:ext cx="12786656" cy="484584"/>
+          </a:xfrm>
+          <a:prstGeom prst="rect">
+            <a:avLst/>
+          </a:prstGeom>
+          <a:noFill/>
+          <a:ln w="0">
+            <a:noFill/>
+          </a:ln>
+        </p:spPr>
+        <p:txBody>
+          <a:bodyPr>
+            <a:noAutofit/>
+          </a:bodyPr>
+          <a:lstStyle/>
+          <a:p>
+            <a:pPr>
+              <a:defRPr sz="1725" b="0">
+                <a:solidFill>
+                  <a:srgbClr val="423C3B"/>
+                </a:solidFill>
+                <a:latin typeface="Source Han Serif TW"/>
+                <a:ea typeface="Source Han Serif TW"/>
+                <a:cs typeface="Source Han Serif TW"/>
+              </a:defRPr>
+            </a:pPr>
+            <a:r>
+              <a:rPr sz="1725" b="0">
+                <a:solidFill>
+                  <a:srgbClr val="423C3B"/>
+                </a:solidFill>
+                <a:latin typeface="Source Han Serif TW"/>
+                <a:ea typeface="Source Han Serif TW"/>
+                <a:cs typeface="Source Han Serif TW"/>
+              </a:rPr>
+              <a:t>Refresh contract caveat 會影響演化路徑解讀；final-test 結果仍是共同固定對手組的實際對戰結果。</a:t>
+            </a:r>
+          </a:p>
+        </p:txBody>
+      </p:sp>
+      <p:sp>
+        <p:nvSpPr>
+          <p:cNvPr id="7" name="">
+            <a:extLst>
+              <a:ext uri="{FF2B5EF4-FFF2-40B4-BE49-F238E27FC236}">
+                <ns2:creationId id="{E986BE4C-D60A-4EED-958F-5A1B351AA10C}"/>
+              </a:ext>
+            </a:extLst>
+          </p:cNvPr>
+          <p:cNvSpPr>
+            <a:spLocks noGrp="1"/>
+          </p:cNvSpPr>
+          <p:nvPr/>
+        </p:nvSpPr>
+        <p:spPr>
+          <a:xfrm>
+            <a:off x="1428750" y="7249120"/>
+            <a:ext cx="12955642" cy="572691"/>
+          </a:xfrm>
+          <a:prstGeom prst="rect">
+            <a:avLst/>
+          </a:prstGeom>
+          <a:noFill/>
+          <a:ln w="0">
+            <a:noFill/>
+          </a:ln>
+        </p:spPr>
+        <p:txBody>
+          <a:bodyPr>
+            <a:noAutofit/>
+          </a:bodyPr>
+          <a:lstStyle/>
+          <a:p>
+            <a:pPr>
+              <a:defRPr sz="2070" b="1">
+                <a:solidFill>
+                  <a:srgbClr val="47171C"/>
+                </a:solidFill>
+                <a:latin typeface="Source Han Serif TW"/>
+                <a:ea typeface="Source Han Serif TW"/>
+                <a:cs typeface="Source Han Serif TW"/>
+              </a:defRPr>
+            </a:pPr>
+            <a:r>
+              <a:rPr sz="2070" b="1">
+                <a:solidFill>
+                  <a:srgbClr val="47171C"/>
+                </a:solidFill>
+                <a:latin typeface="Source Han Serif TW"/>
+                <a:ea typeface="Source Han Serif TW"/>
+                <a:cs typeface="Source Han Serif TW"/>
+              </a:rPr>
+              <a:t>高 search GP 沒有轉成固定對手勝局；refresh 尚有 36/50 次 Java 漂移</a:t>
+            </a:r>
+          </a:p>
+        </p:txBody>
+      </p:sp>
+      <p:sp>
+        <p:nvSpPr>
+          <p:cNvPr id="15" name="Slide Number"/>
+          <p:cNvSpPr>
+            <a:spLocks noGrp="1"/>
+          </p:cNvSpPr>
+          <p:nvPr>
+            <p:ph type="sldNum" sz="quarter" idx="90"/>
+          </p:nvPr>
+        </p:nvSpPr>
+        <p:spPr>
+          <a:xfrm>
+            <a:off x="7296150" y="8477250"/>
+            <a:ext cx="1333500" cy="304800"/>
+          </a:xfrm>
+          <a:prstGeom prst="rect">
+            <a:avLst/>
+          </a:prstGeom>
+          <a:noFill/>
+          <a:ln w="0">
+            <a:noFill/>
+          </a:ln>
+        </p:spPr>
+        <p:txBody>
+          <a:bodyPr lIns="76200" tIns="28575" rIns="76200" bIns="28575" anchor="ctr">
+            <a:noAutofit/>
+          </a:bodyPr>
+          <a:lstStyle/>
+          <a:p>
+            <a:pPr marL="0" indent="0" algn="ctr">
+              <a:buNone/>
+              <a:defRPr sz="1650" b="0">
+                <a:solidFill>
+                  <a:srgbClr val="CF8792"/>
+                </a:solidFill>
+                <a:latin typeface="Source Han Serif TW"/>
+                <a:ea typeface="Source Han Serif TW"/>
+                <a:cs typeface="Source Han Serif TW"/>
+              </a:defRPr>
+            </a:pPr>
+            <a:fld id="{190013B4-C754-404D-8672-FF9D872B13AD}" type="slidenum">
+              <a:rPr sz="1650" b="0">
+                <a:solidFill>
+                  <a:srgbClr val="CF8792"/>
+                </a:solidFill>
+                <a:latin typeface="Source Han Serif TW"/>
+                <a:ea typeface="Source Han Serif TW"/>
+                <a:cs typeface="Source Han Serif TW"/>
+              </a:rPr>
+              <a:t>10</a:t>
+            </a:fld>
+          </a:p>
+        </p:txBody>
+      </p:sp>
+    </p:spTree>
+    <p:extLst>
+      <p:ext uri="{BB962C8B-B14F-4D97-AF65-F5344CB8AC3E}">
+        <ns3:creationId val="1328656091"/>
+      </p:ext>
+    </p:extLst>
+  </p:cSld>
+</p:sld>
+</file>
+
+<file path=ppt/slides/slide11.xml><?xml version="1.0" encoding="utf-8"?>
+<p:sld xmlns:a="http://schemas.openxmlformats.org/drawingml/2006/main" xmlns:ns2="http://schemas.microsoft.com/office/drawing/2014/main" xmlns:ns3="http://schemas.openxmlformats.org/drawingml/2006/chart" xmlns:ns5="http://schemas.microsoft.com/office/powerpoint/2010/main" xmlns:p="http://schemas.openxmlformats.org/presentationml/2006/main" xmlns:r="http://schemas.openxmlformats.org/officeDocument/2006/relationships" showMasterSp="1">
+  <p:cSld>
+    <p:spTree>
+      <p:nvGrpSpPr>
+        <p:cNvPr id="1" name=""/>
+        <p:cNvGrpSpPr/>
+        <p:nvPr/>
+      </p:nvGrpSpPr>
+      <p:grpSpPr>
+        <a:xfrm/>
+      </p:grpSpPr>
+      <p:sp>
+        <p:nvSpPr>
+          <p:cNvPr id="13" name="EAGLE_0">
+            <a:extLst>
+              <a:ext uri="{FF2B5EF4-FFF2-40B4-BE49-F238E27FC236}">
+                <ns2:creationId id="{CF3E0503-8A12-4C35-B8A7-3B7B65A661AB}"/>
+              </a:ext>
+            </a:extLst>
+          </p:cNvPr>
+          <p:cNvSpPr>
+            <a:spLocks noGrp="1"/>
+          </p:cNvSpPr>
+          <p:nvPr>
+            <p:ph idx="0"/>
+          </p:nvPr>
+        </p:nvSpPr>
+        <p:spPr>
+          <a:xfrm>
+            <a:off x="2286000" y="438150"/>
+            <a:ext cx="11353800" cy="1047750"/>
+          </a:xfrm>
+        </p:spPr>
+        <p:txBody>
+          <a:bodyPr anchor="ctr">
+            <a:noAutofit/>
+          </a:bodyPr>
+          <a:lstStyle/>
+          <a:p>
+            <a:pPr algn="ctr">
+              <a:defRPr sz="3668" b="1">
+                <a:solidFill>
+                  <a:srgbClr val="47171C"/>
+                </a:solidFill>
+                <a:latin typeface="Source Han Serif TW"/>
+                <a:ea typeface="Source Han Serif TW"/>
+                <a:cs typeface="Source Han Serif TW"/>
+              </a:defRPr>
+              <a:buNone/>
+            </a:pPr>
+            <a:r>
+              <a:rPr sz="3668" b="1">
+                <a:solidFill>
+                  <a:srgbClr val="47171C"/>
+                </a:solidFill>
+                <a:latin typeface="Source Han Serif TW"/>
+                <a:ea typeface="Source Han Serif TW"/>
+                <a:cs typeface="Source Han Serif TW"/>
+              </a:rPr>
+              <a:t>100 FFE：10×10 明顯優於 5×20，但只有單次觀察</a:t>
+            </a:r>
+          </a:p>
+        </p:txBody>
+      </p:sp>
+      <p:sp>
+        <p:nvSpPr>
+          <p:cNvPr id="14" name="EAGLE_1">
+            <a:extLst>
+              <a:ext uri="{FF2B5EF4-FFF2-40B4-BE49-F238E27FC236}">
+                <ns2:creationId id="{3A26E587-99C4-434B-94A5-0AAB266AB683}"/>
+              </a:ext>
+            </a:extLst>
+          </p:cNvPr>
+          <p:cNvSpPr>
+            <a:spLocks noGrp="1"/>
+          </p:cNvSpPr>
+          <p:nvPr>
+            <p:ph idx="1"/>
+          </p:nvPr>
+        </p:nvSpPr>
+        <p:spPr>
+          <a:xfrm>
+            <a:off x="2476500" y="1571625"/>
+            <a:ext cx="10972800" cy="457200"/>
+          </a:xfrm>
+        </p:spPr>
+        <p:txBody>
+          <a:bodyPr anchor="ctr">
+            <a:noAutofit/>
+          </a:bodyPr>
+          <a:lstStyle/>
+          <a:p>
+            <a:pPr algn="ctr">
+              <a:defRPr sz="1875" b="0">
+                <a:solidFill>
+                  <a:srgbClr val="423C3B"/>
+                </a:solidFill>
+                <a:latin typeface="Source Han Serif TW"/>
+                <a:ea typeface="Source Han Serif TW"/>
+                <a:cs typeface="Source Han Serif TW"/>
+              </a:defRPr>
+              <a:buNone/>
+            </a:pPr>
+            <a:r>
+              <a:rPr sz="1875" b="0">
+                <a:solidFill>
+                  <a:srgbClr val="423C3B"/>
+                </a:solidFill>
+                <a:latin typeface="Source Han Serif TW"/>
+                <a:ea typeface="Source Han Serif TW"/>
+                <a:cs typeface="Source Han Serif TW"/>
+              </a:rPr>
+              <a:t>兩組使用 semantic tie-break、相同 9 個 semantic probes 與 600 場 final test</a:t>
+            </a:r>
+          </a:p>
+        </p:txBody>
+      </p:sp>
+      <p:graphicFrame>
+        <p:nvGraphicFramePr>
+          <p:cNvPr id="12" name="Chart"/>
+          <p:cNvGraphicFramePr/>
+          <p:nvPr/>
+        </p:nvGraphicFramePr>
+        <p:xfrm>
+          <a:off x="1654066" y="2436316"/>
+          <a:ext cx="12167038" cy="4019848"/>
+        </p:xfrm>
+        <a:graphic>
+          <a:graphicData uri="http://schemas.openxmlformats.org/drawingml/2006/chart">
+            <ns3:chart r:id="Rf1f557d0abc84b19"/>
+          </a:graphicData>
+        </a:graphic>
+      </p:graphicFrame>
+      <p:sp>
+        <p:nvSpPr>
+          <p:cNvPr id="6" name="">
+            <a:extLst>
+              <a:ext uri="{FF2B5EF4-FFF2-40B4-BE49-F238E27FC236}">
+                <ns2:creationId id="{9A18CD3C-D117-4B6F-8A50-675B319DCACC}"/>
+              </a:ext>
+            </a:extLst>
+          </p:cNvPr>
+          <p:cNvSpPr>
+            <a:spLocks noGrp="1"/>
+          </p:cNvSpPr>
+          <p:nvPr/>
+        </p:nvSpPr>
+        <p:spPr>
+          <a:xfrm>
+            <a:off x="1451282" y="6621363"/>
+            <a:ext cx="12899313" cy="462558"/>
+          </a:xfrm>
+          <a:prstGeom prst="rect">
+            <a:avLst/>
+          </a:prstGeom>
+          <a:noFill/>
+          <a:ln w="0">
+            <a:noFill/>
+          </a:ln>
+        </p:spPr>
+        <p:txBody>
+          <a:bodyPr>
+            <a:noAutofit/>
+          </a:bodyPr>
+          <a:lstStyle/>
+          <a:p>
+            <a:pPr>
+              <a:defRPr sz="1811" b="0">
+                <a:solidFill>
+                  <a:srgbClr val="423C3B"/>
+                </a:solidFill>
+                <a:latin typeface="Source Han Serif TW"/>
+                <a:ea typeface="Source Han Serif TW"/>
+                <a:cs typeface="Source Han Serif TW"/>
+              </a:defRPr>
+            </a:pPr>
+            <a:r>
+              <a:rPr sz="1811" b="0">
+                <a:solidFill>
+                  <a:srgbClr val="423C3B"/>
+                </a:solidFill>
+                <a:latin typeface="Source Han Serif TW"/>
+                <a:ea typeface="Source Han Serif TW"/>
+                <a:cs typeface="Source Han Serif TW"/>
+              </a:rPr>
+              <a:t>10×10：42.83% 勝率；5×20：0% 勝率。5×20 搜尋期 180 場全和，正 GP 來自資源／兵力 shaping。</a:t>
+            </a:r>
+          </a:p>
+        </p:txBody>
+      </p:sp>
+      <p:sp>
+        <p:nvSpPr>
+          <p:cNvPr id="7" name="">
+            <a:extLst>
+              <a:ext uri="{FF2B5EF4-FFF2-40B4-BE49-F238E27FC236}">
+                <ns2:creationId id="{2002ECEB-9823-4F44-8B30-79669EAFF638}"/>
+              </a:ext>
+            </a:extLst>
+          </p:cNvPr>
+          <p:cNvSpPr>
+            <a:spLocks noGrp="1"/>
+          </p:cNvSpPr>
+          <p:nvPr/>
+        </p:nvSpPr>
+        <p:spPr>
+          <a:xfrm>
+            <a:off x="1428750" y="7337227"/>
+            <a:ext cx="12955642" cy="572691"/>
+          </a:xfrm>
+          <a:prstGeom prst="rect">
+            <a:avLst/>
+          </a:prstGeom>
+          <a:noFill/>
+          <a:ln w="0">
+            <a:noFill/>
+          </a:ln>
+        </p:spPr>
+        <p:txBody>
+          <a:bodyPr>
+            <a:noAutofit/>
+          </a:bodyPr>
+          <a:lstStyle/>
+          <a:p>
+            <a:pPr>
+              <a:defRPr sz="2070" b="1">
+                <a:solidFill>
+                  <a:srgbClr val="47171C"/>
+                </a:solidFill>
+                <a:latin typeface="Source Han Serif TW"/>
+                <a:ea typeface="Source Han Serif TW"/>
+                <a:cs typeface="Source Han Serif TW"/>
+              </a:defRPr>
+            </a:pPr>
+            <a:r>
+              <a:rPr sz="2070" b="1">
+                <a:solidFill>
+                  <a:srgbClr val="47171C"/>
+                </a:solidFill>
+                <a:latin typeface="Source Han Serif TW"/>
+                <a:ea typeface="Source Han Serif TW"/>
+                <a:cs typeface="Source Han Serif TW"/>
+              </a:rPr>
+              <a:t>同 FFE 的結果差距很大，refresh phenotype 漂移阻止強因果歸因</a:t>
+            </a:r>
+          </a:p>
+        </p:txBody>
+      </p:sp>
+      <p:sp>
+        <p:nvSpPr>
+          <p:cNvPr id="15" name="Slide Number"/>
+          <p:cNvSpPr>
+            <a:spLocks noGrp="1"/>
+          </p:cNvSpPr>
+          <p:nvPr>
+            <p:ph type="sldNum" sz="quarter" idx="90"/>
+          </p:nvPr>
+        </p:nvSpPr>
+        <p:spPr>
+          <a:xfrm>
+            <a:off x="7296150" y="8477250"/>
+            <a:ext cx="1333500" cy="304800"/>
+          </a:xfrm>
+          <a:prstGeom prst="rect">
+            <a:avLst/>
+          </a:prstGeom>
+          <a:noFill/>
+          <a:ln w="0">
+            <a:noFill/>
+          </a:ln>
+        </p:spPr>
+        <p:txBody>
+          <a:bodyPr lIns="76200" tIns="28575" rIns="76200" bIns="28575" anchor="ctr">
+            <a:noAutofit/>
+          </a:bodyPr>
+          <a:lstStyle/>
+          <a:p>
+            <a:pPr marL="0" indent="0" algn="ctr">
+              <a:buNone/>
+              <a:defRPr sz="1650" b="0">
+                <a:solidFill>
+                  <a:srgbClr val="CF8792"/>
+                </a:solidFill>
+                <a:latin typeface="Source Han Serif TW"/>
+                <a:ea typeface="Source Han Serif TW"/>
+                <a:cs typeface="Source Han Serif TW"/>
+              </a:defRPr>
+            </a:pPr>
+            <a:fld id="{4A12C83F-5BA0-47FA-AC5B-337E93A10079}" type="slidenum">
+              <a:rPr sz="1650" b="0">
+                <a:solidFill>
+                  <a:srgbClr val="CF8792"/>
+                </a:solidFill>
+                <a:latin typeface="Source Han Serif TW"/>
+                <a:ea typeface="Source Han Serif TW"/>
+                <a:cs typeface="Source Han Serif TW"/>
+              </a:rPr>
+              <a:t>11</a:t>
+            </a:fld>
+          </a:p>
+        </p:txBody>
+      </p:sp>
+    </p:spTree>
+    <p:extLst>
+      <p:ext uri="{BB962C8B-B14F-4D97-AF65-F5344CB8AC3E}">
+        <ns5:creationId val="472497168"/>
+      </p:ext>
+    </p:extLst>
+  </p:cSld>
+</p:sld>
+</file>
+
+<file path=ppt/slides/slide12.xml><?xml version="1.0" encoding="utf-8"?>
+<p:sld xmlns:a="http://schemas.openxmlformats.org/drawingml/2006/main" xmlns:ns2="http://schemas.microsoft.com/office/drawing/2014/main" xmlns:ns3="http://schemas.microsoft.com/office/powerpoint/2010/main" xmlns:p="http://schemas.openxmlformats.org/presentationml/2006/main" showMasterSp="1">
+  <p:cSld>
+    <p:spTree>
+      <p:nvGrpSpPr>
+        <p:cNvPr id="1" name=""/>
+        <p:cNvGrpSpPr/>
+        <p:nvPr/>
+      </p:nvGrpSpPr>
+      <p:grpSpPr>
+        <a:xfrm/>
+      </p:grpSpPr>
+      <p:sp>
+        <p:nvSpPr>
           <p:cNvPr id="12" name="EAGLE_0">
             <a:extLst>
               <a:ext uri="{FF2B5EF4-FFF2-40B4-BE49-F238E27FC236}">
-                <ns2:creationId id="{519073ED-8774-455E-9BBF-550B221127A3}"/>
+                <ns2:creationId id="{BEE5579D-42D9-4CE3-8CAA-C426DD697628}"/>
               </a:ext>
             </a:extLst>
           </p:cNvPr>
@@ -5871,7 +6979,7 @@
           <p:cNvPr id="13" name="EAGLE_1">
             <a:extLst>
               <a:ext uri="{FF2B5EF4-FFF2-40B4-BE49-F238E27FC236}">
-                <ns2:creationId id="{9A1D5260-5118-4D9B-98A3-39319C1EB0BC}"/>
+                <ns2:creationId id="{84FB2273-5E9B-47A9-871D-5C181592367E}"/>
               </a:ext>
             </a:extLst>
           </p:cNvPr>
@@ -6589,7 +7697,7 @@
           <p:cNvPr id="6" name="">
             <a:extLst>
               <a:ext uri="{FF2B5EF4-FFF2-40B4-BE49-F238E27FC236}">
-                <ns2:creationId id="{5C52E5DB-A11C-4A1E-B8E9-F9080FB66C7F}"/>
+                <ns2:creationId id="{BE4B6A8A-756D-464D-B2C7-FE0698FB1FF0}"/>
               </a:ext>
             </a:extLst>
           </p:cNvPr>
@@ -6681,7 +7789,7 @@
                 <a:cs typeface="Source Han Serif TW"/>
               </a:defRPr>
             </a:pPr>
-            <a:fld id="{1A5CA672-F834-4E25-86A4-55DCF532C4E8}" type="slidenum">
+            <a:fld id="{1C39EA54-3278-4536-A1B7-E0F482C3A157}" type="slidenum">
               <a:rPr sz="1650" b="0">
                 <a:solidFill>
                   <a:srgbClr val="CF8792"/>
@@ -6690,7 +7798,7 @@
                 <a:ea typeface="Source Han Serif TW"/>
                 <a:cs typeface="Source Han Serif TW"/>
               </a:rPr>
-              <a:t>10</a:t>
+              <a:t>12</a:t>
             </a:fld>
           </a:p>
         </p:txBody>
@@ -6698,14 +7806,14 @@
     </p:spTree>
     <p:extLst>
       <p:ext uri="{BB962C8B-B14F-4D97-AF65-F5344CB8AC3E}">
-        <ns3:creationId val="578927247"/>
+        <ns3:creationId val="1901178691"/>
       </p:ext>
     </p:extLst>
   </p:cSld>
 </p:sld>
 </file>
 
-<file path=ppt/slides/slide11.xml><?xml version="1.0" encoding="utf-8"?>
+<file path=ppt/slides/slide13.xml><?xml version="1.0" encoding="utf-8"?>
 <p:sld xmlns:a="http://schemas.openxmlformats.org/drawingml/2006/main" xmlns:ns2="http://schemas.microsoft.com/office/drawing/2014/main" xmlns:ns3="http://schemas.microsoft.com/office/powerpoint/2010/main" xmlns:p="http://schemas.openxmlformats.org/presentationml/2006/main" showMasterSp="1">
   <p:cSld>
     <p:spTree>
@@ -6722,7 +7830,7 @@
           <p:cNvPr id="13" name="EAGLE_0">
             <a:extLst>
               <a:ext uri="{FF2B5EF4-FFF2-40B4-BE49-F238E27FC236}">
-                <ns2:creationId id="{A85D74C7-82D0-4E0F-A596-1442A3CFDEC6}"/>
+                <ns2:creationId id="{4CCCE3E1-9BBF-49DE-B2BF-A78F5180B89D}"/>
               </a:ext>
             </a:extLst>
           </p:cNvPr>
@@ -6775,7 +7883,7 @@
           <p:cNvPr id="14" name="EAGLE_1">
             <a:extLst>
               <a:ext uri="{FF2B5EF4-FFF2-40B4-BE49-F238E27FC236}">
-                <ns2:creationId id="{32A7D7E7-9EDD-47FC-AEDD-F70BB5FDF81F}"/>
+                <ns2:creationId id="{A2BBC6EF-4026-41D1-A86A-7EA8127C27B2}"/>
               </a:ext>
             </a:extLst>
           </p:cNvPr>
@@ -7172,7 +8280,7 @@
           <p:cNvPr id="6" name="">
             <a:extLst>
               <a:ext uri="{FF2B5EF4-FFF2-40B4-BE49-F238E27FC236}">
-                <ns2:creationId id="{FDC1293C-8E31-40BB-A6FD-A381C5280B49}"/>
+                <ns2:creationId id="{A8B0FF08-68C2-4BF3-9B91-CA0F721BB1FE}"/>
               </a:ext>
             </a:extLst>
           </p:cNvPr>
@@ -7229,7 +8337,7 @@
           <p:cNvPr id="7" name="">
             <a:extLst>
               <a:ext uri="{FF2B5EF4-FFF2-40B4-BE49-F238E27FC236}">
-                <ns2:creationId id="{288421A1-EC04-48F5-879A-045E8078AA89}"/>
+                <ns2:creationId id="{A0A53C5A-6506-4261-B973-C990070D5FCE}"/>
               </a:ext>
             </a:extLst>
           </p:cNvPr>
@@ -7321,7 +8429,7 @@
                 <a:cs typeface="Source Han Serif TW"/>
               </a:defRPr>
             </a:pPr>
-            <a:fld id="{01314670-E42B-4FA3-9E24-6E03AE3FEB97}" type="slidenum">
+            <a:fld id="{1E8A4604-E603-4D4A-A7C9-62027B2BCBBF}" type="slidenum">
               <a:rPr sz="1650" b="0">
                 <a:solidFill>
                   <a:srgbClr val="CF8792"/>
@@ -7330,7 +8438,7 @@
                 <a:ea typeface="Source Han Serif TW"/>
                 <a:cs typeface="Source Han Serif TW"/>
               </a:rPr>
-              <a:t>11</a:t>
+              <a:t>13</a:t>
             </a:fld>
           </a:p>
         </p:txBody>
@@ -7338,14 +8446,14 @@
     </p:spTree>
     <p:extLst>
       <p:ext uri="{BB962C8B-B14F-4D97-AF65-F5344CB8AC3E}">
-        <ns3:creationId val="1734519308"/>
+        <ns3:creationId val="1553688419"/>
       </p:ext>
     </p:extLst>
   </p:cSld>
 </p:sld>
 </file>
 
-<file path=ppt/slides/slide12.xml><?xml version="1.0" encoding="utf-8"?>
+<file path=ppt/slides/slide14.xml><?xml version="1.0" encoding="utf-8"?>
 <p:sld xmlns:a="http://schemas.openxmlformats.org/drawingml/2006/main" xmlns:ns2="http://schemas.microsoft.com/office/drawing/2014/main" xmlns:ns3="http://schemas.microsoft.com/office/powerpoint/2010/main" xmlns:p="http://schemas.openxmlformats.org/presentationml/2006/main" showMasterSp="1">
   <p:cSld>
     <p:spTree>
@@ -7362,7 +8470,7 @@
           <p:cNvPr id="13" name="EAGLE_0">
             <a:extLst>
               <a:ext uri="{FF2B5EF4-FFF2-40B4-BE49-F238E27FC236}">
-                <ns2:creationId id="{BBC8805B-AA55-4DE2-83AF-DACB4CE332D0}"/>
+                <ns2:creationId id="{0D3B49C8-F6F1-445C-B15A-C2D4D5E2EF0C}"/>
               </a:ext>
             </a:extLst>
           </p:cNvPr>
@@ -7415,7 +8523,7 @@
           <p:cNvPr id="14" name="EAGLE_1">
             <a:extLst>
               <a:ext uri="{FF2B5EF4-FFF2-40B4-BE49-F238E27FC236}">
-                <ns2:creationId id="{AF172545-103A-4CFD-9397-5720C19511A5}"/>
+                <ns2:creationId id="{0C00FCA1-E032-4920-9726-415EDB01C370}"/>
               </a:ext>
             </a:extLst>
           </p:cNvPr>
@@ -8023,7 +9131,7 @@
           <p:cNvPr id="6" name="">
             <a:extLst>
               <a:ext uri="{FF2B5EF4-FFF2-40B4-BE49-F238E27FC236}">
-                <ns2:creationId id="{362D3F17-8E62-4C1A-9824-1B44232D773D}"/>
+                <ns2:creationId id="{C4739567-9090-49AE-BB06-8DDF0B2156B3}"/>
               </a:ext>
             </a:extLst>
           </p:cNvPr>
@@ -8080,7 +9188,7 @@
           <p:cNvPr id="7" name="">
             <a:extLst>
               <a:ext uri="{FF2B5EF4-FFF2-40B4-BE49-F238E27FC236}">
-                <ns2:creationId id="{37280ACB-5161-4EFA-AAE4-B83B0B0DB9CF}"/>
+                <ns2:creationId id="{7DA93D94-0965-495E-9E4E-A78AF16BD443}"/>
               </a:ext>
             </a:extLst>
           </p:cNvPr>
@@ -8172,7 +9280,7 @@
                 <a:cs typeface="Source Han Serif TW"/>
               </a:defRPr>
             </a:pPr>
-            <a:fld id="{3307F304-2424-4D5F-825C-F08C7A9688AD}" type="slidenum">
+            <a:fld id="{0C18B98E-253C-4ED6-B95A-4D9894F535F3}" type="slidenum">
               <a:rPr sz="1650" b="0">
                 <a:solidFill>
                   <a:srgbClr val="CF8792"/>
@@ -8181,7 +9289,7 @@
                 <a:ea typeface="Source Han Serif TW"/>
                 <a:cs typeface="Source Han Serif TW"/>
               </a:rPr>
-              <a:t>12</a:t>
+              <a:t>14</a:t>
             </a:fld>
           </a:p>
         </p:txBody>
@@ -8189,14 +9297,14 @@
     </p:spTree>
     <p:extLst>
       <p:ext uri="{BB962C8B-B14F-4D97-AF65-F5344CB8AC3E}">
-        <ns3:creationId val="754492113"/>
+        <ns3:creationId val="1487319530"/>
       </p:ext>
     </p:extLst>
   </p:cSld>
 </p:sld>
 </file>
 
-<file path=ppt/slides/slide13.xml><?xml version="1.0" encoding="utf-8"?>
+<file path=ppt/slides/slide15.xml><?xml version="1.0" encoding="utf-8"?>
 <p:sld xmlns:a="http://schemas.openxmlformats.org/drawingml/2006/main" xmlns:ns2="http://schemas.microsoft.com/office/drawing/2014/main" xmlns:ns3="http://schemas.microsoft.com/office/powerpoint/2010/main" xmlns:p="http://schemas.openxmlformats.org/presentationml/2006/main" showMasterSp="1">
   <p:cSld>
     <p:spTree>
@@ -8213,7 +9321,7 @@
           <p:cNvPr id="12" name="EAGLE_0">
             <a:extLst>
               <a:ext uri="{FF2B5EF4-FFF2-40B4-BE49-F238E27FC236}">
-                <ns2:creationId id="{FFB1068D-DCD3-40C7-9DEA-832C0A50D18E}"/>
+                <ns2:creationId id="{EB25EF4A-D8C1-48BE-8EB9-991576D4536E}"/>
               </a:ext>
             </a:extLst>
           </p:cNvPr>
@@ -8266,7 +9374,7 @@
           <p:cNvPr id="13" name="EAGLE_1">
             <a:extLst>
               <a:ext uri="{FF2B5EF4-FFF2-40B4-BE49-F238E27FC236}">
-                <ns2:creationId id="{A4E00CCD-8B8B-4ADA-A30D-C1D65E4BFDB9}"/>
+                <ns2:creationId id="{8C2F2B5C-8564-457B-BFEA-E7459FA208DE}"/>
               </a:ext>
             </a:extLst>
           </p:cNvPr>
@@ -8744,7 +9852,7 @@
           <p:cNvPr id="6" name="">
             <a:extLst>
               <a:ext uri="{FF2B5EF4-FFF2-40B4-BE49-F238E27FC236}">
-                <ns2:creationId id="{517AF826-14AB-4202-97E7-97FE5603DBC7}"/>
+                <ns2:creationId id="{3648B466-A5CC-4713-8AB1-7EAD094B8CB5}"/>
               </a:ext>
             </a:extLst>
           </p:cNvPr>
@@ -8836,7 +9944,7 @@
                 <a:cs typeface="Source Han Serif TW"/>
               </a:defRPr>
             </a:pPr>
-            <a:fld id="{A8C06245-F643-43BC-9237-6CE6C5E6A851}" type="slidenum">
+            <a:fld id="{2CBE9B53-23FB-49A7-A4A7-5FC14AF0934C}" type="slidenum">
               <a:rPr sz="1650" b="0">
                 <a:solidFill>
                   <a:srgbClr val="CF8792"/>
@@ -8845,7 +9953,7 @@
                 <a:ea typeface="Source Han Serif TW"/>
                 <a:cs typeface="Source Han Serif TW"/>
               </a:rPr>
-              <a:t>13</a:t>
+              <a:t>15</a:t>
             </a:fld>
           </a:p>
         </p:txBody>
@@ -8853,14 +9961,14 @@
     </p:spTree>
     <p:extLst>
       <p:ext uri="{BB962C8B-B14F-4D97-AF65-F5344CB8AC3E}">
-        <ns3:creationId val="1646366034"/>
+        <ns3:creationId val="904490851"/>
       </p:ext>
     </p:extLst>
   </p:cSld>
 </p:sld>
 </file>
 
-<file path=ppt/slides/slide14.xml><?xml version="1.0" encoding="utf-8"?>
+<file path=ppt/slides/slide16.xml><?xml version="1.0" encoding="utf-8"?>
 <p:sld xmlns:a="http://schemas.openxmlformats.org/drawingml/2006/main" xmlns:ns2="http://schemas.microsoft.com/office/drawing/2014/main" xmlns:ns3="http://schemas.microsoft.com/office/powerpoint/2010/main" xmlns:p="http://schemas.openxmlformats.org/presentationml/2006/main" showMasterSp="1">
   <p:cSld>
     <p:spTree>
@@ -8877,7 +9985,7 @@
           <p:cNvPr id="13" name="EAGLE_0">
             <a:extLst>
               <a:ext uri="{FF2B5EF4-FFF2-40B4-BE49-F238E27FC236}">
-                <ns2:creationId id="{D7500925-9B13-4B1F-A801-D550430FC8E1}"/>
+                <ns2:creationId id="{C7920685-8A0A-499E-99B1-A429CDE09966}"/>
               </a:ext>
             </a:extLst>
           </p:cNvPr>
@@ -8930,7 +10038,7 @@
           <p:cNvPr id="14" name="EAGLE_1">
             <a:extLst>
               <a:ext uri="{FF2B5EF4-FFF2-40B4-BE49-F238E27FC236}">
-                <ns2:creationId id="{53374EC3-87D1-4FEC-BC47-BE6B34126004}"/>
+                <ns2:creationId id="{C9D58F81-BDD6-4594-A88D-6AE4D84E9FAE}"/>
               </a:ext>
             </a:extLst>
           </p:cNvPr>
@@ -9433,7 +10541,7 @@
           <p:cNvPr id="6" name="">
             <a:extLst>
               <a:ext uri="{FF2B5EF4-FFF2-40B4-BE49-F238E27FC236}">
-                <ns2:creationId id="{FABCDE9B-BD36-49A6-87EF-0E345CBB167A}"/>
+                <ns2:creationId id="{4E22F855-2715-46E6-8CD1-7177BEE7AA4E}"/>
               </a:ext>
             </a:extLst>
           </p:cNvPr>
@@ -9490,7 +10598,7 @@
           <p:cNvPr id="7" name="">
             <a:extLst>
               <a:ext uri="{FF2B5EF4-FFF2-40B4-BE49-F238E27FC236}">
-                <ns2:creationId id="{BA86B1F3-88D6-49AF-A254-5916A8BC50AD}"/>
+                <ns2:creationId id="{F50B0222-17CE-47E5-953D-56055E894198}"/>
               </a:ext>
             </a:extLst>
           </p:cNvPr>
@@ -9582,7 +10690,7 @@
                 <a:cs typeface="Source Han Serif TW"/>
               </a:defRPr>
             </a:pPr>
-            <a:fld id="{1C7CD676-1ACD-412B-81E6-AACD5890D926}" type="slidenum">
+            <a:fld id="{7B0F0F41-4753-4918-9FAE-7B758AC5587B}" type="slidenum">
               <a:rPr sz="1650" b="0">
                 <a:solidFill>
                   <a:srgbClr val="CF8792"/>
@@ -9591,7 +10699,7 @@
                 <a:ea typeface="Source Han Serif TW"/>
                 <a:cs typeface="Source Han Serif TW"/>
               </a:rPr>
-              <a:t>14</a:t>
+              <a:t>16</a:t>
             </a:fld>
           </a:p>
         </p:txBody>
@@ -9599,14 +10707,14 @@
     </p:spTree>
     <p:extLst>
       <p:ext uri="{BB962C8B-B14F-4D97-AF65-F5344CB8AC3E}">
-        <ns3:creationId val="837850365"/>
+        <ns3:creationId val="1581070900"/>
       </p:ext>
     </p:extLst>
   </p:cSld>
 </p:sld>
 </file>
 
-<file path=ppt/slides/slide15.xml><?xml version="1.0" encoding="utf-8"?>
+<file path=ppt/slides/slide17.xml><?xml version="1.0" encoding="utf-8"?>
 <p:sld xmlns:a="http://schemas.openxmlformats.org/drawingml/2006/main" xmlns:ns2="http://schemas.microsoft.com/office/drawing/2014/main" xmlns:ns3="http://schemas.openxmlformats.org/drawingml/2006/chart" xmlns:ns5="http://schemas.microsoft.com/office/powerpoint/2010/main" xmlns:p="http://schemas.openxmlformats.org/presentationml/2006/main" xmlns:r="http://schemas.openxmlformats.org/officeDocument/2006/relationships" showMasterSp="1">
   <p:cSld>
     <p:spTree>
@@ -9623,7 +10731,7 @@
           <p:cNvPr id="13" name="EAGLE_0">
             <a:extLst>
               <a:ext uri="{FF2B5EF4-FFF2-40B4-BE49-F238E27FC236}">
-                <ns2:creationId id="{4E67E068-9C27-4D16-B7A9-2F39F6DF81B7}"/>
+                <ns2:creationId id="{D2B45EE0-DE70-4F78-BFA0-7018054E5CF3}"/>
               </a:ext>
             </a:extLst>
           </p:cNvPr>
@@ -9676,7 +10784,7 @@
           <p:cNvPr id="14" name="EAGLE_1">
             <a:extLst>
               <a:ext uri="{FF2B5EF4-FFF2-40B4-BE49-F238E27FC236}">
-                <ns2:creationId id="{F64C6E44-4714-4301-8467-B7BC1AA58803}"/>
+                <ns2:creationId id="{D8F44511-91A2-4D46-B4F6-81B8A43E9A6B}"/>
               </a:ext>
             </a:extLst>
           </p:cNvPr>
@@ -9736,7 +10844,7 @@
         </p:xfrm>
         <a:graphic>
           <a:graphicData uri="http://schemas.openxmlformats.org/drawingml/2006/chart">
-            <ns3:chart r:id="R531f9fb61b474019"/>
+            <ns3:chart r:id="R0ef0fe7f43da4d29"/>
           </a:graphicData>
         </a:graphic>
       </p:graphicFrame>
@@ -9745,7 +10853,7 @@
           <p:cNvPr id="6" name="">
             <a:extLst>
               <a:ext uri="{FF2B5EF4-FFF2-40B4-BE49-F238E27FC236}">
-                <ns2:creationId id="{DC197EAB-9788-4621-9CA7-1E5D47B17011}"/>
+                <ns2:creationId id="{5381E505-A25C-45FB-B4AB-9AEB6B39E9A0}"/>
               </a:ext>
             </a:extLst>
           </p:cNvPr>
@@ -9802,7 +10910,7 @@
           <p:cNvPr id="7" name="">
             <a:extLst>
               <a:ext uri="{FF2B5EF4-FFF2-40B4-BE49-F238E27FC236}">
-                <ns2:creationId id="{10F82B43-B22F-4A58-A723-6928B245003D}"/>
+                <ns2:creationId id="{AEFBCE4D-A790-4251-B85E-FBE5A3341479}"/>
               </a:ext>
             </a:extLst>
           </p:cNvPr>
@@ -9894,7 +11002,7 @@
                 <a:cs typeface="Source Han Serif TW"/>
               </a:defRPr>
             </a:pPr>
-            <a:fld id="{AB4B49AD-FA47-4D42-B7D4-F653245E2704}" type="slidenum">
+            <a:fld id="{B14298A2-A7D8-4114-9551-A0264EC70F86}" type="slidenum">
               <a:rPr sz="1650" b="0">
                 <a:solidFill>
                   <a:srgbClr val="CF8792"/>
@@ -9903,7 +11011,7 @@
                 <a:ea typeface="Source Han Serif TW"/>
                 <a:cs typeface="Source Han Serif TW"/>
               </a:rPr>
-              <a:t>15</a:t>
+              <a:t>17</a:t>
             </a:fld>
           </a:p>
         </p:txBody>
@@ -9911,14 +11019,14 @@
     </p:spTree>
     <p:extLst>
       <p:ext uri="{BB962C8B-B14F-4D97-AF65-F5344CB8AC3E}">
-        <ns5:creationId val="540224743"/>
+        <ns5:creationId val="777585848"/>
       </p:ext>
     </p:extLst>
   </p:cSld>
 </p:sld>
 </file>
 
-<file path=ppt/slides/slide16.xml><?xml version="1.0" encoding="utf-8"?>
+<file path=ppt/slides/slide18.xml><?xml version="1.0" encoding="utf-8"?>
 <p:sld xmlns:a="http://schemas.openxmlformats.org/drawingml/2006/main" xmlns:ns2="http://schemas.microsoft.com/office/drawing/2014/main" xmlns:ns3="http://schemas.microsoft.com/office/powerpoint/2010/main" xmlns:p="http://schemas.openxmlformats.org/presentationml/2006/main" showMasterSp="1">
   <p:cSld>
     <p:spTree>
@@ -9935,7 +11043,7 @@
           <p:cNvPr id="13" name="EAGLE_0">
             <a:extLst>
               <a:ext uri="{FF2B5EF4-FFF2-40B4-BE49-F238E27FC236}">
-                <ns2:creationId id="{73F526BB-6B94-4642-983F-C298671A4720}"/>
+                <ns2:creationId id="{E01B563B-7DF2-48C3-9BD5-4044A7127D0B}"/>
               </a:ext>
             </a:extLst>
           </p:cNvPr>
@@ -9988,7 +11096,7 @@
           <p:cNvPr id="14" name="EAGLE_1">
             <a:extLst>
               <a:ext uri="{FF2B5EF4-FFF2-40B4-BE49-F238E27FC236}">
-                <ns2:creationId id="{02CCF35C-6A2E-4343-8AA2-398A44D49F68}"/>
+                <ns2:creationId id="{B040FB3A-3788-4FA7-9A9B-147A14DA9F2E}"/>
               </a:ext>
             </a:extLst>
           </p:cNvPr>
@@ -10491,7 +11599,7 @@
           <p:cNvPr id="6" name="">
             <a:extLst>
               <a:ext uri="{FF2B5EF4-FFF2-40B4-BE49-F238E27FC236}">
-                <ns2:creationId id="{A738CB3B-B9F6-4077-9B4D-C8A44C64C410}"/>
+                <ns2:creationId id="{31E2BFB4-7774-4DB0-AAFC-F23700EAC4CA}"/>
               </a:ext>
             </a:extLst>
           </p:cNvPr>
@@ -10548,7 +11656,7 @@
           <p:cNvPr id="7" name="">
             <a:extLst>
               <a:ext uri="{FF2B5EF4-FFF2-40B4-BE49-F238E27FC236}">
-                <ns2:creationId id="{CDCE966E-0ED9-42DE-85EE-BF6B84B88C23}"/>
+                <ns2:creationId id="{6E7B71B1-CBE6-499E-B8AA-EBAFCEB2C77A}"/>
               </a:ext>
             </a:extLst>
           </p:cNvPr>
@@ -10640,7 +11748,7 @@
                 <a:cs typeface="Source Han Serif TW"/>
               </a:defRPr>
             </a:pPr>
-            <a:fld id="{4D676A2F-1938-4902-9269-5C23FA62D616}" type="slidenum">
+            <a:fld id="{AB1F3808-7835-4B89-A665-5FA648B64953}" type="slidenum">
               <a:rPr sz="1650" b="0">
                 <a:solidFill>
                   <a:srgbClr val="CF8792"/>
@@ -10649,7 +11757,7 @@
                 <a:ea typeface="Source Han Serif TW"/>
                 <a:cs typeface="Source Han Serif TW"/>
               </a:rPr>
-              <a:t>16</a:t>
+              <a:t>18</a:t>
             </a:fld>
           </a:p>
         </p:txBody>
@@ -10657,14 +11765,14 @@
     </p:spTree>
     <p:extLst>
       <p:ext uri="{BB962C8B-B14F-4D97-AF65-F5344CB8AC3E}">
-        <ns3:creationId val="777971432"/>
+        <ns3:creationId val="1916477955"/>
       </p:ext>
     </p:extLst>
   </p:cSld>
 </p:sld>
 </file>
 
-<file path=ppt/slides/slide17.xml><?xml version="1.0" encoding="utf-8"?>
+<file path=ppt/slides/slide19.xml><?xml version="1.0" encoding="utf-8"?>
 <p:sld xmlns:a="http://schemas.openxmlformats.org/drawingml/2006/main" xmlns:ns2="http://schemas.microsoft.com/office/drawing/2014/main" xmlns:ns3="http://schemas.microsoft.com/office/powerpoint/2010/main" xmlns:p="http://schemas.openxmlformats.org/presentationml/2006/main" showMasterSp="1">
   <p:cSld>
     <p:spTree>
@@ -10681,7 +11789,7 @@
           <p:cNvPr id="12" name="EAGLE_0">
             <a:extLst>
               <a:ext uri="{FF2B5EF4-FFF2-40B4-BE49-F238E27FC236}">
-                <ns2:creationId id="{0ACBA75D-86AF-442A-AC5C-ECE7259AAF49}"/>
+                <ns2:creationId id="{8DB38851-F606-4330-9224-B5349636C4E9}"/>
               </a:ext>
             </a:extLst>
           </p:cNvPr>
@@ -10734,7 +11842,7 @@
           <p:cNvPr id="13" name="EAGLE_1">
             <a:extLst>
               <a:ext uri="{FF2B5EF4-FFF2-40B4-BE49-F238E27FC236}">
-                <ns2:creationId id="{A1FF8948-21B8-4946-8227-24436CA4BE9D}"/>
+                <ns2:creationId id="{11DA9853-B17A-4696-9641-74482FADAC54}"/>
               </a:ext>
             </a:extLst>
           </p:cNvPr>
@@ -11243,7 +12351,7 @@
           <p:cNvPr id="6" name="">
             <a:extLst>
               <a:ext uri="{FF2B5EF4-FFF2-40B4-BE49-F238E27FC236}">
-                <ns2:creationId id="{0EAE1F2D-714D-4E83-84F0-E844C6BF9056}"/>
+                <ns2:creationId id="{C61479E8-BAFA-427D-B501-61B2F4BA3EAE}"/>
               </a:ext>
             </a:extLst>
           </p:cNvPr>
@@ -11335,7 +12443,7 @@
                 <a:cs typeface="Source Han Serif TW"/>
               </a:defRPr>
             </a:pPr>
-            <a:fld id="{484DC8B8-7677-4048-922C-1C5BFD843A1E}" type="slidenum">
+            <a:fld id="{F00C7EB9-3203-4A71-92B7-2BBAFA1BCBA7}" type="slidenum">
               <a:rPr sz="1650" b="0">
                 <a:solidFill>
                   <a:srgbClr val="CF8792"/>
@@ -11344,7 +12452,7 @@
                 <a:ea typeface="Source Han Serif TW"/>
                 <a:cs typeface="Source Han Serif TW"/>
               </a:rPr>
-              <a:t>17</a:t>
+              <a:t>19</a:t>
             </a:fld>
           </a:p>
         </p:txBody>
@@ -11352,14 +12460,14 @@
     </p:spTree>
     <p:extLst>
       <p:ext uri="{BB962C8B-B14F-4D97-AF65-F5344CB8AC3E}">
-        <ns3:creationId val="22371854"/>
+        <ns3:creationId val="1651810427"/>
       </p:ext>
     </p:extLst>
   </p:cSld>
 </p:sld>
 </file>
 
-<file path=ppt/slides/slide18.xml><?xml version="1.0" encoding="utf-8"?>
+<file path=ppt/slides/slide2.xml><?xml version="1.0" encoding="utf-8"?>
 <p:sld xmlns:a="http://schemas.openxmlformats.org/drawingml/2006/main" xmlns:ns2="http://schemas.microsoft.com/office/drawing/2014/main" xmlns:ns3="http://schemas.microsoft.com/office/powerpoint/2010/main" xmlns:p="http://schemas.openxmlformats.org/presentationml/2006/main" showMasterSp="1">
   <p:cSld>
     <p:spTree>
@@ -11376,7 +12484,7 @@
           <p:cNvPr id="12" name="EAGLE_0">
             <a:extLst>
               <a:ext uri="{FF2B5EF4-FFF2-40B4-BE49-F238E27FC236}">
-                <ns2:creationId id="{EB0AF600-431A-4665-B6E2-B21450623C9A}"/>
+                <ns2:creationId id="{763C505E-A699-4D77-B84C-43A3DB65E6A3}"/>
               </a:ext>
             </a:extLst>
           </p:cNvPr>
@@ -11419,7 +12527,7 @@
                 <a:ea typeface="Source Han Serif TW"/>
                 <a:cs typeface="Source Han Serif TW"/>
               </a:rPr>
-              <a:t>來源與數據限制</a:t>
+              <a:t>原草稿需更新的數字與比較口徑</a:t>
             </a:r>
           </a:p>
         </p:txBody>
@@ -11429,7 +12537,7 @@
           <p:cNvPr id="13" name="EAGLE_1">
             <a:extLst>
               <a:ext uri="{FF2B5EF4-FFF2-40B4-BE49-F238E27FC236}">
-                <ns2:creationId id="{A4EB73EA-09B7-422C-98DA-DA07CD107EF1}"/>
+                <ns2:creationId id="{F31D48B2-94AC-4E13-A1AB-C01D01CC91EA}"/>
               </a:ext>
             </a:extLst>
           </p:cNvPr>
@@ -11472,7 +12580,7 @@
                 <a:ea typeface="Source Han Serif TW"/>
                 <a:cs typeface="Source Han Serif TW"/>
               </a:rPr>
-              <a:t>以 canonical run artifacts 為優先；本次可用的 0924 後彙整為 Notion page + meeting snapshot</a:t>
+              <a:t>舊版資料仍有參考價值，但不能當作最新 10×20 結果</a:t>
             </a:r>
           </a:p>
         </p:txBody>
@@ -11485,7 +12593,7 @@
         </p:nvGraphicFramePr>
         <p:xfrm>
           <a:off x="1428750" y="2491383"/>
-          <a:ext cx="13068300" cy="3303984"/>
+          <a:ext cx="13068300" cy="3854648"/>
         </p:xfrm>
         <a:graphic>
           <a:graphicData uri="http://schemas.openxmlformats.org/drawingml/2006/table">
@@ -11494,27 +12602,27 @@
                 <a:tableStyleId>{8497E131-5584-4FF0-9A17-202609170001}</a:tableStyleId>
               </a:tblPr>
               <a:tblGrid>
-                <a:gridCol w="3830364"/>
-                <a:gridCol w="9237936"/>
+                <a:gridCol w="3379733"/>
+                <a:gridCol w="9688567"/>
               </a:tblGrid>
-              <a:tr h="660797">
-                <a:tc>
-                  <a:txBody>
-                    <a:bodyPr>
-                      <a:noAutofit/>
-                    </a:bodyPr>
-                    <a:lstStyle/>
-                    <a:p>
-                      <a:r>
-                        <a:rPr sz="1639" b="1">
-                          <a:solidFill>
-                            <a:srgbClr val="423C3B"/>
-                          </a:solidFill>
-                          <a:latin typeface="Source Han Serif TW"/>
-                          <a:ea typeface="Source Han Serif TW"/>
-                          <a:cs typeface="Source Han Serif TW"/>
-                        </a:rPr>
-                        <a:t>來源組</a:t>
+              <a:tr h="642441">
+                <a:tc>
+                  <a:txBody>
+                    <a:bodyPr>
+                      <a:noAutofit/>
+                    </a:bodyPr>
+                    <a:lstStyle/>
+                    <a:p>
+                      <a:r>
+                        <a:rPr sz="1725" b="1">
+                          <a:solidFill>
+                            <a:srgbClr val="423C3B"/>
+                          </a:solidFill>
+                          <a:latin typeface="Source Han Serif TW"/>
+                          <a:ea typeface="Source Han Serif TW"/>
+                          <a:cs typeface="Source Han Serif TW"/>
+                        </a:rPr>
+                        <a:t>校核項目</a:t>
                       </a:r>
                     </a:p>
                   </a:txBody>
@@ -11532,15 +12640,15 @@
                     <a:lstStyle/>
                     <a:p>
                       <a:r>
-                        <a:rPr sz="1639" b="1">
-                          <a:solidFill>
-                            <a:srgbClr val="423C3B"/>
-                          </a:solidFill>
-                          <a:latin typeface="Source Han Serif TW"/>
-                          <a:ea typeface="Source Han Serif TW"/>
-                          <a:cs typeface="Source Han Serif TW"/>
-                        </a:rPr>
-                        <a:t>納入文件／記錄</a:t>
+                        <a:rPr sz="1725" b="1">
+                          <a:solidFill>
+                            <a:srgbClr val="423C3B"/>
+                          </a:solidFill>
+                          <a:latin typeface="Source Han Serif TW"/>
+                          <a:ea typeface="Source Han Serif TW"/>
+                          <a:cs typeface="Source Han Serif TW"/>
+                        </a:rPr>
+                        <a:t>校正後口徑</a:t>
                       </a:r>
                     </a:p>
                   </a:txBody>
@@ -11551,50 +12659,50 @@
                   </a:tcPr>
                 </a:tc>
               </a:tr>
-              <a:tr h="660797">
-                <a:tc>
-                  <a:txBody>
-                    <a:bodyPr>
-                      <a:noAutofit/>
-                    </a:bodyPr>
-                    <a:lstStyle/>
-                    <a:p>
-                      <a:r>
-                        <a:rPr sz="1639" b="0">
-                          <a:solidFill>
-                            <a:srgbClr val="423C3B"/>
-                          </a:solidFill>
-                          <a:latin typeface="Source Han Serif TW"/>
-                          <a:ea typeface="Source Han Serif TW"/>
-                          <a:cs typeface="Source Han Serif TW"/>
-                        </a:rPr>
-                        <a:t>Single-objective 主分析</a:t>
-                      </a:r>
-                    </a:p>
-                  </a:txBody>
-                  <a:tcPr marL="76200" marR="76200" marT="28575" marB="28575">
-                    <a:solidFill>
-                      <a:srgbClr val="FCF8F5"/>
-                    </a:solidFill>
-                  </a:tcPr>
-                </a:tc>
-                <a:tc>
-                  <a:txBody>
-                    <a:bodyPr>
-                      <a:noAutofit/>
-                    </a:bodyPr>
-                    <a:lstStyle/>
-                    <a:p>
-                      <a:r>
-                        <a:rPr sz="1639" b="0">
-                          <a:solidFill>
-                            <a:srgbClr val="423C3B"/>
-                          </a:solidFill>
-                          <a:latin typeface="Source Han Serif TW"/>
-                          <a:ea typeface="Source Han Serif TW"/>
-                          <a:cs typeface="Source Han Serif TW"/>
-                        </a:rPr>
-                        <a:t>Notion 0926 10×10、0926 5×20、0927 10×20；README.md 與 self-play analysis</a:t>
+              <a:tr h="642441">
+                <a:tc>
+                  <a:txBody>
+                    <a:bodyPr>
+                      <a:noAutofit/>
+                    </a:bodyPr>
+                    <a:lstStyle/>
+                    <a:p>
+                      <a:r>
+                        <a:rPr sz="1725" b="0">
+                          <a:solidFill>
+                            <a:srgbClr val="423C3B"/>
+                          </a:solidFill>
+                          <a:latin typeface="Source Han Serif TW"/>
+                          <a:ea typeface="Source Han Serif TW"/>
+                          <a:cs typeface="Source Han Serif TW"/>
+                        </a:rPr>
+                        <a:t>0923 10×20 與 0927 10×20</a:t>
+                      </a:r>
+                    </a:p>
+                  </a:txBody>
+                  <a:tcPr marL="76200" marR="76200" marT="28575" marB="28575">
+                    <a:solidFill>
+                      <a:srgbClr val="FCF8F5"/>
+                    </a:solidFill>
+                  </a:tcPr>
+                </a:tc>
+                <a:tc>
+                  <a:txBody>
+                    <a:bodyPr>
+                      <a:noAutofit/>
+                    </a:bodyPr>
+                    <a:lstStyle/>
+                    <a:p>
+                      <a:r>
+                        <a:rPr sz="1725" b="0">
+                          <a:solidFill>
+                            <a:srgbClr val="423C3B"/>
+                          </a:solidFill>
+                          <a:latin typeface="Source Han Serif TW"/>
+                          <a:ea typeface="Source Han Serif TW"/>
+                          <a:cs typeface="Source Han Serif TW"/>
+                        </a:rPr>
+                        <a:t>不同 run。0927 semantic tie-break 為 0/444/156/0 W/L/D/E；舊 0923 為 0/449/151/0。</a:t>
                       </a:r>
                     </a:p>
                   </a:txBody>
@@ -11605,50 +12713,50 @@
                   </a:tcPr>
                 </a:tc>
               </a:tr>
-              <a:tr h="660797">
-                <a:tc>
-                  <a:txBody>
-                    <a:bodyPr>
-                      <a:noAutofit/>
-                    </a:bodyPr>
-                    <a:lstStyle/>
-                    <a:p>
-                      <a:r>
-                        <a:rPr sz="1639" b="0">
-                          <a:solidFill>
-                            <a:srgbClr val="423C3B"/>
-                          </a:solidFill>
-                          <a:latin typeface="Source Han Serif TW"/>
-                          <a:ea typeface="Source Han Serif TW"/>
-                          <a:cs typeface="Source Han Serif TW"/>
-                        </a:rPr>
-                        <a:t>evaluation-mode control</a:t>
-                      </a:r>
-                    </a:p>
-                  </a:txBody>
-                  <a:tcPr marL="76200" marR="76200" marT="28575" marB="28575">
-                    <a:solidFill>
-                      <a:srgbClr val="FCF8F5"/>
-                    </a:solidFill>
-                  </a:tcPr>
-                </a:tc>
-                <a:tc>
-                  <a:txBody>
-                    <a:bodyPr>
-                      <a:noAutofit/>
-                    </a:bodyPr>
-                    <a:lstStyle/>
-                    <a:p>
-                      <a:r>
-                        <a:rPr sz="1639" b="0">
-                          <a:solidFill>
-                            <a:srgbClr val="423C3B"/>
-                          </a:solidFill>
-                          <a:latin typeface="Source Han Serif TW"/>
-                          <a:ea typeface="Source Han Serif TW"/>
-                          <a:cs typeface="Source Han Serif TW"/>
-                        </a:rPr>
-                        <a:t>09/11 fixed-roster 10×20 歷史 run；0929 同設定重跑 config 待執行</a:t>
+              <a:tr h="642441">
+                <a:tc>
+                  <a:txBody>
+                    <a:bodyPr>
+                      <a:noAutofit/>
+                    </a:bodyPr>
+                    <a:lstStyle/>
+                    <a:p>
+                      <a:r>
+                        <a:rPr sz="1725" b="0">
+                          <a:solidFill>
+                            <a:srgbClr val="423C3B"/>
+                          </a:solidFill>
+                          <a:latin typeface="Source Han Serif TW"/>
+                          <a:ea typeface="Source Han Serif TW"/>
+                          <a:cs typeface="Source Han Serif TW"/>
+                        </a:rPr>
+                        <a:t>0925 5×40 evaluation</a:t>
+                      </a:r>
+                    </a:p>
+                  </a:txBody>
+                  <a:tcPr marL="76200" marR="76200" marT="28575" marB="28575">
+                    <a:solidFill>
+                      <a:srgbClr val="FCF8F5"/>
+                    </a:solidFill>
+                  </a:tcPr>
+                </a:tc>
+                <a:tc>
+                  <a:txBody>
+                    <a:bodyPr>
+                      <a:noAutofit/>
+                    </a:bodyPr>
+                    <a:lstStyle/>
+                    <a:p>
+                      <a:r>
+                        <a:rPr sz="1725" b="0">
+                          <a:solidFill>
+                            <a:srgbClr val="423C3B"/>
+                          </a:solidFill>
+                          <a:latin typeface="Source Han Serif TW"/>
+                          <a:ea typeface="Source Han Serif TW"/>
+                          <a:cs typeface="Source Han Serif TW"/>
+                        </a:rPr>
+                        <a:t>舊 lexicase 對 10 個 self-play snapshot opponents；不是單一 game_performance 目標，排除主表。</a:t>
                       </a:r>
                     </a:p>
                   </a:txBody>
@@ -11659,50 +12767,50 @@
                   </a:tcPr>
                 </a:tc>
               </a:tr>
-              <a:tr h="660797">
-                <a:tc>
-                  <a:txBody>
-                    <a:bodyPr>
-                      <a:noAutofit/>
-                    </a:bodyPr>
-                    <a:lstStyle/>
-                    <a:p>
-                      <a:r>
-                        <a:rPr sz="1639" b="0">
-                          <a:solidFill>
-                            <a:srgbClr val="423C3B"/>
-                          </a:solidFill>
-                          <a:latin typeface="Source Han Serif TW"/>
-                          <a:ea typeface="Source Han Serif TW"/>
-                          <a:cs typeface="Source Han Serif TW"/>
-                        </a:rPr>
-                        <a:t>Earlier controlled studies</a:t>
-                      </a:r>
-                    </a:p>
-                  </a:txBody>
-                  <a:tcPr marL="76200" marR="76200" marT="28575" marB="28575">
-                    <a:solidFill>
-                      <a:srgbClr val="FCF8F5"/>
-                    </a:solidFill>
-                  </a:tcPr>
-                </a:tc>
-                <a:tc>
-                  <a:txBody>
-                    <a:bodyPr>
-                      <a:noAutofit/>
-                    </a:bodyPr>
-                    <a:lstStyle/>
-                    <a:p>
-                      <a:r>
-                        <a:rPr sz="1639" b="0">
-                          <a:solidFill>
-                            <a:srgbClr val="423C3B"/>
-                          </a:solidFill>
-                          <a:latin typeface="Source Han Serif TW"/>
-                          <a:ea typeface="Source Han Serif TW"/>
-                          <a:cs typeface="Source Han Serif TW"/>
-                        </a:rPr>
-                        <a:t>09/07 reflection、09/10 model、09/12 initialization、09/14 parent regeneration</a:t>
+              <a:tr h="642441">
+                <a:tc>
+                  <a:txBody>
+                    <a:bodyPr>
+                      <a:noAutofit/>
+                    </a:bodyPr>
+                    <a:lstStyle/>
+                    <a:p>
+                      <a:r>
+                        <a:rPr sz="1725" b="0">
+                          <a:solidFill>
+                            <a:srgbClr val="423C3B"/>
+                          </a:solidFill>
+                          <a:latin typeface="Source Han Serif TW"/>
+                          <a:ea typeface="Source Han Serif TW"/>
+                          <a:cs typeface="Source Han Serif TW"/>
+                        </a:rPr>
+                        <a:t>單一目標範圍</a:t>
+                      </a:r>
+                    </a:p>
+                  </a:txBody>
+                  <a:tcPr marL="76200" marR="76200" marT="28575" marB="28575">
+                    <a:solidFill>
+                      <a:srgbClr val="FCF8F5"/>
+                    </a:solidFill>
+                  </a:tcPr>
+                </a:tc>
+                <a:tc>
+                  <a:txBody>
+                    <a:bodyPr>
+                      <a:noAutofit/>
+                    </a:bodyPr>
+                    <a:lstStyle/>
+                    <a:p>
+                      <a:r>
+                        <a:rPr sz="1725" b="0">
+                          <a:solidFill>
+                            <a:srgbClr val="423C3B"/>
+                          </a:solidFill>
+                          <a:latin typeface="Source Han Serif TW"/>
+                          <a:ea typeface="Source Han Serif TW"/>
+                          <a:cs typeface="Source Han Serif TW"/>
+                        </a:rPr>
+                        <a:t>0926–0927 三組只有 game_performance 數值目標；semantic tie-break 有使用、但只在 fitness 差距 ≤1.0 時決勝。</a:t>
                       </a:r>
                     </a:p>
                   </a:txBody>
@@ -11713,50 +12821,104 @@
                   </a:tcPr>
                 </a:tc>
               </a:tr>
-              <a:tr h="660797">
-                <a:tc>
-                  <a:txBody>
-                    <a:bodyPr>
-                      <a:noAutofit/>
-                    </a:bodyPr>
-                    <a:lstStyle/>
-                    <a:p>
-                      <a:r>
-                        <a:rPr sz="1639" b="0">
-                          <a:solidFill>
-                            <a:srgbClr val="423C3B"/>
-                          </a:solidFill>
-                          <a:latin typeface="Source Han Serif TW"/>
-                          <a:ea typeface="Source Han Serif TW"/>
-                          <a:cs typeface="Source Han Serif TW"/>
-                        </a:rPr>
-                        <a:t>Limit</a:t>
-                      </a:r>
-                    </a:p>
-                  </a:txBody>
-                  <a:tcPr marL="76200" marR="76200" marT="28575" marB="28575">
-                    <a:solidFill>
-                      <a:srgbClr val="FCF8F5"/>
-                    </a:solidFill>
-                  </a:tcPr>
-                </a:tc>
-                <a:tc>
-                  <a:txBody>
-                    <a:bodyPr>
-                      <a:noAutofit/>
-                    </a:bodyPr>
-                    <a:lstStyle/>
-                    <a:p>
-                      <a:r>
-                        <a:rPr sz="1639" b="0">
-                          <a:solidFill>
-                            <a:srgbClr val="423C3B"/>
-                          </a:solidFill>
-                          <a:latin typeface="Source Han Serif TW"/>
-                          <a:ea typeface="Source Han Serif TW"/>
-                          <a:cs typeface="Source Han Serif TW"/>
-                        </a:rPr>
-                        <a:t>0929 5×40 與 fixed-opponent control configs 尚未執行；無新結果。近期細節以 Notion page 和 analysis_md 為證據。</a:t>
+              <a:tr h="642441">
+                <a:tc>
+                  <a:txBody>
+                    <a:bodyPr>
+                      <a:noAutofit/>
+                    </a:bodyPr>
+                    <a:lstStyle/>
+                    <a:p>
+                      <a:r>
+                        <a:rPr sz="1725" b="0">
+                          <a:solidFill>
+                            <a:srgbClr val="423C3B"/>
+                          </a:solidFill>
+                          <a:latin typeface="Source Han Serif TW"/>
+                          <a:ea typeface="Source Han Serif TW"/>
+                          <a:cs typeface="Source Han Serif TW"/>
+                        </a:rPr>
+                        <a:t>比分順序</a:t>
+                      </a:r>
+                    </a:p>
+                  </a:txBody>
+                  <a:tcPr marL="76200" marR="76200" marT="28575" marB="28575">
+                    <a:solidFill>
+                      <a:srgbClr val="FCF8F5"/>
+                    </a:solidFill>
+                  </a:tcPr>
+                </a:tc>
+                <a:tc>
+                  <a:txBody>
+                    <a:bodyPr>
+                      <a:noAutofit/>
+                    </a:bodyPr>
+                    <a:lstStyle/>
+                    <a:p>
+                      <a:r>
+                        <a:rPr sz="1725" b="0">
+                          <a:solidFill>
+                            <a:srgbClr val="423C3B"/>
+                          </a:solidFill>
+                          <a:latin typeface="Source Han Serif TW"/>
+                          <a:ea typeface="Source Han Serif TW"/>
+                          <a:cs typeface="Source Han Serif TW"/>
+                        </a:rPr>
+                        <a:t>全簡報統一使用 W/L/D/E；不得混用 W/D/L。</a:t>
+                      </a:r>
+                    </a:p>
+                  </a:txBody>
+                  <a:tcPr marL="76200" marR="76200" marT="28575" marB="28575">
+                    <a:solidFill>
+                      <a:srgbClr val="FCF8F5"/>
+                    </a:solidFill>
+                  </a:tcPr>
+                </a:tc>
+              </a:tr>
+              <a:tr h="642441">
+                <a:tc>
+                  <a:txBody>
+                    <a:bodyPr>
+                      <a:noAutofit/>
+                    </a:bodyPr>
+                    <a:lstStyle/>
+                    <a:p>
+                      <a:r>
+                        <a:rPr sz="1725" b="0">
+                          <a:solidFill>
+                            <a:srgbClr val="423C3B"/>
+                          </a:solidFill>
+                          <a:latin typeface="Source Han Serif TW"/>
+                          <a:ea typeface="Source Han Serif TW"/>
+                          <a:cs typeface="Source Han Serif TW"/>
+                        </a:rPr>
+                        <a:t>fitness 比較</a:t>
+                      </a:r>
+                    </a:p>
+                  </a:txBody>
+                  <a:tcPr marL="76200" marR="76200" marT="28575" marB="28575">
+                    <a:solidFill>
+                      <a:srgbClr val="FCF8F5"/>
+                    </a:solidFill>
+                  </a:tcPr>
+                </a:tc>
+                <a:tc>
+                  <a:txBody>
+                    <a:bodyPr>
+                      <a:noAutofit/>
+                    </a:bodyPr>
+                    <a:lstStyle/>
+                    <a:p>
+                      <a:r>
+                        <a:rPr sz="1725" b="0">
+                          <a:solidFill>
+                            <a:srgbClr val="423C3B"/>
+                          </a:solidFill>
+                          <a:latin typeface="Source Han Serif TW"/>
+                          <a:ea typeface="Source Han Serif TW"/>
+                          <a:cs typeface="Source Han Serif TW"/>
+                        </a:rPr>
+                        <a:t>Self-play snapshot 每 5 代換對手 context；跨 snapshot/run 不直接比較 GP。</a:t>
                       </a:r>
                     </a:p>
                   </a:txBody>
@@ -11776,7 +12938,7 @@
           <p:cNvPr id="6" name="">
             <a:extLst>
               <a:ext uri="{FF2B5EF4-FFF2-40B4-BE49-F238E27FC236}">
-                <ns2:creationId id="{51ABC6E5-8166-41C9-9659-A5F75305E50A}"/>
+                <ns2:creationId id="{FD69D6F4-3102-44A3-A6E9-BE9116442979}"/>
               </a:ext>
             </a:extLst>
           </p:cNvPr>
@@ -11787,8 +12949,8 @@
         </p:nvSpPr>
         <p:spPr>
           <a:xfrm>
-            <a:off x="1451282" y="6180832"/>
-            <a:ext cx="12955642" cy="682823"/>
+            <a:off x="1428750" y="7282160"/>
+            <a:ext cx="12955642" cy="572691"/>
           </a:xfrm>
           <a:prstGeom prst="rect">
             <a:avLst/>
@@ -11805,9 +12967,9 @@
           <a:lstStyle/>
           <a:p>
             <a:pPr>
-              <a:defRPr sz="1208" b="0">
-                <a:solidFill>
-                  <a:srgbClr val="423C3B"/>
+              <a:defRPr sz="2070" b="1">
+                <a:solidFill>
+                  <a:srgbClr val="47171C"/>
                 </a:solidFill>
                 <a:latin typeface="Source Han Serif TW"/>
                 <a:ea typeface="Source Han Serif TW"/>
@@ -11815,15 +12977,15 @@
               </a:defRPr>
             </a:pPr>
             <a:r>
-              <a:rPr sz="1208" b="0">
-                <a:solidFill>
-                  <a:srgbClr val="423C3B"/>
+              <a:rPr sz="2070" b="1">
+                <a:solidFill>
+                  <a:srgbClr val="47171C"/>
                 </a:solidFill>
                 <a:latin typeface="Source Han Serif TW"/>
                 <a:ea typeface="Source Han Serif TW"/>
                 <a:cs typeface="Source Han Serif TW"/>
               </a:rPr>
-              <a:t>Notion sources: https://app.notion.com/p/3eac9b9735d9810d87b4ce89769bd4b6 ; https://app.notion.com/p/3eac9b9735d981f78c00e9a7706af646 ; https://app.notion.com/p/3eac9b9735d98115b78be874b606a195 ; https://app.notion.com/p/3eac9b9735d981518b7cf0dfe691ade7</a:t>
+              <a:t>外部泛化統一看共同 600 場 fixed-roster final test 的 W/L/D/E</a:t>
             </a:r>
           </a:p>
         </p:txBody>
@@ -11868,7 +13030,7 @@
                 <a:cs typeface="Source Han Serif TW"/>
               </a:defRPr>
             </a:pPr>
-            <a:fld id="{76BB165B-A82F-4847-B8F3-06D00334483E}" type="slidenum">
+            <a:fld id="{7FCAA458-BF19-4FE1-8284-FE773A5CB6A4}" type="slidenum">
               <a:rPr sz="1650" b="0">
                 <a:solidFill>
                   <a:srgbClr val="CF8792"/>
@@ -11877,7 +13039,7 @@
                 <a:ea typeface="Source Han Serif TW"/>
                 <a:cs typeface="Source Han Serif TW"/>
               </a:rPr>
-              <a:t>18</a:t>
+              <a:t>2</a:t>
             </a:fld>
           </a:p>
         </p:txBody>
@@ -11885,14 +13047,14 @@
     </p:spTree>
     <p:extLst>
       <p:ext uri="{BB962C8B-B14F-4D97-AF65-F5344CB8AC3E}">
-        <ns3:creationId val="943265581"/>
+        <ns3:creationId val="1197658639"/>
       </p:ext>
     </p:extLst>
   </p:cSld>
 </p:sld>
 </file>
 
-<file path=ppt/slides/slide2.xml><?xml version="1.0" encoding="utf-8"?>
+<file path=ppt/slides/slide20.xml><?xml version="1.0" encoding="utf-8"?>
 <p:sld xmlns:a="http://schemas.openxmlformats.org/drawingml/2006/main" xmlns:ns2="http://schemas.microsoft.com/office/drawing/2014/main" xmlns:ns3="http://schemas.microsoft.com/office/powerpoint/2010/main" xmlns:p="http://schemas.openxmlformats.org/presentationml/2006/main" showMasterSp="1">
   <p:cSld>
     <p:spTree>
@@ -11909,7 +13071,7 @@
           <p:cNvPr id="12" name="EAGLE_0">
             <a:extLst>
               <a:ext uri="{FF2B5EF4-FFF2-40B4-BE49-F238E27FC236}">
-                <ns2:creationId id="{82FF10C9-C1D1-40E6-BC3E-D38372AF23B4}"/>
+                <ns2:creationId id="{D82F1BA5-8726-4305-A369-2124B8795E48}"/>
               </a:ext>
             </a:extLst>
           </p:cNvPr>
@@ -11952,7 +13114,7 @@
                 <a:ea typeface="Source Han Serif TW"/>
                 <a:cs typeface="Source Han Serif TW"/>
               </a:rPr>
-              <a:t>原草稿需更新的數字與比較口徑</a:t>
+              <a:t>來源與數據限制</a:t>
             </a:r>
           </a:p>
         </p:txBody>
@@ -11962,7 +13124,7 @@
           <p:cNvPr id="13" name="EAGLE_1">
             <a:extLst>
               <a:ext uri="{FF2B5EF4-FFF2-40B4-BE49-F238E27FC236}">
-                <ns2:creationId id="{00BAB8A9-065B-426D-A63D-E01FF8059F09}"/>
+                <ns2:creationId id="{B82AE40D-0197-4D13-A3B3-7E2716755B27}"/>
               </a:ext>
             </a:extLst>
           </p:cNvPr>
@@ -12005,7 +13167,7 @@
                 <a:ea typeface="Source Han Serif TW"/>
                 <a:cs typeface="Source Han Serif TW"/>
               </a:rPr>
-              <a:t>舊版資料仍有參考價值，但不能當作最新 10×20 結果</a:t>
+              <a:t>以 canonical run artifacts 為優先；本次可用的 0924 後彙整為 Notion page + meeting snapshot</a:t>
             </a:r>
           </a:p>
         </p:txBody>
@@ -12018,7 +13180,7 @@
         </p:nvGraphicFramePr>
         <p:xfrm>
           <a:off x="1428750" y="2491383"/>
-          <a:ext cx="13068300" cy="3854648"/>
+          <a:ext cx="13068300" cy="3303984"/>
         </p:xfrm>
         <a:graphic>
           <a:graphicData uri="http://schemas.openxmlformats.org/drawingml/2006/table">
@@ -12027,27 +13189,27 @@
                 <a:tableStyleId>{8497E131-5584-4FF0-9A17-202609170001}</a:tableStyleId>
               </a:tblPr>
               <a:tblGrid>
-                <a:gridCol w="3379733"/>
-                <a:gridCol w="9688567"/>
+                <a:gridCol w="3830364"/>
+                <a:gridCol w="9237936"/>
               </a:tblGrid>
-              <a:tr h="642441">
-                <a:tc>
-                  <a:txBody>
-                    <a:bodyPr>
-                      <a:noAutofit/>
-                    </a:bodyPr>
-                    <a:lstStyle/>
-                    <a:p>
-                      <a:r>
-                        <a:rPr sz="1725" b="1">
-                          <a:solidFill>
-                            <a:srgbClr val="423C3B"/>
-                          </a:solidFill>
-                          <a:latin typeface="Source Han Serif TW"/>
-                          <a:ea typeface="Source Han Serif TW"/>
-                          <a:cs typeface="Source Han Serif TW"/>
-                        </a:rPr>
-                        <a:t>校核項目</a:t>
+              <a:tr h="550664">
+                <a:tc>
+                  <a:txBody>
+                    <a:bodyPr>
+                      <a:noAutofit/>
+                    </a:bodyPr>
+                    <a:lstStyle/>
+                    <a:p>
+                      <a:r>
+                        <a:rPr sz="1639" b="1">
+                          <a:solidFill>
+                            <a:srgbClr val="423C3B"/>
+                          </a:solidFill>
+                          <a:latin typeface="Source Han Serif TW"/>
+                          <a:ea typeface="Source Han Serif TW"/>
+                          <a:cs typeface="Source Han Serif TW"/>
+                        </a:rPr>
+                        <a:t>來源組</a:t>
                       </a:r>
                     </a:p>
                   </a:txBody>
@@ -12065,15 +13227,15 @@
                     <a:lstStyle/>
                     <a:p>
                       <a:r>
-                        <a:rPr sz="1725" b="1">
-                          <a:solidFill>
-                            <a:srgbClr val="423C3B"/>
-                          </a:solidFill>
-                          <a:latin typeface="Source Han Serif TW"/>
-                          <a:ea typeface="Source Han Serif TW"/>
-                          <a:cs typeface="Source Han Serif TW"/>
-                        </a:rPr>
-                        <a:t>校正後口徑</a:t>
+                        <a:rPr sz="1639" b="1">
+                          <a:solidFill>
+                            <a:srgbClr val="423C3B"/>
+                          </a:solidFill>
+                          <a:latin typeface="Source Han Serif TW"/>
+                          <a:ea typeface="Source Han Serif TW"/>
+                          <a:cs typeface="Source Han Serif TW"/>
+                        </a:rPr>
+                        <a:t>納入文件／記錄</a:t>
                       </a:r>
                     </a:p>
                   </a:txBody>
@@ -12084,50 +13246,50 @@
                   </a:tcPr>
                 </a:tc>
               </a:tr>
-              <a:tr h="642441">
-                <a:tc>
-                  <a:txBody>
-                    <a:bodyPr>
-                      <a:noAutofit/>
-                    </a:bodyPr>
-                    <a:lstStyle/>
-                    <a:p>
-                      <a:r>
-                        <a:rPr sz="1725" b="0">
-                          <a:solidFill>
-                            <a:srgbClr val="423C3B"/>
-                          </a:solidFill>
-                          <a:latin typeface="Source Han Serif TW"/>
-                          <a:ea typeface="Source Han Serif TW"/>
-                          <a:cs typeface="Source Han Serif TW"/>
-                        </a:rPr>
-                        <a:t>0923 10×20 與 0927 10×20</a:t>
-                      </a:r>
-                    </a:p>
-                  </a:txBody>
-                  <a:tcPr marL="76200" marR="76200" marT="28575" marB="28575">
-                    <a:solidFill>
-                      <a:srgbClr val="FCF8F5"/>
-                    </a:solidFill>
-                  </a:tcPr>
-                </a:tc>
-                <a:tc>
-                  <a:txBody>
-                    <a:bodyPr>
-                      <a:noAutofit/>
-                    </a:bodyPr>
-                    <a:lstStyle/>
-                    <a:p>
-                      <a:r>
-                        <a:rPr sz="1725" b="0">
-                          <a:solidFill>
-                            <a:srgbClr val="423C3B"/>
-                          </a:solidFill>
-                          <a:latin typeface="Source Han Serif TW"/>
-                          <a:ea typeface="Source Han Serif TW"/>
-                          <a:cs typeface="Source Han Serif TW"/>
-                        </a:rPr>
-                        <a:t>不同 run。0927 semantic tie-break 為 0/444/156/0 W/L/D/E；舊 0923 為 0/449/151/0。</a:t>
+              <a:tr h="550664">
+                <a:tc>
+                  <a:txBody>
+                    <a:bodyPr>
+                      <a:noAutofit/>
+                    </a:bodyPr>
+                    <a:lstStyle/>
+                    <a:p>
+                      <a:r>
+                        <a:rPr sz="1639" b="0">
+                          <a:solidFill>
+                            <a:srgbClr val="423C3B"/>
+                          </a:solidFill>
+                          <a:latin typeface="Source Han Serif TW"/>
+                          <a:ea typeface="Source Han Serif TW"/>
+                          <a:cs typeface="Source Han Serif TW"/>
+                        </a:rPr>
+                        <a:t>Single-objective 主分析</a:t>
+                      </a:r>
+                    </a:p>
+                  </a:txBody>
+                  <a:tcPr marL="76200" marR="76200" marT="28575" marB="28575">
+                    <a:solidFill>
+                      <a:srgbClr val="FCF8F5"/>
+                    </a:solidFill>
+                  </a:tcPr>
+                </a:tc>
+                <a:tc>
+                  <a:txBody>
+                    <a:bodyPr>
+                      <a:noAutofit/>
+                    </a:bodyPr>
+                    <a:lstStyle/>
+                    <a:p>
+                      <a:r>
+                        <a:rPr sz="1639" b="0">
+                          <a:solidFill>
+                            <a:srgbClr val="423C3B"/>
+                          </a:solidFill>
+                          <a:latin typeface="Source Han Serif TW"/>
+                          <a:ea typeface="Source Han Serif TW"/>
+                          <a:cs typeface="Source Han Serif TW"/>
+                        </a:rPr>
+                        <a:t>Notion 0926 10×10、0926 5×20、0927 10×20；09/29 整理頁補充 run delta、candidate、refresh 與 opponent evidence</a:t>
                       </a:r>
                     </a:p>
                   </a:txBody>
@@ -12138,50 +13300,50 @@
                   </a:tcPr>
                 </a:tc>
               </a:tr>
-              <a:tr h="642441">
-                <a:tc>
-                  <a:txBody>
-                    <a:bodyPr>
-                      <a:noAutofit/>
-                    </a:bodyPr>
-                    <a:lstStyle/>
-                    <a:p>
-                      <a:r>
-                        <a:rPr sz="1725" b="0">
-                          <a:solidFill>
-                            <a:srgbClr val="423C3B"/>
-                          </a:solidFill>
-                          <a:latin typeface="Source Han Serif TW"/>
-                          <a:ea typeface="Source Han Serif TW"/>
-                          <a:cs typeface="Source Han Serif TW"/>
-                        </a:rPr>
-                        <a:t>0925 5×40 evaluation</a:t>
-                      </a:r>
-                    </a:p>
-                  </a:txBody>
-                  <a:tcPr marL="76200" marR="76200" marT="28575" marB="28575">
-                    <a:solidFill>
-                      <a:srgbClr val="FCF8F5"/>
-                    </a:solidFill>
-                  </a:tcPr>
-                </a:tc>
-                <a:tc>
-                  <a:txBody>
-                    <a:bodyPr>
-                      <a:noAutofit/>
-                    </a:bodyPr>
-                    <a:lstStyle/>
-                    <a:p>
-                      <a:r>
-                        <a:rPr sz="1725" b="0">
-                          <a:solidFill>
-                            <a:srgbClr val="423C3B"/>
-                          </a:solidFill>
-                          <a:latin typeface="Source Han Serif TW"/>
-                          <a:ea typeface="Source Han Serif TW"/>
-                          <a:cs typeface="Source Han Serif TW"/>
-                        </a:rPr>
-                        <a:t>舊 lexicase 對 10 個 self-play snapshot opponents；不是單一 game_performance 目標，排除主表。</a:t>
+              <a:tr h="550664">
+                <a:tc>
+                  <a:txBody>
+                    <a:bodyPr>
+                      <a:noAutofit/>
+                    </a:bodyPr>
+                    <a:lstStyle/>
+                    <a:p>
+                      <a:r>
+                        <a:rPr sz="1639" b="0">
+                          <a:solidFill>
+                            <a:srgbClr val="423C3B"/>
+                          </a:solidFill>
+                          <a:latin typeface="Source Han Serif TW"/>
+                          <a:ea typeface="Source Han Serif TW"/>
+                          <a:cs typeface="Source Han Serif TW"/>
+                        </a:rPr>
+                        <a:t>evaluation-mode control</a:t>
+                      </a:r>
+                    </a:p>
+                  </a:txBody>
+                  <a:tcPr marL="76200" marR="76200" marT="28575" marB="28575">
+                    <a:solidFill>
+                      <a:srgbClr val="FCF8F5"/>
+                    </a:solidFill>
+                  </a:tcPr>
+                </a:tc>
+                <a:tc>
+                  <a:txBody>
+                    <a:bodyPr>
+                      <a:noAutofit/>
+                    </a:bodyPr>
+                    <a:lstStyle/>
+                    <a:p>
+                      <a:r>
+                        <a:rPr sz="1639" b="0">
+                          <a:solidFill>
+                            <a:srgbClr val="423C3B"/>
+                          </a:solidFill>
+                          <a:latin typeface="Source Han Serif TW"/>
+                          <a:ea typeface="Source Han Serif TW"/>
+                          <a:cs typeface="Source Han Serif TW"/>
+                        </a:rPr>
+                        <a:t>09/11 fixed-roster 10×20 歷史 run；0929 同設定重跑 config 待執行</a:t>
                       </a:r>
                     </a:p>
                   </a:txBody>
@@ -12192,50 +13354,50 @@
                   </a:tcPr>
                 </a:tc>
               </a:tr>
-              <a:tr h="642441">
-                <a:tc>
-                  <a:txBody>
-                    <a:bodyPr>
-                      <a:noAutofit/>
-                    </a:bodyPr>
-                    <a:lstStyle/>
-                    <a:p>
-                      <a:r>
-                        <a:rPr sz="1725" b="0">
-                          <a:solidFill>
-                            <a:srgbClr val="423C3B"/>
-                          </a:solidFill>
-                          <a:latin typeface="Source Han Serif TW"/>
-                          <a:ea typeface="Source Han Serif TW"/>
-                          <a:cs typeface="Source Han Serif TW"/>
-                        </a:rPr>
-                        <a:t>單一目標範圍</a:t>
-                      </a:r>
-                    </a:p>
-                  </a:txBody>
-                  <a:tcPr marL="76200" marR="76200" marT="28575" marB="28575">
-                    <a:solidFill>
-                      <a:srgbClr val="FCF8F5"/>
-                    </a:solidFill>
-                  </a:tcPr>
-                </a:tc>
-                <a:tc>
-                  <a:txBody>
-                    <a:bodyPr>
-                      <a:noAutofit/>
-                    </a:bodyPr>
-                    <a:lstStyle/>
-                    <a:p>
-                      <a:r>
-                        <a:rPr sz="1725" b="0">
-                          <a:solidFill>
-                            <a:srgbClr val="423C3B"/>
-                          </a:solidFill>
-                          <a:latin typeface="Source Han Serif TW"/>
-                          <a:ea typeface="Source Han Serif TW"/>
-                          <a:cs typeface="Source Han Serif TW"/>
-                        </a:rPr>
-                        <a:t>0926–0927 三組只有 game_performance 數值目標；semantic tie-break 有使用、但只在 fitness 差距 ≤1.0 時決勝。</a:t>
+              <a:tr h="550664">
+                <a:tc>
+                  <a:txBody>
+                    <a:bodyPr>
+                      <a:noAutofit/>
+                    </a:bodyPr>
+                    <a:lstStyle/>
+                    <a:p>
+                      <a:r>
+                        <a:rPr sz="1639" b="0">
+                          <a:solidFill>
+                            <a:srgbClr val="423C3B"/>
+                          </a:solidFill>
+                          <a:latin typeface="Source Han Serif TW"/>
+                          <a:ea typeface="Source Han Serif TW"/>
+                          <a:cs typeface="Source Han Serif TW"/>
+                        </a:rPr>
+                        <a:t>Earlier controlled studies</a:t>
+                      </a:r>
+                    </a:p>
+                  </a:txBody>
+                  <a:tcPr marL="76200" marR="76200" marT="28575" marB="28575">
+                    <a:solidFill>
+                      <a:srgbClr val="FCF8F5"/>
+                    </a:solidFill>
+                  </a:tcPr>
+                </a:tc>
+                <a:tc>
+                  <a:txBody>
+                    <a:bodyPr>
+                      <a:noAutofit/>
+                    </a:bodyPr>
+                    <a:lstStyle/>
+                    <a:p>
+                      <a:r>
+                        <a:rPr sz="1639" b="0">
+                          <a:solidFill>
+                            <a:srgbClr val="423C3B"/>
+                          </a:solidFill>
+                          <a:latin typeface="Source Han Serif TW"/>
+                          <a:ea typeface="Source Han Serif TW"/>
+                          <a:cs typeface="Source Han Serif TW"/>
+                        </a:rPr>
+                        <a:t>09/07 reflection、09/10 model、09/12 initialization、09/14 parent regeneration</a:t>
                       </a:r>
                     </a:p>
                   </a:txBody>
@@ -12246,50 +13408,50 @@
                   </a:tcPr>
                 </a:tc>
               </a:tr>
-              <a:tr h="642441">
-                <a:tc>
-                  <a:txBody>
-                    <a:bodyPr>
-                      <a:noAutofit/>
-                    </a:bodyPr>
-                    <a:lstStyle/>
-                    <a:p>
-                      <a:r>
-                        <a:rPr sz="1725" b="0">
-                          <a:solidFill>
-                            <a:srgbClr val="423C3B"/>
-                          </a:solidFill>
-                          <a:latin typeface="Source Han Serif TW"/>
-                          <a:ea typeface="Source Han Serif TW"/>
-                          <a:cs typeface="Source Han Serif TW"/>
-                        </a:rPr>
-                        <a:t>比分順序</a:t>
-                      </a:r>
-                    </a:p>
-                  </a:txBody>
-                  <a:tcPr marL="76200" marR="76200" marT="28575" marB="28575">
-                    <a:solidFill>
-                      <a:srgbClr val="FCF8F5"/>
-                    </a:solidFill>
-                  </a:tcPr>
-                </a:tc>
-                <a:tc>
-                  <a:txBody>
-                    <a:bodyPr>
-                      <a:noAutofit/>
-                    </a:bodyPr>
-                    <a:lstStyle/>
-                    <a:p>
-                      <a:r>
-                        <a:rPr sz="1725" b="0">
-                          <a:solidFill>
-                            <a:srgbClr val="423C3B"/>
-                          </a:solidFill>
-                          <a:latin typeface="Source Han Serif TW"/>
-                          <a:ea typeface="Source Han Serif TW"/>
-                          <a:cs typeface="Source Han Serif TW"/>
-                        </a:rPr>
-                        <a:t>全簡報統一使用 W/L/D/E；不得混用 W/D/L。</a:t>
+              <a:tr h="550664">
+                <a:tc>
+                  <a:txBody>
+                    <a:bodyPr>
+                      <a:noAutofit/>
+                    </a:bodyPr>
+                    <a:lstStyle/>
+                    <a:p>
+                      <a:r>
+                        <a:rPr sz="1639" b="0">
+                          <a:solidFill>
+                            <a:srgbClr val="423C3B"/>
+                          </a:solidFill>
+                          <a:latin typeface="Source Han Serif TW"/>
+                          <a:ea typeface="Source Han Serif TW"/>
+                          <a:cs typeface="Source Han Serif TW"/>
+                        </a:rPr>
+                        <a:t>Pre-0924 artifact cleanup</a:t>
+                      </a:r>
+                    </a:p>
+                  </a:txBody>
+                  <a:tcPr marL="76200" marR="76200" marT="28575" marB="28575">
+                    <a:solidFill>
+                      <a:srgbClr val="FCF8F5"/>
+                    </a:solidFill>
+                  </a:tcPr>
+                </a:tc>
+                <a:tc>
+                  <a:txBody>
+                    <a:bodyPr>
+                      <a:noAutofit/>
+                    </a:bodyPr>
+                    <a:lstStyle/>
+                    <a:p>
+                      <a:r>
+                        <a:rPr sz="1639" b="0">
+                          <a:solidFill>
+                            <a:srgbClr val="423C3B"/>
+                          </a:solidFill>
+                          <a:latin typeface="Source Han Serif TW"/>
+                          <a:ea typeface="Source Han Serif TW"/>
+                          <a:cs typeface="Source Han Serif TW"/>
+                        </a:rPr>
+                        <a:t>依確認刪除 21 個未引用且非 control 的 raw runs（約 70 GB）；control、baseline、seed/model audit 與現行比較資料保留</a:t>
                       </a:r>
                     </a:p>
                   </a:txBody>
@@ -12300,50 +13462,50 @@
                   </a:tcPr>
                 </a:tc>
               </a:tr>
-              <a:tr h="642441">
-                <a:tc>
-                  <a:txBody>
-                    <a:bodyPr>
-                      <a:noAutofit/>
-                    </a:bodyPr>
-                    <a:lstStyle/>
-                    <a:p>
-                      <a:r>
-                        <a:rPr sz="1725" b="0">
-                          <a:solidFill>
-                            <a:srgbClr val="423C3B"/>
-                          </a:solidFill>
-                          <a:latin typeface="Source Han Serif TW"/>
-                          <a:ea typeface="Source Han Serif TW"/>
-                          <a:cs typeface="Source Han Serif TW"/>
-                        </a:rPr>
-                        <a:t>fitness 比較</a:t>
-                      </a:r>
-                    </a:p>
-                  </a:txBody>
-                  <a:tcPr marL="76200" marR="76200" marT="28575" marB="28575">
-                    <a:solidFill>
-                      <a:srgbClr val="FCF8F5"/>
-                    </a:solidFill>
-                  </a:tcPr>
-                </a:tc>
-                <a:tc>
-                  <a:txBody>
-                    <a:bodyPr>
-                      <a:noAutofit/>
-                    </a:bodyPr>
-                    <a:lstStyle/>
-                    <a:p>
-                      <a:r>
-                        <a:rPr sz="1725" b="0">
-                          <a:solidFill>
-                            <a:srgbClr val="423C3B"/>
-                          </a:solidFill>
-                          <a:latin typeface="Source Han Serif TW"/>
-                          <a:ea typeface="Source Han Serif TW"/>
-                          <a:cs typeface="Source Han Serif TW"/>
-                        </a:rPr>
-                        <a:t>Self-play snapshot 每 5 代換對手 context；跨 snapshot/run 不直接比較 GP。</a:t>
+              <a:tr h="550664">
+                <a:tc>
+                  <a:txBody>
+                    <a:bodyPr>
+                      <a:noAutofit/>
+                    </a:bodyPr>
+                    <a:lstStyle/>
+                    <a:p>
+                      <a:r>
+                        <a:rPr sz="1639" b="0">
+                          <a:solidFill>
+                            <a:srgbClr val="423C3B"/>
+                          </a:solidFill>
+                          <a:latin typeface="Source Han Serif TW"/>
+                          <a:ea typeface="Source Han Serif TW"/>
+                          <a:cs typeface="Source Han Serif TW"/>
+                        </a:rPr>
+                        <a:t>Limit</a:t>
+                      </a:r>
+                    </a:p>
+                  </a:txBody>
+                  <a:tcPr marL="76200" marR="76200" marT="28575" marB="28575">
+                    <a:solidFill>
+                      <a:srgbClr val="FCF8F5"/>
+                    </a:solidFill>
+                  </a:tcPr>
+                </a:tc>
+                <a:tc>
+                  <a:txBody>
+                    <a:bodyPr>
+                      <a:noAutofit/>
+                    </a:bodyPr>
+                    <a:lstStyle/>
+                    <a:p>
+                      <a:r>
+                        <a:rPr sz="1639" b="0">
+                          <a:solidFill>
+                            <a:srgbClr val="423C3B"/>
+                          </a:solidFill>
+                          <a:latin typeface="Source Han Serif TW"/>
+                          <a:ea typeface="Source Han Serif TW"/>
+                          <a:cs typeface="Source Han Serif TW"/>
+                        </a:rPr>
+                        <a:t>0929 5×40 與 fixed-opponent control configs 尚未執行；近期細節以 Notion 09/29 page 和 analysis_md 為證據。</a:t>
                       </a:r>
                     </a:p>
                   </a:txBody>
@@ -12363,7 +13525,7 @@
           <p:cNvPr id="6" name="">
             <a:extLst>
               <a:ext uri="{FF2B5EF4-FFF2-40B4-BE49-F238E27FC236}">
-                <ns2:creationId id="{8BA21B76-54FF-41C1-BCE8-F9B7CEB45427}"/>
+                <ns2:creationId id="{07ED2067-951A-474B-8E40-F48EDCEAE8D6}"/>
               </a:ext>
             </a:extLst>
           </p:cNvPr>
@@ -12374,8 +13536,8 @@
         </p:nvSpPr>
         <p:spPr>
           <a:xfrm>
-            <a:off x="1428750" y="7282160"/>
-            <a:ext cx="12955642" cy="572691"/>
+            <a:off x="1451282" y="6180832"/>
+            <a:ext cx="12955642" cy="682823"/>
           </a:xfrm>
           <a:prstGeom prst="rect">
             <a:avLst/>
@@ -12392,9 +13554,9 @@
           <a:lstStyle/>
           <a:p>
             <a:pPr>
-              <a:defRPr sz="2070" b="1">
-                <a:solidFill>
-                  <a:srgbClr val="47171C"/>
+              <a:defRPr sz="1208" b="0">
+                <a:solidFill>
+                  <a:srgbClr val="423C3B"/>
                 </a:solidFill>
                 <a:latin typeface="Source Han Serif TW"/>
                 <a:ea typeface="Source Han Serif TW"/>
@@ -12402,15 +13564,15 @@
               </a:defRPr>
             </a:pPr>
             <a:r>
-              <a:rPr sz="2070" b="1">
-                <a:solidFill>
-                  <a:srgbClr val="47171C"/>
+              <a:rPr sz="1208" b="0">
+                <a:solidFill>
+                  <a:srgbClr val="423C3B"/>
                 </a:solidFill>
                 <a:latin typeface="Source Han Serif TW"/>
                 <a:ea typeface="Source Han Serif TW"/>
                 <a:cs typeface="Source Han Serif TW"/>
               </a:rPr>
-              <a:t>外部泛化統一看共同 600 場 fixed-roster final test 的 W/L/D/E</a:t>
+              <a:t>Notion sources: https://app.notion.com/p/3eac9b9735d9810d87b4ce89769bd4b6 ; https://app.notion.com/p/3eac9b9735d981f78c00e9a7706af646 ; https://app.notion.com/p/3eac9b9735d98115b78be874b606a195 ; https://app.notion.com/p/3eac9b9735d981518b7cf0dfe691ade7</a:t>
             </a:r>
           </a:p>
         </p:txBody>
@@ -12455,7 +13617,7 @@
                 <a:cs typeface="Source Han Serif TW"/>
               </a:defRPr>
             </a:pPr>
-            <a:fld id="{3E7E6945-CF90-48AB-806F-EE7AECD183F3}" type="slidenum">
+            <a:fld id="{C679EEAB-AB37-46BB-8C1F-364870C7686F}" type="slidenum">
               <a:rPr sz="1650" b="0">
                 <a:solidFill>
                   <a:srgbClr val="CF8792"/>
@@ -12464,7 +13626,7 @@
                 <a:ea typeface="Source Han Serif TW"/>
                 <a:cs typeface="Source Han Serif TW"/>
               </a:rPr>
-              <a:t>2</a:t>
+              <a:t>20</a:t>
             </a:fld>
           </a:p>
         </p:txBody>
@@ -12472,7 +13634,7 @@
     </p:spTree>
     <p:extLst>
       <p:ext uri="{BB962C8B-B14F-4D97-AF65-F5344CB8AC3E}">
-        <ns3:creationId val="1171926029"/>
+        <ns3:creationId val="1674290150"/>
       </p:ext>
     </p:extLst>
   </p:cSld>
@@ -12496,7 +13658,7 @@
           <p:cNvPr id="13" name="EAGLE_0">
             <a:extLst>
               <a:ext uri="{FF2B5EF4-FFF2-40B4-BE49-F238E27FC236}">
-                <ns2:creationId id="{6A0866E3-73E7-454B-8D0B-6B88B91FDD30}"/>
+                <ns2:creationId id="{381A7667-6AB0-49B8-BC4C-32F7883F2B94}"/>
               </a:ext>
             </a:extLst>
           </p:cNvPr>
@@ -12549,7 +13711,7 @@
           <p:cNvPr id="14" name="EAGLE_1">
             <a:extLst>
               <a:ext uri="{FF2B5EF4-FFF2-40B4-BE49-F238E27FC236}">
-                <ns2:creationId id="{54224C64-CD1C-49EE-8EEC-86DC45997282}"/>
+                <ns2:creationId id="{72CF0B8C-A78B-488A-99F0-3416A0ECABE3}"/>
               </a:ext>
             </a:extLst>
           </p:cNvPr>
@@ -13027,7 +14189,7 @@
           <p:cNvPr id="6" name="">
             <a:extLst>
               <a:ext uri="{FF2B5EF4-FFF2-40B4-BE49-F238E27FC236}">
-                <ns2:creationId id="{4A7035BC-9B16-4376-BB92-E073A309079C}"/>
+                <ns2:creationId id="{91FEB417-EB89-430A-A6E7-0125116993A5}"/>
               </a:ext>
             </a:extLst>
           </p:cNvPr>
@@ -13084,7 +14246,7 @@
           <p:cNvPr id="7" name="">
             <a:extLst>
               <a:ext uri="{FF2B5EF4-FFF2-40B4-BE49-F238E27FC236}">
-                <ns2:creationId id="{AB31584A-8235-4BA2-BB06-A2EE80751ABB}"/>
+                <ns2:creationId id="{9223310D-76A2-4D63-B5AB-F00A1C215903}"/>
               </a:ext>
             </a:extLst>
           </p:cNvPr>
@@ -13176,7 +14338,7 @@
                 <a:cs typeface="Source Han Serif TW"/>
               </a:defRPr>
             </a:pPr>
-            <a:fld id="{67B380AF-91E5-4E63-B856-53CE6A1F8137}" type="slidenum">
+            <a:fld id="{C31744E4-EAA5-4157-B37A-F6220FF92768}" type="slidenum">
               <a:rPr sz="1650" b="0">
                 <a:solidFill>
                   <a:srgbClr val="CF8792"/>
@@ -13193,7 +14355,7 @@
     </p:spTree>
     <p:extLst>
       <p:ext uri="{BB962C8B-B14F-4D97-AF65-F5344CB8AC3E}">
-        <ns3:creationId val="1385412734"/>
+        <ns3:creationId val="1294459967"/>
       </p:ext>
     </p:extLst>
   </p:cSld>
@@ -13217,7 +14379,7 @@
           <p:cNvPr id="13" name="EAGLE_0">
             <a:extLst>
               <a:ext uri="{FF2B5EF4-FFF2-40B4-BE49-F238E27FC236}">
-                <ns2:creationId id="{BEFB1342-78DB-4013-B54F-EFFC5F9DCDFF}"/>
+                <ns2:creationId id="{9065A990-E636-4E36-A9C2-5F64EC014AAD}"/>
               </a:ext>
             </a:extLst>
           </p:cNvPr>
@@ -13270,7 +14432,7 @@
           <p:cNvPr id="14" name="EAGLE_1">
             <a:extLst>
               <a:ext uri="{FF2B5EF4-FFF2-40B4-BE49-F238E27FC236}">
-                <ns2:creationId id="{25D8BF36-332D-436A-856A-396A5AE82AFA}"/>
+                <ns2:creationId id="{1C0578DA-93CC-4E98-8F02-3D8A3C9567B4}"/>
               </a:ext>
             </a:extLst>
           </p:cNvPr>
@@ -13828,7 +14990,7 @@
           <p:cNvPr id="6" name="">
             <a:extLst>
               <a:ext uri="{FF2B5EF4-FFF2-40B4-BE49-F238E27FC236}">
-                <ns2:creationId id="{F21A828F-1FEB-412E-8A46-62960EDDB948}"/>
+                <ns2:creationId id="{9DEEB057-619D-4D1D-840F-C93A325FA585}"/>
               </a:ext>
             </a:extLst>
           </p:cNvPr>
@@ -13885,7 +15047,7 @@
           <p:cNvPr id="7" name="">
             <a:extLst>
               <a:ext uri="{FF2B5EF4-FFF2-40B4-BE49-F238E27FC236}">
-                <ns2:creationId id="{4842D059-A6DF-41D5-813E-B16FEED5CCC7}"/>
+                <ns2:creationId id="{EB998351-F665-40E0-8E1E-5854C5E302B2}"/>
               </a:ext>
             </a:extLst>
           </p:cNvPr>
@@ -13977,7 +15139,7 @@
                 <a:cs typeface="Source Han Serif TW"/>
               </a:defRPr>
             </a:pPr>
-            <a:fld id="{61A0C9F6-A030-4429-82D8-7A8C5BEE4F38}" type="slidenum">
+            <a:fld id="{5B4DF481-E62C-43AE-A85C-FE139D573547}" type="slidenum">
               <a:rPr sz="1650" b="0">
                 <a:solidFill>
                   <a:srgbClr val="CF8792"/>
@@ -13994,7 +15156,7 @@
     </p:spTree>
     <p:extLst>
       <p:ext uri="{BB962C8B-B14F-4D97-AF65-F5344CB8AC3E}">
-        <ns3:creationId val="800909425"/>
+        <ns3:creationId val="1187093144"/>
       </p:ext>
     </p:extLst>
   </p:cSld>
@@ -14018,7 +15180,7 @@
           <p:cNvPr id="13" name="EAGLE_0">
             <a:extLst>
               <a:ext uri="{FF2B5EF4-FFF2-40B4-BE49-F238E27FC236}">
-                <ns2:creationId id="{F0E02D47-8A10-4F99-8925-D8081FEF04A6}"/>
+                <ns2:creationId id="{441C0B83-25E2-4BC0-AA13-10EEAF9469B6}"/>
               </a:ext>
             </a:extLst>
           </p:cNvPr>
@@ -14071,7 +15233,7 @@
           <p:cNvPr id="14" name="EAGLE_1">
             <a:extLst>
               <a:ext uri="{FF2B5EF4-FFF2-40B4-BE49-F238E27FC236}">
-                <ns2:creationId id="{4A8D6A0D-9287-4E2E-814C-49ED543A62E3}"/>
+                <ns2:creationId id="{CFA66C50-7967-4789-9832-508E5723FF9F}"/>
               </a:ext>
             </a:extLst>
           </p:cNvPr>
@@ -14549,7 +15711,7 @@
           <p:cNvPr id="6" name="">
             <a:extLst>
               <a:ext uri="{FF2B5EF4-FFF2-40B4-BE49-F238E27FC236}">
-                <ns2:creationId id="{30C11FC0-8629-4F13-8482-D9DE56FCDA6A}"/>
+                <ns2:creationId id="{DDF8DFF1-30A9-43A4-89BF-B5A15337850D}"/>
               </a:ext>
             </a:extLst>
           </p:cNvPr>
@@ -14606,7 +15768,7 @@
           <p:cNvPr id="7" name="">
             <a:extLst>
               <a:ext uri="{FF2B5EF4-FFF2-40B4-BE49-F238E27FC236}">
-                <ns2:creationId id="{6F71B1E1-2608-4F15-9E9D-4FF788EF2419}"/>
+                <ns2:creationId id="{A1892286-3512-449C-BFE9-28BABC234F40}"/>
               </a:ext>
             </a:extLst>
           </p:cNvPr>
@@ -14698,7 +15860,7 @@
                 <a:cs typeface="Source Han Serif TW"/>
               </a:defRPr>
             </a:pPr>
-            <a:fld id="{9A5A8FFC-B84A-4C5E-BE5F-4E781328FB02}" type="slidenum">
+            <a:fld id="{F0E7D07A-E2BE-40AF-BBDD-C38670F12563}" type="slidenum">
               <a:rPr sz="1650" b="0">
                 <a:solidFill>
                   <a:srgbClr val="CF8792"/>
@@ -14715,7 +15877,7 @@
     </p:spTree>
     <p:extLst>
       <p:ext uri="{BB962C8B-B14F-4D97-AF65-F5344CB8AC3E}">
-        <ns3:creationId val="1287304546"/>
+        <ns3:creationId val="1884146934"/>
       </p:ext>
     </p:extLst>
   </p:cSld>
@@ -14739,7 +15901,7 @@
           <p:cNvPr id="13" name="EAGLE_0">
             <a:extLst>
               <a:ext uri="{FF2B5EF4-FFF2-40B4-BE49-F238E27FC236}">
-                <ns2:creationId id="{2A5584A0-813D-4AEE-93DD-39FEEA7C9DDF}"/>
+                <ns2:creationId id="{92192B96-CDA4-4110-9AA6-F64D302AED46}"/>
               </a:ext>
             </a:extLst>
           </p:cNvPr>
@@ -14792,7 +15954,7 @@
           <p:cNvPr id="14" name="EAGLE_1">
             <a:extLst>
               <a:ext uri="{FF2B5EF4-FFF2-40B4-BE49-F238E27FC236}">
-                <ns2:creationId id="{01B6F3C5-ADB8-4470-96A1-A0CA7734C274}"/>
+                <ns2:creationId id="{F0ED12C8-9D3E-4D75-8C5C-062F825C6D78}"/>
               </a:ext>
             </a:extLst>
           </p:cNvPr>
@@ -15270,7 +16432,7 @@
           <p:cNvPr id="6" name="">
             <a:extLst>
               <a:ext uri="{FF2B5EF4-FFF2-40B4-BE49-F238E27FC236}">
-                <ns2:creationId id="{391EB4F8-149D-444B-90BA-E10E100284C7}"/>
+                <ns2:creationId id="{F1057295-1961-40B9-81AE-DD420B908BC7}"/>
               </a:ext>
             </a:extLst>
           </p:cNvPr>
@@ -15327,7 +16489,7 @@
           <p:cNvPr id="7" name="">
             <a:extLst>
               <a:ext uri="{FF2B5EF4-FFF2-40B4-BE49-F238E27FC236}">
-                <ns2:creationId id="{A5E7E2C6-A960-4A45-A7E9-177D131DC1B6}"/>
+                <ns2:creationId id="{94944C27-8F02-42D1-AC4C-2532C6749B63}"/>
               </a:ext>
             </a:extLst>
           </p:cNvPr>
@@ -15419,7 +16581,7 @@
                 <a:cs typeface="Source Han Serif TW"/>
               </a:defRPr>
             </a:pPr>
-            <a:fld id="{44EE84E2-EB35-4199-AA4A-810169245AD5}" type="slidenum">
+            <a:fld id="{47189480-CF32-4787-9D48-C6F2167B3612}" type="slidenum">
               <a:rPr sz="1650" b="0">
                 <a:solidFill>
                   <a:srgbClr val="CF8792"/>
@@ -15436,7 +16598,7 @@
     </p:spTree>
     <p:extLst>
       <p:ext uri="{BB962C8B-B14F-4D97-AF65-F5344CB8AC3E}">
-        <ns3:creationId val="266163929"/>
+        <ns3:creationId val="1955104643"/>
       </p:ext>
     </p:extLst>
   </p:cSld>
@@ -15460,7 +16622,7 @@
           <p:cNvPr id="13" name="EAGLE_0">
             <a:extLst>
               <a:ext uri="{FF2B5EF4-FFF2-40B4-BE49-F238E27FC236}">
-                <ns2:creationId id="{57B356E1-1DE6-40ED-90D6-8AE53000C480}"/>
+                <ns2:creationId id="{2BD947C2-70B7-450E-A040-01DC3A6A9F65}"/>
               </a:ext>
             </a:extLst>
           </p:cNvPr>
@@ -15513,7 +16675,7 @@
           <p:cNvPr id="14" name="EAGLE_1">
             <a:extLst>
               <a:ext uri="{FF2B5EF4-FFF2-40B4-BE49-F238E27FC236}">
-                <ns2:creationId id="{3269C2C8-8879-4B73-9949-6A02DBC16C87}"/>
+                <ns2:creationId id="{83689BD7-709E-4E11-A26C-A2DE45823ADE}"/>
               </a:ext>
             </a:extLst>
           </p:cNvPr>
@@ -15806,7 +16968,7 @@
           <p:cNvPr id="6" name="">
             <a:extLst>
               <a:ext uri="{FF2B5EF4-FFF2-40B4-BE49-F238E27FC236}">
-                <ns2:creationId id="{FE1DD4BD-5C1F-4795-98EA-AA1E55D779AD}"/>
+                <ns2:creationId id="{FA1FE105-8DE3-4052-94C0-6976E18ED637}"/>
               </a:ext>
             </a:extLst>
           </p:cNvPr>
@@ -15863,7 +17025,7 @@
           <p:cNvPr id="7" name="">
             <a:extLst>
               <a:ext uri="{FF2B5EF4-FFF2-40B4-BE49-F238E27FC236}">
-                <ns2:creationId id="{CD8A6A59-C231-4895-9A8F-D173539D1627}"/>
+                <ns2:creationId id="{8222CF7E-2F54-4504-82A0-74E3A61A0C4A}"/>
               </a:ext>
             </a:extLst>
           </p:cNvPr>
@@ -15955,7 +17117,7 @@
                 <a:cs typeface="Source Han Serif TW"/>
               </a:defRPr>
             </a:pPr>
-            <a:fld id="{E1CA52C4-97F8-4AC2-9A96-4D7030F4A1A7}" type="slidenum">
+            <a:fld id="{558F135F-A780-410E-9BAA-4C4920203A79}" type="slidenum">
               <a:rPr sz="1650" b="0">
                 <a:solidFill>
                   <a:srgbClr val="CF8792"/>
@@ -15972,7 +17134,7 @@
     </p:spTree>
     <p:extLst>
       <p:ext uri="{BB962C8B-B14F-4D97-AF65-F5344CB8AC3E}">
-        <ns3:creationId val="793562071"/>
+        <ns3:creationId val="1615964104"/>
       </p:ext>
     </p:extLst>
   </p:cSld>
@@ -15996,7 +17158,7 @@
           <p:cNvPr id="13" name="EAGLE_0">
             <a:extLst>
               <a:ext uri="{FF2B5EF4-FFF2-40B4-BE49-F238E27FC236}">
-                <ns2:creationId id="{52307C25-BE68-4A55-B4D4-26873CFB23BE}"/>
+                <ns2:creationId id="{37F9B17B-9BF9-45B3-9E8E-DE0159B34F0D}"/>
               </a:ext>
             </a:extLst>
           </p:cNvPr>
@@ -16049,7 +17211,7 @@
           <p:cNvPr id="14" name="EAGLE_1">
             <a:extLst>
               <a:ext uri="{FF2B5EF4-FFF2-40B4-BE49-F238E27FC236}">
-                <ns2:creationId id="{7A4DBCEC-5339-47FF-A8C7-D67F9A0BE593}"/>
+                <ns2:creationId id="{BEC07F08-B68A-43FE-891D-820F505B9D6F}"/>
               </a:ext>
             </a:extLst>
           </p:cNvPr>
@@ -16657,7 +17819,7 @@
           <p:cNvPr id="6" name="">
             <a:extLst>
               <a:ext uri="{FF2B5EF4-FFF2-40B4-BE49-F238E27FC236}">
-                <ns2:creationId id="{DC0E36C7-CD3F-485F-9EF6-89E0FC3D092E}"/>
+                <ns2:creationId id="{CEAB2866-7069-40A6-881C-61878C6D3690}"/>
               </a:ext>
             </a:extLst>
           </p:cNvPr>
@@ -16714,7 +17876,7 @@
           <p:cNvPr id="7" name="">
             <a:extLst>
               <a:ext uri="{FF2B5EF4-FFF2-40B4-BE49-F238E27FC236}">
-                <ns2:creationId id="{297D0E50-CD62-4170-B643-5752B91C79FC}"/>
+                <ns2:creationId id="{B5AA9FFB-575C-4E70-8C66-7395FD74E226}"/>
               </a:ext>
             </a:extLst>
           </p:cNvPr>
@@ -16806,7 +17968,7 @@
                 <a:cs typeface="Source Han Serif TW"/>
               </a:defRPr>
             </a:pPr>
-            <a:fld id="{BC40875A-8BCA-4F82-BBC1-89566185C323}" type="slidenum">
+            <a:fld id="{00043A06-76BF-438F-9D7E-EE234BB36223}" type="slidenum">
               <a:rPr sz="1650" b="0">
                 <a:solidFill>
                   <a:srgbClr val="CF8792"/>
@@ -16823,7 +17985,7 @@
     </p:spTree>
     <p:extLst>
       <p:ext uri="{BB962C8B-B14F-4D97-AF65-F5344CB8AC3E}">
-        <ns3:creationId val="638170892"/>
+        <ns3:creationId val="2054517980"/>
       </p:ext>
     </p:extLst>
   </p:cSld>
@@ -16831,7 +17993,7 @@
 </file>
 
 <file path=ppt/slides/slide9.xml><?xml version="1.0" encoding="utf-8"?>
-<p:sld xmlns:a="http://schemas.openxmlformats.org/drawingml/2006/main" xmlns:ns2="http://schemas.microsoft.com/office/drawing/2014/main" xmlns:ns3="http://schemas.openxmlformats.org/drawingml/2006/chart" xmlns:ns5="http://schemas.microsoft.com/office/powerpoint/2010/main" xmlns:p="http://schemas.openxmlformats.org/presentationml/2006/main" xmlns:r="http://schemas.openxmlformats.org/officeDocument/2006/relationships" showMasterSp="1">
+<p:sld xmlns:a="http://schemas.openxmlformats.org/drawingml/2006/main" xmlns:ns2="http://schemas.microsoft.com/office/drawing/2014/main" xmlns:ns3="http://schemas.microsoft.com/office/powerpoint/2010/main" xmlns:p="http://schemas.openxmlformats.org/presentationml/2006/main" showMasterSp="1">
   <p:cSld>
     <p:spTree>
       <p:nvGrpSpPr>
@@ -16847,7 +18009,7 @@
           <p:cNvPr id="13" name="EAGLE_0">
             <a:extLst>
               <a:ext uri="{FF2B5EF4-FFF2-40B4-BE49-F238E27FC236}">
-                <ns2:creationId id="{BBD4F1B4-1EF2-4658-88D5-C25CB2B59D9D}"/>
+                <ns2:creationId id="{A7FDE948-8CE2-452E-83D0-ACB79349BA0E}"/>
               </a:ext>
             </a:extLst>
           </p:cNvPr>
@@ -16871,7 +18033,7 @@
           <a:lstStyle/>
           <a:p>
             <a:pPr algn="ctr">
-              <a:defRPr sz="3668" b="1">
+              <a:defRPr sz="3827" b="1">
                 <a:solidFill>
                   <a:srgbClr val="47171C"/>
                 </a:solidFill>
@@ -16882,7 +18044,7 @@
               <a:buNone/>
             </a:pPr>
             <a:r>
-              <a:rPr sz="3668" b="1">
+              <a:rPr sz="3827" b="1">
                 <a:solidFill>
                   <a:srgbClr val="47171C"/>
                 </a:solidFill>
@@ -16890,7 +18052,7 @@
                 <a:ea typeface="Source Han Serif TW"/>
                 <a:cs typeface="Source Han Serif TW"/>
               </a:rPr>
-              <a:t>100 FFE：10×10 明顯優於 5×20，但只有單次觀察</a:t>
+              <a:t>0927 10×20：semantic tie-break 的實際變更</a:t>
             </a:r>
           </a:p>
         </p:txBody>
@@ -16900,7 +18062,7 @@
           <p:cNvPr id="14" name="EAGLE_1">
             <a:extLst>
               <a:ext uri="{FF2B5EF4-FFF2-40B4-BE49-F238E27FC236}">
-                <ns2:creationId id="{45CBFB38-9EC2-4840-B4CE-D27045CE0849}"/>
+                <ns2:creationId id="{172F5681-47E4-43B5-9EFD-60B6D34C0DBD}"/>
               </a:ext>
             </a:extLst>
           </p:cNvPr>
@@ -16943,24 +18105,593 @@
                 <a:ea typeface="Source Han Serif TW"/>
                 <a:cs typeface="Source Han Serif TW"/>
               </a:rPr>
-              <a:t>兩組使用 semantic tie-break、相同 9 個 semantic probes 與 600 場 final test</a:t>
+              <a:t>相對 0923 legacy self-play；保留主要搜尋條件，只更改 evaluation selection protocol</a:t>
             </a:r>
           </a:p>
         </p:txBody>
       </p:sp>
       <p:graphicFrame>
         <p:nvGraphicFramePr>
-          <p:cNvPr id="12" name="Chart"/>
+          <p:cNvPr id="12" name=""/>
           <p:cNvGraphicFramePr/>
           <p:nvPr/>
         </p:nvGraphicFramePr>
         <p:xfrm>
-          <a:off x="1654066" y="2436316"/>
-          <a:ext cx="12167038" cy="4019848"/>
+          <a:off x="1428750" y="2436316"/>
+          <a:ext cx="13068300" cy="4019848"/>
         </p:xfrm>
         <a:graphic>
-          <a:graphicData uri="http://schemas.openxmlformats.org/drawingml/2006/chart">
-            <ns3:chart r:id="R9dabe66619de4eca"/>
+          <a:graphicData uri="http://schemas.openxmlformats.org/drawingml/2006/table">
+            <a:tbl>
+              <a:tblPr firstRow="1" bandRow="0">
+                <a:tableStyleId>{8497E131-5584-4FF0-9A17-202609170001}</a:tableStyleId>
+              </a:tblPr>
+              <a:tblGrid>
+                <a:gridCol w="3379733"/>
+                <a:gridCol w="4731626"/>
+                <a:gridCol w="4956941"/>
+              </a:tblGrid>
+              <a:tr h="574264">
+                <a:tc>
+                  <a:txBody>
+                    <a:bodyPr>
+                      <a:noAutofit/>
+                    </a:bodyPr>
+                    <a:lstStyle/>
+                    <a:p>
+                      <a:r>
+                        <a:rPr sz="1552" b="1">
+                          <a:solidFill>
+                            <a:srgbClr val="423C3B"/>
+                          </a:solidFill>
+                          <a:latin typeface="Source Han Serif TW"/>
+                          <a:ea typeface="Source Han Serif TW"/>
+                          <a:cs typeface="Source Han Serif TW"/>
+                        </a:rPr>
+                        <a:t>項目</a:t>
+                      </a:r>
+                    </a:p>
+                  </a:txBody>
+                  <a:tcPr marL="76200" marR="76200" marT="28575" marB="28575">
+                    <a:solidFill>
+                      <a:srgbClr val="DEB4BA"/>
+                    </a:solidFill>
+                  </a:tcPr>
+                </a:tc>
+                <a:tc>
+                  <a:txBody>
+                    <a:bodyPr>
+                      <a:noAutofit/>
+                    </a:bodyPr>
+                    <a:lstStyle/>
+                    <a:p>
+                      <a:r>
+                        <a:rPr sz="1552" b="1">
+                          <a:solidFill>
+                            <a:srgbClr val="423C3B"/>
+                          </a:solidFill>
+                          <a:latin typeface="Source Han Serif TW"/>
+                          <a:ea typeface="Source Han Serif TW"/>
+                          <a:cs typeface="Source Han Serif TW"/>
+                        </a:rPr>
+                        <a:t>0923 legacy self-play</a:t>
+                      </a:r>
+                    </a:p>
+                  </a:txBody>
+                  <a:tcPr marL="76200" marR="76200" marT="28575" marB="28575">
+                    <a:solidFill>
+                      <a:srgbClr val="DEB4BA"/>
+                    </a:solidFill>
+                  </a:tcPr>
+                </a:tc>
+                <a:tc>
+                  <a:txBody>
+                    <a:bodyPr>
+                      <a:noAutofit/>
+                    </a:bodyPr>
+                    <a:lstStyle/>
+                    <a:p>
+                      <a:r>
+                        <a:rPr sz="1552" b="1">
+                          <a:solidFill>
+                            <a:srgbClr val="423C3B"/>
+                          </a:solidFill>
+                          <a:latin typeface="Source Han Serif TW"/>
+                          <a:ea typeface="Source Han Serif TW"/>
+                          <a:cs typeface="Source Han Serif TW"/>
+                        </a:rPr>
+                        <a:t>0927 run</a:t>
+                      </a:r>
+                    </a:p>
+                  </a:txBody>
+                  <a:tcPr marL="76200" marR="76200" marT="28575" marB="28575">
+                    <a:solidFill>
+                      <a:srgbClr val="DEB4BA"/>
+                    </a:solidFill>
+                  </a:tcPr>
+                </a:tc>
+              </a:tr>
+              <a:tr h="574264">
+                <a:tc>
+                  <a:txBody>
+                    <a:bodyPr>
+                      <a:noAutofit/>
+                    </a:bodyPr>
+                    <a:lstStyle/>
+                    <a:p>
+                      <a:r>
+                        <a:rPr sz="1552" b="0">
+                          <a:solidFill>
+                            <a:srgbClr val="423C3B"/>
+                          </a:solidFill>
+                          <a:latin typeface="Source Han Serif TW"/>
+                          <a:ea typeface="Source Han Serif TW"/>
+                          <a:cs typeface="Source Han Serif TW"/>
+                        </a:rPr>
+                        <a:t>保留條件</a:t>
+                      </a:r>
+                    </a:p>
+                  </a:txBody>
+                  <a:tcPr marL="76200" marR="76200" marT="28575" marB="28575">
+                    <a:solidFill>
+                      <a:srgbClr val="FCF8F5"/>
+                    </a:solidFill>
+                  </a:tcPr>
+                </a:tc>
+                <a:tc>
+                  <a:txBody>
+                    <a:bodyPr>
+                      <a:noAutofit/>
+                    </a:bodyPr>
+                    <a:lstStyle/>
+                    <a:p>
+                      <a:r>
+                        <a:rPr sz="1552" b="0">
+                          <a:solidFill>
+                            <a:srgbClr val="423C3B"/>
+                          </a:solidFill>
+                          <a:latin typeface="Source Han Serif TW"/>
+                          <a:ea typeface="Source Han Serif TW"/>
+                          <a:cs typeface="Source Han Serif TW"/>
+                        </a:rPr>
+                        <a:t>20×10、模型、refresh 間隔、初始化、inherited genotype、static reflection、seed、地圖</a:t>
+                      </a:r>
+                    </a:p>
+                  </a:txBody>
+                  <a:tcPr marL="76200" marR="76200" marT="28575" marB="28575">
+                    <a:solidFill>
+                      <a:srgbClr val="FCF8F5"/>
+                    </a:solidFill>
+                  </a:tcPr>
+                </a:tc>
+                <a:tc>
+                  <a:txBody>
+                    <a:bodyPr>
+                      <a:noAutofit/>
+                    </a:bodyPr>
+                    <a:lstStyle/>
+                    <a:p>
+                      <a:r>
+                        <a:rPr sz="1552" b="0">
+                          <a:solidFill>
+                            <a:srgbClr val="423C3B"/>
+                          </a:solidFill>
+                          <a:latin typeface="Source Han Serif TW"/>
+                          <a:ea typeface="Source Han Serif TW"/>
+                          <a:cs typeface="Source Han Serif TW"/>
+                        </a:rPr>
+                        <a:t>同左</a:t>
+                      </a:r>
+                    </a:p>
+                  </a:txBody>
+                  <a:tcPr marL="76200" marR="76200" marT="28575" marB="28575">
+                    <a:solidFill>
+                      <a:srgbClr val="FCF8F5"/>
+                    </a:solidFill>
+                  </a:tcPr>
+                </a:tc>
+              </a:tr>
+              <a:tr h="574264">
+                <a:tc>
+                  <a:txBody>
+                    <a:bodyPr>
+                      <a:noAutofit/>
+                    </a:bodyPr>
+                    <a:lstStyle/>
+                    <a:p>
+                      <a:r>
+                        <a:rPr sz="1552" b="0">
+                          <a:solidFill>
+                            <a:srgbClr val="423C3B"/>
+                          </a:solidFill>
+                          <a:latin typeface="Source Han Serif TW"/>
+                          <a:ea typeface="Source Han Serif TW"/>
+                          <a:cs typeface="Source Han Serif TW"/>
+                        </a:rPr>
+                        <a:t>Selection algorithm</a:t>
+                      </a:r>
+                    </a:p>
+                  </a:txBody>
+                  <a:tcPr marL="76200" marR="76200" marT="28575" marB="28575">
+                    <a:solidFill>
+                      <a:srgbClr val="FCF8F5"/>
+                    </a:solidFill>
+                  </a:tcPr>
+                </a:tc>
+                <a:tc>
+                  <a:txBody>
+                    <a:bodyPr>
+                      <a:noAutofit/>
+                    </a:bodyPr>
+                    <a:lstStyle/>
+                    <a:p>
+                      <a:r>
+                        <a:rPr sz="1552" b="0">
+                          <a:solidFill>
+                            <a:srgbClr val="423C3B"/>
+                          </a:solidFill>
+                          <a:latin typeface="Source Han Serif TW"/>
+                          <a:ea typeface="Source Han Serif TW"/>
+                          <a:cs typeface="Source Han Serif TW"/>
+                        </a:rPr>
+                        <a:t>lexicase</a:t>
+                      </a:r>
+                    </a:p>
+                  </a:txBody>
+                  <a:tcPr marL="76200" marR="76200" marT="28575" marB="28575">
+                    <a:solidFill>
+                      <a:srgbClr val="FCF8F5"/>
+                    </a:solidFill>
+                  </a:tcPr>
+                </a:tc>
+                <a:tc>
+                  <a:txBody>
+                    <a:bodyPr>
+                      <a:noAutofit/>
+                    </a:bodyPr>
+                    <a:lstStyle/>
+                    <a:p>
+                      <a:r>
+                        <a:rPr sz="1552" b="0">
+                          <a:solidFill>
+                            <a:srgbClr val="423C3B"/>
+                          </a:solidFill>
+                          <a:latin typeface="Source Han Serif TW"/>
+                          <a:ea typeface="Source Han Serif TW"/>
+                          <a:cs typeface="Source Han Serif TW"/>
+                        </a:rPr>
+                        <a:t>game_performance_semantic_tiebreak</a:t>
+                      </a:r>
+                    </a:p>
+                  </a:txBody>
+                  <a:tcPr marL="76200" marR="76200" marT="28575" marB="28575">
+                    <a:solidFill>
+                      <a:srgbClr val="FCF8F5"/>
+                    </a:solidFill>
+                  </a:tcPr>
+                </a:tc>
+              </a:tr>
+              <a:tr h="574264">
+                <a:tc>
+                  <a:txBody>
+                    <a:bodyPr>
+                      <a:noAutofit/>
+                    </a:bodyPr>
+                    <a:lstStyle/>
+                    <a:p>
+                      <a:r>
+                        <a:rPr sz="1552" b="0">
+                          <a:solidFill>
+                            <a:srgbClr val="423C3B"/>
+                          </a:solidFill>
+                          <a:latin typeface="Source Han Serif TW"/>
+                          <a:ea typeface="Source Han Serif TW"/>
+                          <a:cs typeface="Source Han Serif TW"/>
+                        </a:rPr>
+                        <a:t>唯一數值目標</a:t>
+                      </a:r>
+                    </a:p>
+                  </a:txBody>
+                  <a:tcPr marL="76200" marR="76200" marT="28575" marB="28575">
+                    <a:solidFill>
+                      <a:srgbClr val="FCF8F5"/>
+                    </a:solidFill>
+                  </a:tcPr>
+                </a:tc>
+                <a:tc>
+                  <a:txBody>
+                    <a:bodyPr>
+                      <a:noAutofit/>
+                    </a:bodyPr>
+                    <a:lstStyle/>
+                    <a:p>
+                      <a:r>
+                        <a:rPr sz="1552" b="0">
+                          <a:solidFill>
+                            <a:srgbClr val="423C3B"/>
+                          </a:solidFill>
+                          <a:latin typeface="Source Han Serif TW"/>
+                          <a:ea typeface="Source Han Serif TW"/>
+                          <a:cs typeface="Source Han Serif TW"/>
+                        </a:rPr>
+                        <a:t>10 個 opponent_cases</a:t>
+                      </a:r>
+                    </a:p>
+                  </a:txBody>
+                  <a:tcPr marL="76200" marR="76200" marT="28575" marB="28575">
+                    <a:solidFill>
+                      <a:srgbClr val="FCF8F5"/>
+                    </a:solidFill>
+                  </a:tcPr>
+                </a:tc>
+                <a:tc>
+                  <a:txBody>
+                    <a:bodyPr>
+                      <a:noAutofit/>
+                    </a:bodyPr>
+                    <a:lstStyle/>
+                    <a:p>
+                      <a:r>
+                        <a:rPr sz="1552" b="0">
+                          <a:solidFill>
+                            <a:srgbClr val="423C3B"/>
+                          </a:solidFill>
+                          <a:latin typeface="Source Han Serif TW"/>
+                          <a:ea typeface="Source Han Serif TW"/>
+                          <a:cs typeface="Source Han Serif TW"/>
+                        </a:rPr>
+                        <a:t>game_performance scalar</a:t>
+                      </a:r>
+                    </a:p>
+                  </a:txBody>
+                  <a:tcPr marL="76200" marR="76200" marT="28575" marB="28575">
+                    <a:solidFill>
+                      <a:srgbClr val="FCF8F5"/>
+                    </a:solidFill>
+                  </a:tcPr>
+                </a:tc>
+              </a:tr>
+              <a:tr h="574264">
+                <a:tc>
+                  <a:txBody>
+                    <a:bodyPr>
+                      <a:noAutofit/>
+                    </a:bodyPr>
+                    <a:lstStyle/>
+                    <a:p>
+                      <a:r>
+                        <a:rPr sz="1552" b="0">
+                          <a:solidFill>
+                            <a:srgbClr val="423C3B"/>
+                          </a:solidFill>
+                          <a:latin typeface="Source Han Serif TW"/>
+                          <a:ea typeface="Source Han Serif TW"/>
+                          <a:cs typeface="Source Han Serif TW"/>
+                        </a:rPr>
+                        <a:t>語意資訊</a:t>
+                      </a:r>
+                    </a:p>
+                  </a:txBody>
+                  <a:tcPr marL="76200" marR="76200" marT="28575" marB="28575">
+                    <a:solidFill>
+                      <a:srgbClr val="FCF8F5"/>
+                    </a:solidFill>
+                  </a:tcPr>
+                </a:tc>
+                <a:tc>
+                  <a:txBody>
+                    <a:bodyPr>
+                      <a:noAutofit/>
+                    </a:bodyPr>
+                    <a:lstStyle/>
+                    <a:p>
+                      <a:r>
+                        <a:rPr sz="1552" b="0">
+                          <a:solidFill>
+                            <a:srgbClr val="423C3B"/>
+                          </a:solidFill>
+                          <a:latin typeface="Source Han Serif TW"/>
+                          <a:ea typeface="Source Han Serif TW"/>
+                          <a:cs typeface="Source Han Serif TW"/>
+                        </a:rPr>
+                        <a:t>無 probes</a:t>
+                      </a:r>
+                    </a:p>
+                  </a:txBody>
+                  <a:tcPr marL="76200" marR="76200" marT="28575" marB="28575">
+                    <a:solidFill>
+                      <a:srgbClr val="FCF8F5"/>
+                    </a:solidFill>
+                  </a:tcPr>
+                </a:tc>
+                <a:tc>
+                  <a:txBody>
+                    <a:bodyPr>
+                      <a:noAutofit/>
+                    </a:bodyPr>
+                    <a:lstStyle/>
+                    <a:p>
+                      <a:r>
+                        <a:rPr sz="1552" b="0">
+                          <a:solidFill>
+                            <a:srgbClr val="423C3B"/>
+                          </a:solidFill>
+                          <a:latin typeface="Source Han Serif TW"/>
+                          <a:ea typeface="Source Han Serif TW"/>
+                          <a:cs typeface="Source Han Serif TW"/>
+                        </a:rPr>
+                        <a:t>3 張地圖 × early/mid/late，共 9 個 states</a:t>
+                      </a:r>
+                    </a:p>
+                  </a:txBody>
+                  <a:tcPr marL="76200" marR="76200" marT="28575" marB="28575">
+                    <a:solidFill>
+                      <a:srgbClr val="FCF8F5"/>
+                    </a:solidFill>
+                  </a:tcPr>
+                </a:tc>
+              </a:tr>
+              <a:tr h="574264">
+                <a:tc>
+                  <a:txBody>
+                    <a:bodyPr>
+                      <a:noAutofit/>
+                    </a:bodyPr>
+                    <a:lstStyle/>
+                    <a:p>
+                      <a:r>
+                        <a:rPr sz="1552" b="0">
+                          <a:solidFill>
+                            <a:srgbClr val="423C3B"/>
+                          </a:solidFill>
+                          <a:latin typeface="Source Han Serif TW"/>
+                          <a:ea typeface="Source Han Serif TW"/>
+                          <a:cs typeface="Source Han Serif TW"/>
+                        </a:rPr>
+                        <a:t>Tie handling</a:t>
+                      </a:r>
+                    </a:p>
+                  </a:txBody>
+                  <a:tcPr marL="76200" marR="76200" marT="28575" marB="28575">
+                    <a:solidFill>
+                      <a:srgbClr val="FCF8F5"/>
+                    </a:solidFill>
+                  </a:tcPr>
+                </a:tc>
+                <a:tc>
+                  <a:txBody>
+                    <a:bodyPr>
+                      <a:noAutofit/>
+                    </a:bodyPr>
+                    <a:lstStyle/>
+                    <a:p>
+                      <a:r>
+                        <a:rPr sz="1552" b="0">
+                          <a:solidFill>
+                            <a:srgbClr val="423C3B"/>
+                          </a:solidFill>
+                          <a:latin typeface="Source Han Serif TW"/>
+                          <a:ea typeface="Source Han Serif TW"/>
+                          <a:cs typeface="Source Han Serif TW"/>
+                        </a:rPr>
+                        <a:t>無 semantic tie-break</a:t>
+                      </a:r>
+                    </a:p>
+                  </a:txBody>
+                  <a:tcPr marL="76200" marR="76200" marT="28575" marB="28575">
+                    <a:solidFill>
+                      <a:srgbClr val="FCF8F5"/>
+                    </a:solidFill>
+                  </a:tcPr>
+                </a:tc>
+                <a:tc>
+                  <a:txBody>
+                    <a:bodyPr>
+                      <a:noAutofit/>
+                    </a:bodyPr>
+                    <a:lstStyle/>
+                    <a:p>
+                      <a:r>
+                        <a:rPr sz="1552" b="0">
+                          <a:solidFill>
+                            <a:srgbClr val="423C3B"/>
+                          </a:solidFill>
+                          <a:latin typeface="Source Han Serif TW"/>
+                          <a:ea typeface="Source Han Serif TW"/>
+                          <a:cs typeface="Source Han Serif TW"/>
+                        </a:rPr>
+                        <a:t>fitness 差距 ≤1.0 的 inclusive tier 內依 semantic signature 決勝</a:t>
+                      </a:r>
+                    </a:p>
+                  </a:txBody>
+                  <a:tcPr marL="76200" marR="76200" marT="28575" marB="28575">
+                    <a:solidFill>
+                      <a:srgbClr val="FCF8F5"/>
+                    </a:solidFill>
+                  </a:tcPr>
+                </a:tc>
+              </a:tr>
+              <a:tr h="574264">
+                <a:tc>
+                  <a:txBody>
+                    <a:bodyPr>
+                      <a:noAutofit/>
+                    </a:bodyPr>
+                    <a:lstStyle/>
+                    <a:p>
+                      <a:r>
+                        <a:rPr sz="1552" b="0">
+                          <a:solidFill>
+                            <a:srgbClr val="423C3B"/>
+                          </a:solidFill>
+                          <a:latin typeface="Source Han Serif TW"/>
+                          <a:ea typeface="Source Han Serif TW"/>
+                          <a:cs typeface="Source Han Serif TW"/>
+                        </a:rPr>
+                        <a:t>Parent evaluation mode</a:t>
+                      </a:r>
+                    </a:p>
+                  </a:txBody>
+                  <a:tcPr marL="76200" marR="76200" marT="28575" marB="28575">
+                    <a:solidFill>
+                      <a:srgbClr val="FCF8F5"/>
+                    </a:solidFill>
+                  </a:tcPr>
+                </a:tc>
+                <a:tc>
+                  <a:txBody>
+                    <a:bodyPr>
+                      <a:noAutofit/>
+                    </a:bodyPr>
+                    <a:lstStyle/>
+                    <a:p>
+                      <a:r>
+                        <a:rPr sz="1552" b="0">
+                          <a:solidFill>
+                            <a:srgbClr val="423C3B"/>
+                          </a:solidFill>
+                          <a:latin typeface="Source Han Serif TW"/>
+                          <a:ea typeface="Source Han Serif TW"/>
+                          <a:cs typeface="Source Han Serif TW"/>
+                        </a:rPr>
+                        <a:t>歷史 run 設定</a:t>
+                      </a:r>
+                    </a:p>
+                  </a:txBody>
+                  <a:tcPr marL="76200" marR="76200" marT="28575" marB="28575">
+                    <a:solidFill>
+                      <a:srgbClr val="FCF8F5"/>
+                    </a:solidFill>
+                  </a:tcPr>
+                </a:tc>
+                <a:tc>
+                  <a:txBody>
+                    <a:bodyPr>
+                      <a:noAutofit/>
+                    </a:bodyPr>
+                    <a:lstStyle/>
+                    <a:p>
+                      <a:r>
+                        <a:rPr sz="1552" b="0">
+                          <a:solidFill>
+                            <a:srgbClr val="423C3B"/>
+                          </a:solidFill>
+                          <a:latin typeface="Source Han Serif TW"/>
+                          <a:ea typeface="Source Han Serif TW"/>
+                          <a:cs typeface="Source Han Serif TW"/>
+                        </a:rPr>
+                        <a:t>resolved config 記錄 reuse_cached</a:t>
+                      </a:r>
+                    </a:p>
+                  </a:txBody>
+                  <a:tcPr marL="76200" marR="76200" marT="28575" marB="28575">
+                    <a:solidFill>
+                      <a:srgbClr val="FCF8F5"/>
+                    </a:solidFill>
+                  </a:tcPr>
+                </a:tc>
+              </a:tr>
+            </a:tbl>
           </a:graphicData>
         </a:graphic>
       </p:graphicFrame>
@@ -16969,7 +18700,7 @@
           <p:cNvPr id="6" name="">
             <a:extLst>
               <a:ext uri="{FF2B5EF4-FFF2-40B4-BE49-F238E27FC236}">
-                <ns2:creationId id="{C65F7826-47E0-43C8-9F17-D6E2E3D99452}"/>
+                <ns2:creationId id="{EC64631D-AF32-4F9B-B8C1-C0B299098B66}"/>
               </a:ext>
             </a:extLst>
           </p:cNvPr>
@@ -16980,8 +18711,8 @@
         </p:nvSpPr>
         <p:spPr>
           <a:xfrm>
-            <a:off x="1451282" y="6621363"/>
-            <a:ext cx="12899313" cy="462558"/>
+            <a:off x="1451282" y="6676430"/>
+            <a:ext cx="12820453" cy="495598"/>
           </a:xfrm>
           <a:prstGeom prst="rect">
             <a:avLst/>
@@ -16998,7 +18729,7 @@
           <a:lstStyle/>
           <a:p>
             <a:pPr>
-              <a:defRPr sz="1811" b="0">
+              <a:defRPr sz="1639" b="0">
                 <a:solidFill>
                   <a:srgbClr val="423C3B"/>
                 </a:solidFill>
@@ -17008,7 +18739,7 @@
               </a:defRPr>
             </a:pPr>
             <a:r>
-              <a:rPr sz="1811" b="0">
+              <a:rPr sz="1639" b="0">
                 <a:solidFill>
                   <a:srgbClr val="423C3B"/>
                 </a:solidFill>
@@ -17016,7 +18747,7 @@
                 <a:ea typeface="Source Han Serif TW"/>
                 <a:cs typeface="Source Han Serif TW"/>
               </a:rPr>
-              <a:t>10×10：42.83% 勝率；5×20：0% 勝率。5×20 搜尋期 180 場全和，正 GP 來自資源／兵力 shaping。</a:t>
+              <a:t>0927 best search Game Performance = 1.263534；該 best candidate 的 180 場 self-play 全為和局，正 fitness 來自 shaping，而非勝局。</a:t>
             </a:r>
           </a:p>
         </p:txBody>
@@ -17026,7 +18757,7 @@
           <p:cNvPr id="7" name="">
             <a:extLst>
               <a:ext uri="{FF2B5EF4-FFF2-40B4-BE49-F238E27FC236}">
-                <ns2:creationId id="{23B062EA-8FF5-4B9D-A630-6CF736E2F1D1}"/>
+                <ns2:creationId id="{B58DD732-9EBA-432C-A6D7-3CCD83A9D7EA}"/>
               </a:ext>
             </a:extLst>
           </p:cNvPr>
@@ -17037,7 +18768,7 @@
         </p:nvSpPr>
         <p:spPr>
           <a:xfrm>
-            <a:off x="1428750" y="7337227"/>
+            <a:off x="1428750" y="7249120"/>
             <a:ext cx="12955642" cy="572691"/>
           </a:xfrm>
           <a:prstGeom prst="rect">
@@ -17073,7 +18804,7 @@
                 <a:ea typeface="Source Han Serif TW"/>
                 <a:cs typeface="Source Han Serif TW"/>
               </a:rPr>
-              <a:t>同 FFE 的結果差距很大，refresh phenotype 漂移阻止強因果歸因</a:t>
+              <a:t>semantic signature 是平手規則；selection objective 只有 game_performance</a:t>
             </a:r>
           </a:p>
         </p:txBody>
@@ -17118,7 +18849,7 @@
                 <a:cs typeface="Source Han Serif TW"/>
               </a:defRPr>
             </a:pPr>
-            <a:fld id="{9CB91AE4-501E-4F39-BAAA-8CC2214D6A53}" type="slidenum">
+            <a:fld id="{BF108302-955E-4258-A196-E053534246EB}" type="slidenum">
               <a:rPr sz="1650" b="0">
                 <a:solidFill>
                   <a:srgbClr val="CF8792"/>
@@ -17135,7 +18866,7 @@
     </p:spTree>
     <p:extLst>
       <p:ext uri="{BB962C8B-B14F-4D97-AF65-F5344CB8AC3E}">
-        <ns5:creationId val="1127269012"/>
+        <ns3:creationId val="1532159618"/>
       </p:ext>
     </p:extLst>
   </p:cSld>

</xml_diff>